<commit_message>
Localize team SDD presentation copy
</commit_message>
<xml_diff>
--- a/outputs/team-sdd-principle-mvp-plan.pptx
+++ b/outputs/team-sdd-principle-mvp-plan.pptx
@@ -2,20 +2,20 @@
 <file path=ppt/presentation.xml><?xml version="1.0" encoding="utf-8"?>
 <p:presentation xmlns:p="http://schemas.openxmlformats.org/presentationml/2006/main">
   <p:sldMasterIdLst>
-    <p:sldMasterId xmlns:r="http://schemas.openxmlformats.org/officeDocument/2006/relationships" id="2147483648" r:id="R63e0cd2f03ba494c"/>
+    <p:sldMasterId xmlns:r="http://schemas.openxmlformats.org/officeDocument/2006/relationships" id="2147483648" r:id="R99ea8449c60e4fa0"/>
   </p:sldMasterIdLst>
   <p:notesMasterIdLst>
-    <p:notesMasterId xmlns:r="http://schemas.openxmlformats.org/officeDocument/2006/relationships" r:id="R3c7fffeef62f4303"/>
+    <p:notesMasterId xmlns:r="http://schemas.openxmlformats.org/officeDocument/2006/relationships" r:id="R195616fbcbcc4ec9"/>
   </p:notesMasterIdLst>
   <p:sldIdLst>
-    <p:sldId xmlns:r="http://schemas.openxmlformats.org/officeDocument/2006/relationships" id="256" r:id="R023a324ca1944659"/>
-    <p:sldId xmlns:r="http://schemas.openxmlformats.org/officeDocument/2006/relationships" id="257" r:id="R2eeb1be811934487"/>
-    <p:sldId xmlns:r="http://schemas.openxmlformats.org/officeDocument/2006/relationships" id="258" r:id="R59954d6031974d6d"/>
-    <p:sldId xmlns:r="http://schemas.openxmlformats.org/officeDocument/2006/relationships" id="259" r:id="R64a5614daee14dd4"/>
-    <p:sldId xmlns:r="http://schemas.openxmlformats.org/officeDocument/2006/relationships" id="260" r:id="Rb0302bdac2e9449c"/>
-    <p:sldId xmlns:r="http://schemas.openxmlformats.org/officeDocument/2006/relationships" id="261" r:id="R92ae849b8e80496a"/>
-    <p:sldId xmlns:r="http://schemas.openxmlformats.org/officeDocument/2006/relationships" id="262" r:id="Rc4dcc491043a4562"/>
-    <p:sldId xmlns:r="http://schemas.openxmlformats.org/officeDocument/2006/relationships" id="263" r:id="R3f19c0ad214245c7"/>
+    <p:sldId xmlns:r="http://schemas.openxmlformats.org/officeDocument/2006/relationships" id="256" r:id="R0e6e030085af4858"/>
+    <p:sldId xmlns:r="http://schemas.openxmlformats.org/officeDocument/2006/relationships" id="257" r:id="Re1fbb04603dc4bae"/>
+    <p:sldId xmlns:r="http://schemas.openxmlformats.org/officeDocument/2006/relationships" id="258" r:id="R6461d4f19d394d5d"/>
+    <p:sldId xmlns:r="http://schemas.openxmlformats.org/officeDocument/2006/relationships" id="259" r:id="R71ece9554ddc4e40"/>
+    <p:sldId xmlns:r="http://schemas.openxmlformats.org/officeDocument/2006/relationships" id="260" r:id="R98eafe18eb944c82"/>
+    <p:sldId xmlns:r="http://schemas.openxmlformats.org/officeDocument/2006/relationships" id="261" r:id="R83e6067d4bd74568"/>
+    <p:sldId xmlns:r="http://schemas.openxmlformats.org/officeDocument/2006/relationships" id="262" r:id="Rfdefca2339794799"/>
+    <p:sldId xmlns:r="http://schemas.openxmlformats.org/officeDocument/2006/relationships" id="263" r:id="R0783e4a1809b420a"/>
   </p:sldIdLst>
   <p:sldSz cx="12192000" cy="6858000"/>
   <p:notesSz cx="6858000" cy="9144000"/>
@@ -1070,7 +1070,7 @@
   </p:cSld>
   <p:clrMap bg1="lt1" tx1="dk1" bg2="lt2" tx2="dk2" accent1="accent1" accent2="accent2" accent3="accent3" accent4="accent4" accent5="accent5" accent6="accent6" hlink="hlink" folHlink="folHlink"/>
   <p:sldLayoutIdLst>
-    <p:sldLayoutId xmlns:r="http://schemas.openxmlformats.org/officeDocument/2006/relationships" id="2147483649" r:id="Rf27d8c91a63943ee"/>
+    <p:sldLayoutId xmlns:r="http://schemas.openxmlformats.org/officeDocument/2006/relationships" id="2147483649" r:id="R73a6538f2ab54689"/>
   </p:sldLayoutIdLst>
   <p:txStyles>
     <p:titleStyle>
@@ -1621,7 +1621,7 @@
           <p:cNvPr id="1" name="">
             <a:extLst xmlns:a="http://schemas.openxmlformats.org/drawingml/2006/main">
               <a:ext uri="{FF2B5EF4-FFF2-40B4-BE49-F238E27FC236}">
-                <a16:creationId xmlns:a16="http://schemas.microsoft.com/office/drawing/2014/main" id="{9AE5325F-3F19-4253-8333-A5281D246DF1}"/>
+                <a16:creationId xmlns:a16="http://schemas.microsoft.com/office/drawing/2014/main" id="{84A6E365-A5A5-4D3F-9639-D9A87836B90D}"/>
               </a:ext>
             </a:extLst>
           </p:cNvPr>
@@ -1633,7 +1633,7 @@
         <p:spPr>
           <a:xfrm xmlns:a="http://schemas.openxmlformats.org/drawingml/2006/main">
             <a:off x="609600" y="552450"/>
-            <a:ext cx="7524750" cy="781050"/>
+            <a:ext cx="8572500" cy="781050"/>
           </a:xfrm>
           <a:prstGeom xmlns:a="http://schemas.openxmlformats.org/drawingml/2006/main" prst="rect">
             <a:avLst/>
@@ -1661,7 +1661,7 @@
                   <a:srgbClr val="111827"/>
                 </a:solidFill>
               </a:rPr>
-              <a:t>SDD-процесс для команды</a:t>
+              <a:t>Процесс разработки от требований</a:t>
             </a:r>
           </a:p>
         </p:txBody>
@@ -1671,7 +1671,7 @@
           <p:cNvPr id="2" name="">
             <a:extLst xmlns:a="http://schemas.openxmlformats.org/drawingml/2006/main">
               <a:ext uri="{FF2B5EF4-FFF2-40B4-BE49-F238E27FC236}">
-                <a16:creationId xmlns:a16="http://schemas.microsoft.com/office/drawing/2014/main" id="{C8650833-F7A3-4EA6-9B10-2B702F486883}"/>
+                <a16:creationId xmlns:a16="http://schemas.microsoft.com/office/drawing/2014/main" id="{B2E888CB-53AC-42BE-8BD2-C5F14A9EC863}"/>
               </a:ext>
             </a:extLst>
           </p:cNvPr>
@@ -1711,7 +1711,7 @@
                   <a:srgbClr val="4B5563"/>
                 </a:solidFill>
               </a:rPr>
-              <a:t>Как связать анализ, разработку, тестирование и доказательства в один управляемый поток</a:t>
+              <a:t>Как связать анализ, разработку, тестирование и подтверждение результата в один понятный рабочий поток</a:t>
             </a:r>
           </a:p>
         </p:txBody>
@@ -1721,7 +1721,7 @@
           <p:cNvPr id="3" name="">
             <a:extLst xmlns:a="http://schemas.openxmlformats.org/drawingml/2006/main">
               <a:ext uri="{FF2B5EF4-FFF2-40B4-BE49-F238E27FC236}">
-                <a16:creationId xmlns:a16="http://schemas.microsoft.com/office/drawing/2014/main" id="{31A033E2-1797-4F09-B907-55E0271E10FA}"/>
+                <a16:creationId xmlns:a16="http://schemas.microsoft.com/office/drawing/2014/main" id="{63BD0920-1B14-460A-A26B-5A3749D68B5C}"/>
               </a:ext>
             </a:extLst>
           </p:cNvPr>
@@ -1754,7 +1754,7 @@
           <p:cNvPr id="4" name="">
             <a:extLst xmlns:a="http://schemas.openxmlformats.org/drawingml/2006/main">
               <a:ext uri="{FF2B5EF4-FFF2-40B4-BE49-F238E27FC236}">
-                <a16:creationId xmlns:a16="http://schemas.microsoft.com/office/drawing/2014/main" id="{31668999-C2C9-4362-BC39-EDF021B378F1}"/>
+                <a16:creationId xmlns:a16="http://schemas.microsoft.com/office/drawing/2014/main" id="{28C8EC99-D78E-45A7-8337-D3594A319175}"/>
               </a:ext>
             </a:extLst>
           </p:cNvPr>
@@ -1789,7 +1789,7 @@
           <p:cNvPr id="5" name="">
             <a:extLst xmlns:a="http://schemas.openxmlformats.org/drawingml/2006/main">
               <a:ext uri="{FF2B5EF4-FFF2-40B4-BE49-F238E27FC236}">
-                <a16:creationId xmlns:a16="http://schemas.microsoft.com/office/drawing/2014/main" id="{96CAA60A-56E2-47D2-8B1A-B89B5C11812A}"/>
+                <a16:creationId xmlns:a16="http://schemas.microsoft.com/office/drawing/2014/main" id="{6D3A42AB-2C6F-4296-BD14-AF1AE31F4F94}"/>
               </a:ext>
             </a:extLst>
           </p:cNvPr>
@@ -1829,7 +1829,7 @@
                   <a:srgbClr val="111827"/>
                 </a:solidFill>
               </a:rPr>
-              <a:t>Analysis</a:t>
+              <a:t>Анализ</a:t>
             </a:r>
           </a:p>
         </p:txBody>
@@ -1839,7 +1839,7 @@
           <p:cNvPr id="6" name="">
             <a:extLst xmlns:a="http://schemas.openxmlformats.org/drawingml/2006/main">
               <a:ext uri="{FF2B5EF4-FFF2-40B4-BE49-F238E27FC236}">
-                <a16:creationId xmlns:a16="http://schemas.microsoft.com/office/drawing/2014/main" id="{93AA8E29-3067-45D8-997C-8C06D7347273}"/>
+                <a16:creationId xmlns:a16="http://schemas.microsoft.com/office/drawing/2014/main" id="{E584D57F-5AD8-40C1-A1C7-9B4424F7858D}"/>
               </a:ext>
             </a:extLst>
           </p:cNvPr>
@@ -1872,7 +1872,7 @@
           <p:cNvPr id="7" name="">
             <a:extLst xmlns:a="http://schemas.openxmlformats.org/drawingml/2006/main">
               <a:ext uri="{FF2B5EF4-FFF2-40B4-BE49-F238E27FC236}">
-                <a16:creationId xmlns:a16="http://schemas.microsoft.com/office/drawing/2014/main" id="{126A7C81-6FAE-4715-8F65-83CB018D05DF}"/>
+                <a16:creationId xmlns:a16="http://schemas.microsoft.com/office/drawing/2014/main" id="{FA4EA232-55FF-4AAF-AE42-372619B2F5E1}"/>
               </a:ext>
             </a:extLst>
           </p:cNvPr>
@@ -1907,7 +1907,7 @@
           <p:cNvPr id="8" name="">
             <a:extLst xmlns:a="http://schemas.openxmlformats.org/drawingml/2006/main">
               <a:ext uri="{FF2B5EF4-FFF2-40B4-BE49-F238E27FC236}">
-                <a16:creationId xmlns:a16="http://schemas.microsoft.com/office/drawing/2014/main" id="{EEE5EFA6-1415-4BA5-A643-FF90389BD3A3}"/>
+                <a16:creationId xmlns:a16="http://schemas.microsoft.com/office/drawing/2014/main" id="{DCD60DA5-9AA8-41CB-80FC-2A833512969A}"/>
               </a:ext>
             </a:extLst>
           </p:cNvPr>
@@ -1947,7 +1947,7 @@
                   <a:srgbClr val="0F766E"/>
                 </a:solidFill>
               </a:rPr>
-              <a:t>Spec</a:t>
+              <a:t>Требования</a:t>
             </a:r>
           </a:p>
         </p:txBody>
@@ -1957,7 +1957,7 @@
           <p:cNvPr id="9" name="">
             <a:extLst xmlns:a="http://schemas.openxmlformats.org/drawingml/2006/main">
               <a:ext uri="{FF2B5EF4-FFF2-40B4-BE49-F238E27FC236}">
-                <a16:creationId xmlns:a16="http://schemas.microsoft.com/office/drawing/2014/main" id="{3E685968-0E33-4065-A562-97AFB29DA77A}"/>
+                <a16:creationId xmlns:a16="http://schemas.microsoft.com/office/drawing/2014/main" id="{C3FEFA1A-000D-46C9-B081-3826E1875B97}"/>
               </a:ext>
             </a:extLst>
           </p:cNvPr>
@@ -1990,7 +1990,7 @@
           <p:cNvPr id="10" name="">
             <a:extLst xmlns:a="http://schemas.openxmlformats.org/drawingml/2006/main">
               <a:ext uri="{FF2B5EF4-FFF2-40B4-BE49-F238E27FC236}">
-                <a16:creationId xmlns:a16="http://schemas.microsoft.com/office/drawing/2014/main" id="{EC4F4AA4-0031-4CFC-AF57-30B16913795C}"/>
+                <a16:creationId xmlns:a16="http://schemas.microsoft.com/office/drawing/2014/main" id="{9356D380-7332-4334-907F-9B0FC8BE74AB}"/>
               </a:ext>
             </a:extLst>
           </p:cNvPr>
@@ -2025,7 +2025,7 @@
           <p:cNvPr id="11" name="">
             <a:extLst xmlns:a="http://schemas.openxmlformats.org/drawingml/2006/main">
               <a:ext uri="{FF2B5EF4-FFF2-40B4-BE49-F238E27FC236}">
-                <a16:creationId xmlns:a16="http://schemas.microsoft.com/office/drawing/2014/main" id="{A0C2483C-679C-4821-A0F2-4EA88E328CC0}"/>
+                <a16:creationId xmlns:a16="http://schemas.microsoft.com/office/drawing/2014/main" id="{009BFF43-3F77-4B6D-86B1-69CF601C6334}"/>
               </a:ext>
             </a:extLst>
           </p:cNvPr>
@@ -2065,7 +2065,7 @@
                   <a:srgbClr val="111827"/>
                 </a:solidFill>
               </a:rPr>
-              <a:t>Dev</a:t>
+              <a:t>Разработка</a:t>
             </a:r>
           </a:p>
         </p:txBody>
@@ -2075,7 +2075,7 @@
           <p:cNvPr id="12" name="">
             <a:extLst xmlns:a="http://schemas.openxmlformats.org/drawingml/2006/main">
               <a:ext uri="{FF2B5EF4-FFF2-40B4-BE49-F238E27FC236}">
-                <a16:creationId xmlns:a16="http://schemas.microsoft.com/office/drawing/2014/main" id="{5F7D9711-0D6A-43F9-B33F-A619DA6C5C4D}"/>
+                <a16:creationId xmlns:a16="http://schemas.microsoft.com/office/drawing/2014/main" id="{0A46177C-7A00-47D1-BD82-D3D1C16004A5}"/>
               </a:ext>
             </a:extLst>
           </p:cNvPr>
@@ -2108,7 +2108,7 @@
           <p:cNvPr id="13" name="">
             <a:extLst xmlns:a="http://schemas.openxmlformats.org/drawingml/2006/main">
               <a:ext uri="{FF2B5EF4-FFF2-40B4-BE49-F238E27FC236}">
-                <a16:creationId xmlns:a16="http://schemas.microsoft.com/office/drawing/2014/main" id="{D81A65C1-CDB4-40F2-ADB1-5EE2211323BB}"/>
+                <a16:creationId xmlns:a16="http://schemas.microsoft.com/office/drawing/2014/main" id="{05D8087A-FD75-4012-A4A7-719A66FECFB2}"/>
               </a:ext>
             </a:extLst>
           </p:cNvPr>
@@ -2143,7 +2143,7 @@
           <p:cNvPr id="14" name="">
             <a:extLst xmlns:a="http://schemas.openxmlformats.org/drawingml/2006/main">
               <a:ext uri="{FF2B5EF4-FFF2-40B4-BE49-F238E27FC236}">
-                <a16:creationId xmlns:a16="http://schemas.microsoft.com/office/drawing/2014/main" id="{2D0DBD44-CD86-45EA-BD76-B3F27B662AFA}"/>
+                <a16:creationId xmlns:a16="http://schemas.microsoft.com/office/drawing/2014/main" id="{BD68ADF6-C164-4D93-A66F-20D42B28199C}"/>
               </a:ext>
             </a:extLst>
           </p:cNvPr>
@@ -2183,7 +2183,7 @@
                   <a:srgbClr val="111827"/>
                 </a:solidFill>
               </a:rPr>
-              <a:t>QA/AT</a:t>
+              <a:t>Тесты</a:t>
             </a:r>
           </a:p>
         </p:txBody>
@@ -2193,7 +2193,7 @@
           <p:cNvPr id="15" name="">
             <a:extLst xmlns:a="http://schemas.openxmlformats.org/drawingml/2006/main">
               <a:ext uri="{FF2B5EF4-FFF2-40B4-BE49-F238E27FC236}">
-                <a16:creationId xmlns:a16="http://schemas.microsoft.com/office/drawing/2014/main" id="{D0C7E1EE-BE45-4EA9-AE69-FE9A17D7CD6A}"/>
+                <a16:creationId xmlns:a16="http://schemas.microsoft.com/office/drawing/2014/main" id="{75B9CC41-F59B-4247-B7A5-BD16480D35B8}"/>
               </a:ext>
             </a:extLst>
           </p:cNvPr>
@@ -2226,7 +2226,7 @@
           <p:cNvPr id="16" name="">
             <a:extLst xmlns:a="http://schemas.openxmlformats.org/drawingml/2006/main">
               <a:ext uri="{FF2B5EF4-FFF2-40B4-BE49-F238E27FC236}">
-                <a16:creationId xmlns:a16="http://schemas.microsoft.com/office/drawing/2014/main" id="{E6BB904B-0AF2-4A30-86E0-E294B17A0F5B}"/>
+                <a16:creationId xmlns:a16="http://schemas.microsoft.com/office/drawing/2014/main" id="{EA759BC8-1589-432E-8C54-A885D22FF0B0}"/>
               </a:ext>
             </a:extLst>
           </p:cNvPr>
@@ -2261,7 +2261,7 @@
           <p:cNvPr id="17" name="">
             <a:extLst xmlns:a="http://schemas.openxmlformats.org/drawingml/2006/main">
               <a:ext uri="{FF2B5EF4-FFF2-40B4-BE49-F238E27FC236}">
-                <a16:creationId xmlns:a16="http://schemas.microsoft.com/office/drawing/2014/main" id="{EB02DB22-E0DD-4B39-AE18-ADB4AAD5E725}"/>
+                <a16:creationId xmlns:a16="http://schemas.microsoft.com/office/drawing/2014/main" id="{6144321F-52C8-4051-8034-29077FF3508A}"/>
               </a:ext>
             </a:extLst>
           </p:cNvPr>
@@ -2301,7 +2301,7 @@
                   <a:srgbClr val="111827"/>
                 </a:solidFill>
               </a:rPr>
-              <a:t>Evidence</a:t>
+              <a:t>Проверено</a:t>
             </a:r>
           </a:p>
         </p:txBody>
@@ -2311,7 +2311,7 @@
           <p:cNvPr id="18" name="">
             <a:extLst xmlns:a="http://schemas.openxmlformats.org/drawingml/2006/main">
               <a:ext uri="{FF2B5EF4-FFF2-40B4-BE49-F238E27FC236}">
-                <a16:creationId xmlns:a16="http://schemas.microsoft.com/office/drawing/2014/main" id="{5FC08C8E-752C-4468-9D85-0944082A8805}"/>
+                <a16:creationId xmlns:a16="http://schemas.microsoft.com/office/drawing/2014/main" id="{F13D5A12-44AD-420C-91AC-5AABED427026}"/>
               </a:ext>
             </a:extLst>
           </p:cNvPr>
@@ -2323,7 +2323,7 @@
         <p:spPr>
           <a:xfrm xmlns:a="http://schemas.openxmlformats.org/drawingml/2006/main">
             <a:off x="609600" y="5772150"/>
-            <a:ext cx="3619500" cy="400050"/>
+            <a:ext cx="4953000" cy="400050"/>
           </a:xfrm>
           <a:prstGeom xmlns:a="http://schemas.openxmlformats.org/drawingml/2006/main" prst="rect">
             <a:avLst/>
@@ -2351,7 +2351,7 @@
                   <a:srgbClr val="B45309"/>
                 </a:solidFill>
               </a:rPr>
-              <a:t>MVP за 1,5 месяца</a:t>
+              <a:t>Первый результат за 1,5 месяца</a:t>
             </a:r>
           </a:p>
         </p:txBody>
@@ -2361,7 +2361,7 @@
           <p:cNvPr id="19" name="">
             <a:extLst xmlns:a="http://schemas.openxmlformats.org/drawingml/2006/main">
               <a:ext uri="{FF2B5EF4-FFF2-40B4-BE49-F238E27FC236}">
-                <a16:creationId xmlns:a16="http://schemas.microsoft.com/office/drawing/2014/main" id="{8CD636C7-2B1C-417E-83CC-AF0E15B1F17B}"/>
+                <a16:creationId xmlns:a16="http://schemas.microsoft.com/office/drawing/2014/main" id="{4845B162-EB9E-460F-8169-02E835CA0B30}"/>
               </a:ext>
             </a:extLst>
           </p:cNvPr>
@@ -2411,7 +2411,7 @@
           <p:cNvPr id="20" name="">
             <a:extLst xmlns:a="http://schemas.openxmlformats.org/drawingml/2006/main">
               <a:ext uri="{FF2B5EF4-FFF2-40B4-BE49-F238E27FC236}">
-                <a16:creationId xmlns:a16="http://schemas.microsoft.com/office/drawing/2014/main" id="{E05D3996-460A-4548-B2C1-4C43C6784639}"/>
+                <a16:creationId xmlns:a16="http://schemas.microsoft.com/office/drawing/2014/main" id="{31B58A45-7393-4BF3-9CBD-4DFBAB75B7CA}"/>
               </a:ext>
             </a:extLst>
           </p:cNvPr>
@@ -2459,7 +2459,7 @@
     </p:spTree>
     <p:extLst>
       <p:ext uri="{BB962C8B-B14F-4D97-AF65-F5344CB8AC3E}">
-        <p14:creationId xmlns:p14="http://schemas.microsoft.com/office/powerpoint/2010/main" val="225830047"/>
+        <p14:creationId xmlns:p14="http://schemas.microsoft.com/office/powerpoint/2010/main" val="1637409603"/>
       </p:ext>
     </p:extLst>
   </p:cSld>
@@ -2490,7 +2490,7 @@
           <p:cNvPr id="1" name="">
             <a:extLst xmlns:a="http://schemas.openxmlformats.org/drawingml/2006/main">
               <a:ext uri="{FF2B5EF4-FFF2-40B4-BE49-F238E27FC236}">
-                <a16:creationId xmlns:a16="http://schemas.microsoft.com/office/drawing/2014/main" id="{59E22BE3-7EAD-4597-B1D0-C962F54BD577}"/>
+                <a16:creationId xmlns:a16="http://schemas.microsoft.com/office/drawing/2014/main" id="{A00AF9C6-4D69-440E-BD8A-3F4AF73B05A5}"/>
               </a:ext>
             </a:extLst>
           </p:cNvPr>
@@ -2540,7 +2540,7 @@
           <p:cNvPr id="2" name="">
             <a:extLst xmlns:a="http://schemas.openxmlformats.org/drawingml/2006/main">
               <a:ext uri="{FF2B5EF4-FFF2-40B4-BE49-F238E27FC236}">
-                <a16:creationId xmlns:a16="http://schemas.microsoft.com/office/drawing/2014/main" id="{3C599E51-9871-4B9A-89BA-3AE5BD247BBD}"/>
+                <a16:creationId xmlns:a16="http://schemas.microsoft.com/office/drawing/2014/main" id="{69786195-93CA-4A3A-A901-5803950A388B}"/>
               </a:ext>
             </a:extLst>
           </p:cNvPr>
@@ -2590,7 +2590,7 @@
           <p:cNvPr id="3" name="">
             <a:extLst xmlns:a="http://schemas.openxmlformats.org/drawingml/2006/main">
               <a:ext uri="{FF2B5EF4-FFF2-40B4-BE49-F238E27FC236}">
-                <a16:creationId xmlns:a16="http://schemas.microsoft.com/office/drawing/2014/main" id="{539720FB-9D88-4CA3-9B18-9D91EC4AFCE8}"/>
+                <a16:creationId xmlns:a16="http://schemas.microsoft.com/office/drawing/2014/main" id="{254BDB90-F893-49B2-9397-EEA0F6A4862C}"/>
               </a:ext>
             </a:extLst>
           </p:cNvPr>
@@ -2623,7 +2623,7 @@
           <p:cNvPr id="4" name="">
             <a:extLst xmlns:a="http://schemas.openxmlformats.org/drawingml/2006/main">
               <a:ext uri="{FF2B5EF4-FFF2-40B4-BE49-F238E27FC236}">
-                <a16:creationId xmlns:a16="http://schemas.microsoft.com/office/drawing/2014/main" id="{35D9B216-B572-4B2C-BECA-747D878CC563}"/>
+                <a16:creationId xmlns:a16="http://schemas.microsoft.com/office/drawing/2014/main" id="{FD70A4D0-9019-40C8-9F0C-4103D4C3EB78}"/>
               </a:ext>
             </a:extLst>
           </p:cNvPr>
@@ -2673,7 +2673,7 @@
           <p:cNvPr id="5" name="">
             <a:extLst xmlns:a="http://schemas.openxmlformats.org/drawingml/2006/main">
               <a:ext uri="{FF2B5EF4-FFF2-40B4-BE49-F238E27FC236}">
-                <a16:creationId xmlns:a16="http://schemas.microsoft.com/office/drawing/2014/main" id="{31E8118F-CB7B-466C-A31E-E1D08DC1EF7E}"/>
+                <a16:creationId xmlns:a16="http://schemas.microsoft.com/office/drawing/2014/main" id="{0EFAA6C4-7FDB-4C4F-82A1-4524DBA2F804}"/>
               </a:ext>
             </a:extLst>
           </p:cNvPr>
@@ -2723,7 +2723,7 @@
           <p:cNvPr id="6" name="">
             <a:extLst xmlns:a="http://schemas.openxmlformats.org/drawingml/2006/main">
               <a:ext uri="{FF2B5EF4-FFF2-40B4-BE49-F238E27FC236}">
-                <a16:creationId xmlns:a16="http://schemas.microsoft.com/office/drawing/2014/main" id="{0C6BE8D4-1888-4809-A529-E116709B4CA4}"/>
+                <a16:creationId xmlns:a16="http://schemas.microsoft.com/office/drawing/2014/main" id="{20AFD951-BD5A-4CF7-AA58-3B51C0E15B3D}"/>
               </a:ext>
             </a:extLst>
           </p:cNvPr>
@@ -2758,7 +2758,7 @@
           <p:cNvPr id="7" name="">
             <a:extLst xmlns:a="http://schemas.openxmlformats.org/drawingml/2006/main">
               <a:ext uri="{FF2B5EF4-FFF2-40B4-BE49-F238E27FC236}">
-                <a16:creationId xmlns:a16="http://schemas.microsoft.com/office/drawing/2014/main" id="{A581F687-0710-4964-93E9-72C84CF3D1A3}"/>
+                <a16:creationId xmlns:a16="http://schemas.microsoft.com/office/drawing/2014/main" id="{A55AF6A0-83C6-47F3-ACFF-9FCE2B0E1986}"/>
               </a:ext>
             </a:extLst>
           </p:cNvPr>
@@ -2808,7 +2808,7 @@
           <p:cNvPr id="8" name="">
             <a:extLst xmlns:a="http://schemas.openxmlformats.org/drawingml/2006/main">
               <a:ext uri="{FF2B5EF4-FFF2-40B4-BE49-F238E27FC236}">
-                <a16:creationId xmlns:a16="http://schemas.microsoft.com/office/drawing/2014/main" id="{BB7EE692-1B7D-49E2-A505-9A61BDB96EB8}"/>
+                <a16:creationId xmlns:a16="http://schemas.microsoft.com/office/drawing/2014/main" id="{A2257547-C360-4617-B777-548C3A1B9136}"/>
               </a:ext>
             </a:extLst>
           </p:cNvPr>
@@ -2858,7 +2858,7 @@
           <p:cNvPr id="9" name="">
             <a:extLst xmlns:a="http://schemas.openxmlformats.org/drawingml/2006/main">
               <a:ext uri="{FF2B5EF4-FFF2-40B4-BE49-F238E27FC236}">
-                <a16:creationId xmlns:a16="http://schemas.microsoft.com/office/drawing/2014/main" id="{81DAA087-0912-4AA8-8719-73672167E0F0}"/>
+                <a16:creationId xmlns:a16="http://schemas.microsoft.com/office/drawing/2014/main" id="{47DED1AB-B741-498E-84CF-F5C01083D93B}"/>
               </a:ext>
             </a:extLst>
           </p:cNvPr>
@@ -2893,7 +2893,7 @@
           <p:cNvPr id="10" name="">
             <a:extLst xmlns:a="http://schemas.openxmlformats.org/drawingml/2006/main">
               <a:ext uri="{FF2B5EF4-FFF2-40B4-BE49-F238E27FC236}">
-                <a16:creationId xmlns:a16="http://schemas.microsoft.com/office/drawing/2014/main" id="{AD01FCB1-EDAA-44A1-A265-B71347046FB7}"/>
+                <a16:creationId xmlns:a16="http://schemas.microsoft.com/office/drawing/2014/main" id="{F81DED49-4BA0-4496-A28F-B58775F48F1E}"/>
               </a:ext>
             </a:extLst>
           </p:cNvPr>
@@ -2943,7 +2943,7 @@
           <p:cNvPr id="11" name="">
             <a:extLst xmlns:a="http://schemas.openxmlformats.org/drawingml/2006/main">
               <a:ext uri="{FF2B5EF4-FFF2-40B4-BE49-F238E27FC236}">
-                <a16:creationId xmlns:a16="http://schemas.microsoft.com/office/drawing/2014/main" id="{04801CC5-D269-4EAE-AE11-FE03F23B6A49}"/>
+                <a16:creationId xmlns:a16="http://schemas.microsoft.com/office/drawing/2014/main" id="{48A9B3E4-94CD-4433-B116-5E72816E2641}"/>
               </a:ext>
             </a:extLst>
           </p:cNvPr>
@@ -2993,7 +2993,7 @@
           <p:cNvPr id="12" name="">
             <a:extLst xmlns:a="http://schemas.openxmlformats.org/drawingml/2006/main">
               <a:ext uri="{FF2B5EF4-FFF2-40B4-BE49-F238E27FC236}">
-                <a16:creationId xmlns:a16="http://schemas.microsoft.com/office/drawing/2014/main" id="{6C4CDAC6-B2BE-4EF2-B97C-0D88D87CA4F6}"/>
+                <a16:creationId xmlns:a16="http://schemas.microsoft.com/office/drawing/2014/main" id="{524A3B56-4730-4CB0-A281-18EE5448115E}"/>
               </a:ext>
             </a:extLst>
           </p:cNvPr>
@@ -3028,7 +3028,7 @@
           <p:cNvPr id="13" name="">
             <a:extLst xmlns:a="http://schemas.openxmlformats.org/drawingml/2006/main">
               <a:ext uri="{FF2B5EF4-FFF2-40B4-BE49-F238E27FC236}">
-                <a16:creationId xmlns:a16="http://schemas.microsoft.com/office/drawing/2014/main" id="{3F69399C-8FEF-4A64-8651-B02CD03625B5}"/>
+                <a16:creationId xmlns:a16="http://schemas.microsoft.com/office/drawing/2014/main" id="{8771374E-E55C-4128-B5ED-DE670500643B}"/>
               </a:ext>
             </a:extLst>
           </p:cNvPr>
@@ -3068,7 +3068,7 @@
                   <a:srgbClr val="111827"/>
                 </a:solidFill>
               </a:rPr>
-              <a:t>QA / AT</a:t>
+              <a:t>Тесты / автотесты</a:t>
             </a:r>
           </a:p>
         </p:txBody>
@@ -3078,7 +3078,7 @@
           <p:cNvPr id="14" name="">
             <a:extLst xmlns:a="http://schemas.openxmlformats.org/drawingml/2006/main">
               <a:ext uri="{FF2B5EF4-FFF2-40B4-BE49-F238E27FC236}">
-                <a16:creationId xmlns:a16="http://schemas.microsoft.com/office/drawing/2014/main" id="{6BDF3011-FC43-4F7C-AD3E-F1ACB9FC10B1}"/>
+                <a16:creationId xmlns:a16="http://schemas.microsoft.com/office/drawing/2014/main" id="{AB35938A-204C-4677-B577-AE7EFC50B10F}"/>
               </a:ext>
             </a:extLst>
           </p:cNvPr>
@@ -3128,7 +3128,7 @@
           <p:cNvPr id="15" name="">
             <a:extLst xmlns:a="http://schemas.openxmlformats.org/drawingml/2006/main">
               <a:ext uri="{FF2B5EF4-FFF2-40B4-BE49-F238E27FC236}">
-                <a16:creationId xmlns:a16="http://schemas.microsoft.com/office/drawing/2014/main" id="{1F708B01-C074-4CE3-B2B0-8F0F1F36ABA0}"/>
+                <a16:creationId xmlns:a16="http://schemas.microsoft.com/office/drawing/2014/main" id="{9A2CCEE8-5C09-46DB-854B-B9EE9614AA66}"/>
               </a:ext>
             </a:extLst>
           </p:cNvPr>
@@ -3163,7 +3163,7 @@
           <p:cNvPr id="16" name="">
             <a:extLst xmlns:a="http://schemas.openxmlformats.org/drawingml/2006/main">
               <a:ext uri="{FF2B5EF4-FFF2-40B4-BE49-F238E27FC236}">
-                <a16:creationId xmlns:a16="http://schemas.microsoft.com/office/drawing/2014/main" id="{E33EEC0A-528E-4A5B-B4B8-ED900061EF0D}"/>
+                <a16:creationId xmlns:a16="http://schemas.microsoft.com/office/drawing/2014/main" id="{4BE88CCB-4444-4A5C-A70F-0AD7442C628E}"/>
               </a:ext>
             </a:extLst>
           </p:cNvPr>
@@ -3213,7 +3213,7 @@
           <p:cNvPr id="17" name="">
             <a:extLst xmlns:a="http://schemas.openxmlformats.org/drawingml/2006/main">
               <a:ext uri="{FF2B5EF4-FFF2-40B4-BE49-F238E27FC236}">
-                <a16:creationId xmlns:a16="http://schemas.microsoft.com/office/drawing/2014/main" id="{26C1BE09-7940-4144-80FA-7D3CA20DE4D4}"/>
+                <a16:creationId xmlns:a16="http://schemas.microsoft.com/office/drawing/2014/main" id="{D738468C-3B29-495D-A697-E1875CA4E1E1}"/>
               </a:ext>
             </a:extLst>
           </p:cNvPr>
@@ -3253,7 +3253,7 @@
                   <a:srgbClr val="4B5563"/>
                 </a:solidFill>
               </a:rPr>
-              <a:t>не видит цельную цепочку решений и evidence</a:t>
+              <a:t>не видит цельную цепочку решений и подтверждений</a:t>
             </a:r>
           </a:p>
         </p:txBody>
@@ -3261,7 +3261,7 @@
     </p:spTree>
     <p:extLst>
       <p:ext uri="{BB962C8B-B14F-4D97-AF65-F5344CB8AC3E}">
-        <p14:creationId xmlns:p14="http://schemas.microsoft.com/office/powerpoint/2010/main" val="1254684940"/>
+        <p14:creationId xmlns:p14="http://schemas.microsoft.com/office/powerpoint/2010/main" val="1294687725"/>
       </p:ext>
     </p:extLst>
   </p:cSld>
@@ -3292,7 +3292,7 @@
           <p:cNvPr id="1" name="">
             <a:extLst xmlns:a="http://schemas.openxmlformats.org/drawingml/2006/main">
               <a:ext uri="{FF2B5EF4-FFF2-40B4-BE49-F238E27FC236}">
-                <a16:creationId xmlns:a16="http://schemas.microsoft.com/office/drawing/2014/main" id="{B994AD60-FC83-48FD-B391-100F32ABBBDC}"/>
+                <a16:creationId xmlns:a16="http://schemas.microsoft.com/office/drawing/2014/main" id="{882F881D-B9E4-4FC7-A1C4-4D40AFF40B5E}"/>
               </a:ext>
             </a:extLst>
           </p:cNvPr>
@@ -3342,7 +3342,7 @@
           <p:cNvPr id="2" name="">
             <a:extLst xmlns:a="http://schemas.openxmlformats.org/drawingml/2006/main">
               <a:ext uri="{FF2B5EF4-FFF2-40B4-BE49-F238E27FC236}">
-                <a16:creationId xmlns:a16="http://schemas.microsoft.com/office/drawing/2014/main" id="{D770C0C2-E7A0-45C0-B15B-8136D5D60E37}"/>
+                <a16:creationId xmlns:a16="http://schemas.microsoft.com/office/drawing/2014/main" id="{96F1C73F-6B4D-4262-97E1-0742CE334DD3}"/>
               </a:ext>
             </a:extLst>
           </p:cNvPr>
@@ -3382,7 +3382,7 @@
                   <a:srgbClr val="111827"/>
                 </a:solidFill>
               </a:rPr>
-              <a:t>Источник правды остается в Git/OpenSpec, остальные инструменты получают свои роли</a:t>
+              <a:t>Основные решения храним в Git и OpenSpec, остальные инструменты работают вокруг них</a:t>
             </a:r>
           </a:p>
         </p:txBody>
@@ -3392,7 +3392,7 @@
           <p:cNvPr id="3" name="">
             <a:extLst xmlns:a="http://schemas.openxmlformats.org/drawingml/2006/main">
               <a:ext uri="{FF2B5EF4-FFF2-40B4-BE49-F238E27FC236}">
-                <a16:creationId xmlns:a16="http://schemas.microsoft.com/office/drawing/2014/main" id="{74BC1902-99F1-43DF-8931-280FEA8294AD}"/>
+                <a16:creationId xmlns:a16="http://schemas.microsoft.com/office/drawing/2014/main" id="{70788B82-7F8A-47B0-B413-E7028CF997BC}"/>
               </a:ext>
             </a:extLst>
           </p:cNvPr>
@@ -3425,7 +3425,7 @@
           <p:cNvPr id="4" name="">
             <a:extLst xmlns:a="http://schemas.openxmlformats.org/drawingml/2006/main">
               <a:ext uri="{FF2B5EF4-FFF2-40B4-BE49-F238E27FC236}">
-                <a16:creationId xmlns:a16="http://schemas.microsoft.com/office/drawing/2014/main" id="{DD0100F6-CF6A-4FFD-8D3E-63094DAC780B}"/>
+                <a16:creationId xmlns:a16="http://schemas.microsoft.com/office/drawing/2014/main" id="{BE35DC49-47B1-4653-9F32-C19BC8DDDB83}"/>
               </a:ext>
             </a:extLst>
           </p:cNvPr>
@@ -3475,7 +3475,7 @@
           <p:cNvPr id="5" name="">
             <a:extLst xmlns:a="http://schemas.openxmlformats.org/drawingml/2006/main">
               <a:ext uri="{FF2B5EF4-FFF2-40B4-BE49-F238E27FC236}">
-                <a16:creationId xmlns:a16="http://schemas.microsoft.com/office/drawing/2014/main" id="{C1A30ECA-5373-4B88-A45B-BD8D64F62A9B}"/>
+                <a16:creationId xmlns:a16="http://schemas.microsoft.com/office/drawing/2014/main" id="{4C1CF10D-96A3-4FE5-B161-8DA174BC3AE9}"/>
               </a:ext>
             </a:extLst>
           </p:cNvPr>
@@ -3525,7 +3525,7 @@
           <p:cNvPr id="6" name="">
             <a:extLst xmlns:a="http://schemas.openxmlformats.org/drawingml/2006/main">
               <a:ext uri="{FF2B5EF4-FFF2-40B4-BE49-F238E27FC236}">
-                <a16:creationId xmlns:a16="http://schemas.microsoft.com/office/drawing/2014/main" id="{4AC50598-9729-4289-9B27-A03ED2112817}"/>
+                <a16:creationId xmlns:a16="http://schemas.microsoft.com/office/drawing/2014/main" id="{B8C2F632-C766-4C5B-BB4F-161F1FEF1461}"/>
               </a:ext>
             </a:extLst>
           </p:cNvPr>
@@ -3560,7 +3560,7 @@
           <p:cNvPr id="7" name="">
             <a:extLst xmlns:a="http://schemas.openxmlformats.org/drawingml/2006/main">
               <a:ext uri="{FF2B5EF4-FFF2-40B4-BE49-F238E27FC236}">
-                <a16:creationId xmlns:a16="http://schemas.microsoft.com/office/drawing/2014/main" id="{AC6EBD8D-1143-4BEF-BCA7-849EEB259ED4}"/>
+                <a16:creationId xmlns:a16="http://schemas.microsoft.com/office/drawing/2014/main" id="{650DAD0A-A6E8-4D04-AF4A-8F2DBE25D6F5}"/>
               </a:ext>
             </a:extLst>
           </p:cNvPr>
@@ -3610,7 +3610,7 @@
           <p:cNvPr id="8" name="">
             <a:extLst xmlns:a="http://schemas.openxmlformats.org/drawingml/2006/main">
               <a:ext uri="{FF2B5EF4-FFF2-40B4-BE49-F238E27FC236}">
-                <a16:creationId xmlns:a16="http://schemas.microsoft.com/office/drawing/2014/main" id="{10D4BF7D-DCAB-45E7-8EB4-3A43B99AE181}"/>
+                <a16:creationId xmlns:a16="http://schemas.microsoft.com/office/drawing/2014/main" id="{A5E87BD2-FD2F-4103-999D-E7014F5CEE1B}"/>
               </a:ext>
             </a:extLst>
           </p:cNvPr>
@@ -3650,7 +3650,7 @@
                   <a:srgbClr val="111827"/>
                 </a:solidFill>
               </a:rPr>
-              <a:t>каноничные требования и change packages</a:t>
+              <a:t>главные требования и пакеты изменений</a:t>
             </a:r>
           </a:p>
         </p:txBody>
@@ -3660,7 +3660,7 @@
           <p:cNvPr id="9" name="">
             <a:extLst xmlns:a="http://schemas.openxmlformats.org/drawingml/2006/main">
               <a:ext uri="{FF2B5EF4-FFF2-40B4-BE49-F238E27FC236}">
-                <a16:creationId xmlns:a16="http://schemas.microsoft.com/office/drawing/2014/main" id="{67439528-958E-4674-84D5-DFD5524F4470}"/>
+                <a16:creationId xmlns:a16="http://schemas.microsoft.com/office/drawing/2014/main" id="{E7404860-C504-4084-A58E-7DE810F2EFCD}"/>
               </a:ext>
             </a:extLst>
           </p:cNvPr>
@@ -3695,7 +3695,7 @@
           <p:cNvPr id="10" name="">
             <a:extLst xmlns:a="http://schemas.openxmlformats.org/drawingml/2006/main">
               <a:ext uri="{FF2B5EF4-FFF2-40B4-BE49-F238E27FC236}">
-                <a16:creationId xmlns:a16="http://schemas.microsoft.com/office/drawing/2014/main" id="{1EA81123-4E7F-4BB1-A3F5-9A644C91C0E7}"/>
+                <a16:creationId xmlns:a16="http://schemas.microsoft.com/office/drawing/2014/main" id="{14F19EF4-BC15-4C31-9071-31823387FE4A}"/>
               </a:ext>
             </a:extLst>
           </p:cNvPr>
@@ -3745,7 +3745,7 @@
           <p:cNvPr id="11" name="">
             <a:extLst xmlns:a="http://schemas.openxmlformats.org/drawingml/2006/main">
               <a:ext uri="{FF2B5EF4-FFF2-40B4-BE49-F238E27FC236}">
-                <a16:creationId xmlns:a16="http://schemas.microsoft.com/office/drawing/2014/main" id="{530908A6-5FE9-47D8-AC55-28CF484BDB35}"/>
+                <a16:creationId xmlns:a16="http://schemas.microsoft.com/office/drawing/2014/main" id="{6845845A-09C9-401E-A4F1-E56568AFAB15}"/>
               </a:ext>
             </a:extLst>
           </p:cNvPr>
@@ -3785,7 +3785,7 @@
                   <a:srgbClr val="4B5563"/>
                 </a:solidFill>
               </a:rPr>
-              <a:t>читаемые публикации</a:t>
+              <a:t>страницы для чтения</a:t>
             </a:r>
           </a:p>
         </p:txBody>
@@ -3795,7 +3795,7 @@
           <p:cNvPr id="12" name="">
             <a:extLst xmlns:a="http://schemas.openxmlformats.org/drawingml/2006/main">
               <a:ext uri="{FF2B5EF4-FFF2-40B4-BE49-F238E27FC236}">
-                <a16:creationId xmlns:a16="http://schemas.microsoft.com/office/drawing/2014/main" id="{BB2B9B2A-DD49-4D4C-B58A-626C0CFE77FD}"/>
+                <a16:creationId xmlns:a16="http://schemas.microsoft.com/office/drawing/2014/main" id="{8430AD4A-289B-4F41-942A-800FC68D77F2}"/>
               </a:ext>
             </a:extLst>
           </p:cNvPr>
@@ -3830,7 +3830,7 @@
           <p:cNvPr id="13" name="">
             <a:extLst xmlns:a="http://schemas.openxmlformats.org/drawingml/2006/main">
               <a:ext uri="{FF2B5EF4-FFF2-40B4-BE49-F238E27FC236}">
-                <a16:creationId xmlns:a16="http://schemas.microsoft.com/office/drawing/2014/main" id="{97AA8BC8-3508-4B04-B25F-771580B871A2}"/>
+                <a16:creationId xmlns:a16="http://schemas.microsoft.com/office/drawing/2014/main" id="{10549EE1-4F79-47B0-9433-440BC08540E4}"/>
               </a:ext>
             </a:extLst>
           </p:cNvPr>
@@ -3870,7 +3870,7 @@
                   <a:srgbClr val="111827"/>
                 </a:solidFill>
               </a:rPr>
-              <a:t>Jira / tracker</a:t>
+              <a:t>Jira</a:t>
             </a:r>
           </a:p>
         </p:txBody>
@@ -3880,7 +3880,7 @@
           <p:cNvPr id="14" name="">
             <a:extLst xmlns:a="http://schemas.openxmlformats.org/drawingml/2006/main">
               <a:ext uri="{FF2B5EF4-FFF2-40B4-BE49-F238E27FC236}">
-                <a16:creationId xmlns:a16="http://schemas.microsoft.com/office/drawing/2014/main" id="{FD7F6E8C-B60E-4D35-80BF-03FAA4B1978C}"/>
+                <a16:creationId xmlns:a16="http://schemas.microsoft.com/office/drawing/2014/main" id="{D7F9CA15-8829-47E1-8737-8F8059C2ECD8}"/>
               </a:ext>
             </a:extLst>
           </p:cNvPr>
@@ -3920,7 +3920,7 @@
                   <a:srgbClr val="4B5563"/>
                 </a:solidFill>
               </a:rPr>
-              <a:t>статус и работа</a:t>
+              <a:t>статусы и задачи</a:t>
             </a:r>
           </a:p>
         </p:txBody>
@@ -3930,7 +3930,7 @@
           <p:cNvPr id="15" name="">
             <a:extLst xmlns:a="http://schemas.openxmlformats.org/drawingml/2006/main">
               <a:ext uri="{FF2B5EF4-FFF2-40B4-BE49-F238E27FC236}">
-                <a16:creationId xmlns:a16="http://schemas.microsoft.com/office/drawing/2014/main" id="{39C61869-24BC-420D-B7CB-BDE4EEEFF0A8}"/>
+                <a16:creationId xmlns:a16="http://schemas.microsoft.com/office/drawing/2014/main" id="{CBBC3785-C929-401C-8EE0-239BA5578CFA}"/>
               </a:ext>
             </a:extLst>
           </p:cNvPr>
@@ -3965,7 +3965,7 @@
           <p:cNvPr id="16" name="">
             <a:extLst xmlns:a="http://schemas.openxmlformats.org/drawingml/2006/main">
               <a:ext uri="{FF2B5EF4-FFF2-40B4-BE49-F238E27FC236}">
-                <a16:creationId xmlns:a16="http://schemas.microsoft.com/office/drawing/2014/main" id="{9D7786C6-45B6-486C-B2A2-91BBC2E516F5}"/>
+                <a16:creationId xmlns:a16="http://schemas.microsoft.com/office/drawing/2014/main" id="{C16D6819-3D9F-49C7-8FEB-55B294E5D63D}"/>
               </a:ext>
             </a:extLst>
           </p:cNvPr>
@@ -4005,7 +4005,7 @@
                   <a:srgbClr val="111827"/>
                 </a:solidFill>
               </a:rPr>
-              <a:t>Bitbucket PR</a:t>
+              <a:t>Bitbucket</a:t>
             </a:r>
           </a:p>
         </p:txBody>
@@ -4015,7 +4015,7 @@
           <p:cNvPr id="17" name="">
             <a:extLst xmlns:a="http://schemas.openxmlformats.org/drawingml/2006/main">
               <a:ext uri="{FF2B5EF4-FFF2-40B4-BE49-F238E27FC236}">
-                <a16:creationId xmlns:a16="http://schemas.microsoft.com/office/drawing/2014/main" id="{8D0FEEA0-5096-4EAF-BE66-690A790DE042}"/>
+                <a16:creationId xmlns:a16="http://schemas.microsoft.com/office/drawing/2014/main" id="{9057C8CF-B38A-4972-89A6-30AA6A343B63}"/>
               </a:ext>
             </a:extLst>
           </p:cNvPr>
@@ -4055,7 +4055,7 @@
                   <a:srgbClr val="4B5563"/>
                 </a:solidFill>
               </a:rPr>
-              <a:t>review и audit</a:t>
+              <a:t>ревью и история решений</a:t>
             </a:r>
           </a:p>
         </p:txBody>
@@ -4065,7 +4065,7 @@
           <p:cNvPr id="18" name="">
             <a:extLst xmlns:a="http://schemas.openxmlformats.org/drawingml/2006/main">
               <a:ext uri="{FF2B5EF4-FFF2-40B4-BE49-F238E27FC236}">
-                <a16:creationId xmlns:a16="http://schemas.microsoft.com/office/drawing/2014/main" id="{5C116166-78FE-4D5A-92CF-9CDE1DE63F85}"/>
+                <a16:creationId xmlns:a16="http://schemas.microsoft.com/office/drawing/2014/main" id="{EAD3F0D1-7753-4C32-AB96-17AC791F58CC}"/>
               </a:ext>
             </a:extLst>
           </p:cNvPr>
@@ -4100,7 +4100,7 @@
           <p:cNvPr id="19" name="">
             <a:extLst xmlns:a="http://schemas.openxmlformats.org/drawingml/2006/main">
               <a:ext uri="{FF2B5EF4-FFF2-40B4-BE49-F238E27FC236}">
-                <a16:creationId xmlns:a16="http://schemas.microsoft.com/office/drawing/2014/main" id="{1CB8C93D-C452-42BF-BBAB-693A60DC9FBE}"/>
+                <a16:creationId xmlns:a16="http://schemas.microsoft.com/office/drawing/2014/main" id="{A22D35C2-7CDC-427C-B99F-0EF297C6CEDA}"/>
               </a:ext>
             </a:extLst>
           </p:cNvPr>
@@ -4150,7 +4150,7 @@
           <p:cNvPr id="20" name="">
             <a:extLst xmlns:a="http://schemas.openxmlformats.org/drawingml/2006/main">
               <a:ext uri="{FF2B5EF4-FFF2-40B4-BE49-F238E27FC236}">
-                <a16:creationId xmlns:a16="http://schemas.microsoft.com/office/drawing/2014/main" id="{8F5F9753-2D41-4F28-AA8A-E533AB6D130B}"/>
+                <a16:creationId xmlns:a16="http://schemas.microsoft.com/office/drawing/2014/main" id="{74C3036A-1952-49BE-B9C3-E67B3080CEC9}"/>
               </a:ext>
             </a:extLst>
           </p:cNvPr>
@@ -4190,7 +4190,7 @@
                   <a:srgbClr val="4B5563"/>
                 </a:solidFill>
               </a:rPr>
-              <a:t>проверки и gates</a:t>
+              <a:t>автоматические проверки</a:t>
             </a:r>
           </a:p>
         </p:txBody>
@@ -4200,7 +4200,7 @@
           <p:cNvPr id="21" name="">
             <a:extLst xmlns:a="http://schemas.openxmlformats.org/drawingml/2006/main">
               <a:ext uri="{FF2B5EF4-FFF2-40B4-BE49-F238E27FC236}">
-                <a16:creationId xmlns:a16="http://schemas.microsoft.com/office/drawing/2014/main" id="{B8BBDCD6-DE4E-4347-8EC8-F30E3FD35EAE}"/>
+                <a16:creationId xmlns:a16="http://schemas.microsoft.com/office/drawing/2014/main" id="{13AF2772-F3ED-45A3-9151-96157D6292CC}"/>
               </a:ext>
             </a:extLst>
           </p:cNvPr>
@@ -4233,7 +4233,7 @@
           <p:cNvPr id="22" name="">
             <a:extLst xmlns:a="http://schemas.openxmlformats.org/drawingml/2006/main">
               <a:ext uri="{FF2B5EF4-FFF2-40B4-BE49-F238E27FC236}">
-                <a16:creationId xmlns:a16="http://schemas.microsoft.com/office/drawing/2014/main" id="{CBEA3B68-D4FC-4444-8FCB-BE1C138E5DEA}"/>
+                <a16:creationId xmlns:a16="http://schemas.microsoft.com/office/drawing/2014/main" id="{DFCB0E7A-0FF3-400F-9A3B-C63E570294CF}"/>
               </a:ext>
             </a:extLst>
           </p:cNvPr>
@@ -4266,7 +4266,7 @@
           <p:cNvPr id="23" name="">
             <a:extLst xmlns:a="http://schemas.openxmlformats.org/drawingml/2006/main">
               <a:ext uri="{FF2B5EF4-FFF2-40B4-BE49-F238E27FC236}">
-                <a16:creationId xmlns:a16="http://schemas.microsoft.com/office/drawing/2014/main" id="{EA6CFC89-C430-4A3A-9E79-94823D49003B}"/>
+                <a16:creationId xmlns:a16="http://schemas.microsoft.com/office/drawing/2014/main" id="{6804C068-0474-4E24-803E-25A91D7C60EE}"/>
               </a:ext>
             </a:extLst>
           </p:cNvPr>
@@ -4299,7 +4299,7 @@
           <p:cNvPr id="24" name="">
             <a:extLst xmlns:a="http://schemas.openxmlformats.org/drawingml/2006/main">
               <a:ext uri="{FF2B5EF4-FFF2-40B4-BE49-F238E27FC236}">
-                <a16:creationId xmlns:a16="http://schemas.microsoft.com/office/drawing/2014/main" id="{6BA24F21-B82E-4237-BB0D-A48567013C5E}"/>
+                <a16:creationId xmlns:a16="http://schemas.microsoft.com/office/drawing/2014/main" id="{7BDD41F2-13BA-484F-B411-7D6B98952A4A}"/>
               </a:ext>
             </a:extLst>
           </p:cNvPr>
@@ -4330,7 +4330,7 @@
     </p:spTree>
     <p:extLst>
       <p:ext uri="{BB962C8B-B14F-4D97-AF65-F5344CB8AC3E}">
-        <p14:creationId xmlns:p14="http://schemas.microsoft.com/office/powerpoint/2010/main" val="2043485819"/>
+        <p14:creationId xmlns:p14="http://schemas.microsoft.com/office/powerpoint/2010/main" val="881361200"/>
       </p:ext>
     </p:extLst>
   </p:cSld>
@@ -4361,7 +4361,7 @@
           <p:cNvPr id="1" name="">
             <a:extLst xmlns:a="http://schemas.openxmlformats.org/drawingml/2006/main">
               <a:ext uri="{FF2B5EF4-FFF2-40B4-BE49-F238E27FC236}">
-                <a16:creationId xmlns:a16="http://schemas.microsoft.com/office/drawing/2014/main" id="{0ECF9DB6-2986-4F26-A1EC-65BE263C88F6}"/>
+                <a16:creationId xmlns:a16="http://schemas.microsoft.com/office/drawing/2014/main" id="{007AAB9A-992E-4D01-9827-57D5739A4177}"/>
               </a:ext>
             </a:extLst>
           </p:cNvPr>
@@ -4411,7 +4411,7 @@
           <p:cNvPr id="2" name="">
             <a:extLst xmlns:a="http://schemas.openxmlformats.org/drawingml/2006/main">
               <a:ext uri="{FF2B5EF4-FFF2-40B4-BE49-F238E27FC236}">
-                <a16:creationId xmlns:a16="http://schemas.microsoft.com/office/drawing/2014/main" id="{4C20320E-18B5-4CF7-9E40-77817C111023}"/>
+                <a16:creationId xmlns:a16="http://schemas.microsoft.com/office/drawing/2014/main" id="{E44A5E4E-6039-4BB9-B6B8-CE22F35B5357}"/>
               </a:ext>
             </a:extLst>
           </p:cNvPr>
@@ -4451,7 +4451,7 @@
                   <a:srgbClr val="111827"/>
                 </a:solidFill>
               </a:rPr>
-              <a:t>Change package связывает решение, реализацию и проверку</a:t>
+              <a:t>Пакет изменения связывает решение, реализацию и проверку</a:t>
             </a:r>
           </a:p>
         </p:txBody>
@@ -4461,7 +4461,7 @@
           <p:cNvPr id="3" name="">
             <a:extLst xmlns:a="http://schemas.openxmlformats.org/drawingml/2006/main">
               <a:ext uri="{FF2B5EF4-FFF2-40B4-BE49-F238E27FC236}">
-                <a16:creationId xmlns:a16="http://schemas.microsoft.com/office/drawing/2014/main" id="{BCC3F44E-51F0-4154-8F9A-F85353419901}"/>
+                <a16:creationId xmlns:a16="http://schemas.microsoft.com/office/drawing/2014/main" id="{B143F845-8CD6-477A-A564-B6FFA0AEB7BA}"/>
               </a:ext>
             </a:extLst>
           </p:cNvPr>
@@ -4494,7 +4494,7 @@
           <p:cNvPr id="4" name="">
             <a:extLst xmlns:a="http://schemas.openxmlformats.org/drawingml/2006/main">
               <a:ext uri="{FF2B5EF4-FFF2-40B4-BE49-F238E27FC236}">
-                <a16:creationId xmlns:a16="http://schemas.microsoft.com/office/drawing/2014/main" id="{4FC7E807-CB55-43B7-8AD6-BC902725EC60}"/>
+                <a16:creationId xmlns:a16="http://schemas.microsoft.com/office/drawing/2014/main" id="{0A4FACF7-8228-4AC5-97A6-82CEAA93550B}"/>
               </a:ext>
             </a:extLst>
           </p:cNvPr>
@@ -4544,7 +4544,7 @@
           <p:cNvPr id="5" name="">
             <a:extLst xmlns:a="http://schemas.openxmlformats.org/drawingml/2006/main">
               <a:ext uri="{FF2B5EF4-FFF2-40B4-BE49-F238E27FC236}">
-                <a16:creationId xmlns:a16="http://schemas.microsoft.com/office/drawing/2014/main" id="{641018C3-0F64-466F-A3E5-791F22FCB04F}"/>
+                <a16:creationId xmlns:a16="http://schemas.microsoft.com/office/drawing/2014/main" id="{02F5DDFD-6FB6-4BBF-93DF-DDAE7D1F824E}"/>
               </a:ext>
             </a:extLst>
           </p:cNvPr>
@@ -4594,7 +4594,7 @@
           <p:cNvPr id="6" name="">
             <a:extLst xmlns:a="http://schemas.openxmlformats.org/drawingml/2006/main">
               <a:ext uri="{FF2B5EF4-FFF2-40B4-BE49-F238E27FC236}">
-                <a16:creationId xmlns:a16="http://schemas.microsoft.com/office/drawing/2014/main" id="{232DDFF1-C55B-4C90-8206-D5BBBF75DF19}"/>
+                <a16:creationId xmlns:a16="http://schemas.microsoft.com/office/drawing/2014/main" id="{A4EEBF41-FDF6-4644-BC11-AA39E6912FB2}"/>
               </a:ext>
             </a:extLst>
           </p:cNvPr>
@@ -4629,7 +4629,7 @@
           <p:cNvPr id="7" name="">
             <a:extLst xmlns:a="http://schemas.openxmlformats.org/drawingml/2006/main">
               <a:ext uri="{FF2B5EF4-FFF2-40B4-BE49-F238E27FC236}">
-                <a16:creationId xmlns:a16="http://schemas.microsoft.com/office/drawing/2014/main" id="{D0062B7A-494E-4E0F-9E8E-766077A745B0}"/>
+                <a16:creationId xmlns:a16="http://schemas.microsoft.com/office/drawing/2014/main" id="{080284E9-8F10-4418-AA88-A78ED078A738}"/>
               </a:ext>
             </a:extLst>
           </p:cNvPr>
@@ -4669,7 +4669,7 @@
                   <a:srgbClr val="111827"/>
                 </a:solidFill>
               </a:rPr>
-              <a:t>Intent</a:t>
+              <a:t>Замысел</a:t>
             </a:r>
           </a:p>
         </p:txBody>
@@ -4679,7 +4679,7 @@
           <p:cNvPr id="8" name="">
             <a:extLst xmlns:a="http://schemas.openxmlformats.org/drawingml/2006/main">
               <a:ext uri="{FF2B5EF4-FFF2-40B4-BE49-F238E27FC236}">
-                <a16:creationId xmlns:a16="http://schemas.microsoft.com/office/drawing/2014/main" id="{6E111594-8947-4EBD-AD6B-DA6D7CB3847B}"/>
+                <a16:creationId xmlns:a16="http://schemas.microsoft.com/office/drawing/2014/main" id="{FFAE93E0-8AC8-4D61-89BC-7090B0AE0767}"/>
               </a:ext>
             </a:extLst>
           </p:cNvPr>
@@ -4729,7 +4729,7 @@
           <p:cNvPr id="9" name="">
             <a:extLst xmlns:a="http://schemas.openxmlformats.org/drawingml/2006/main">
               <a:ext uri="{FF2B5EF4-FFF2-40B4-BE49-F238E27FC236}">
-                <a16:creationId xmlns:a16="http://schemas.microsoft.com/office/drawing/2014/main" id="{5044F0A2-5D42-45B1-8E60-147EC16CF8F8}"/>
+                <a16:creationId xmlns:a16="http://schemas.microsoft.com/office/drawing/2014/main" id="{47BD51BD-86FC-49A3-8F0F-E528FBEEC6C3}"/>
               </a:ext>
             </a:extLst>
           </p:cNvPr>
@@ -4762,7 +4762,7 @@
           <p:cNvPr id="10" name="">
             <a:extLst xmlns:a="http://schemas.openxmlformats.org/drawingml/2006/main">
               <a:ext uri="{FF2B5EF4-FFF2-40B4-BE49-F238E27FC236}">
-                <a16:creationId xmlns:a16="http://schemas.microsoft.com/office/drawing/2014/main" id="{7AE79872-9CAC-43CB-833E-BBFE5DAC36FD}"/>
+                <a16:creationId xmlns:a16="http://schemas.microsoft.com/office/drawing/2014/main" id="{EB623D7D-2EAD-4314-BB97-A678CAFFF48B}"/>
               </a:ext>
             </a:extLst>
           </p:cNvPr>
@@ -4797,7 +4797,7 @@
           <p:cNvPr id="11" name="">
             <a:extLst xmlns:a="http://schemas.openxmlformats.org/drawingml/2006/main">
               <a:ext uri="{FF2B5EF4-FFF2-40B4-BE49-F238E27FC236}">
-                <a16:creationId xmlns:a16="http://schemas.microsoft.com/office/drawing/2014/main" id="{54D24163-6237-4528-9DDD-F73FE933B1C3}"/>
+                <a16:creationId xmlns:a16="http://schemas.microsoft.com/office/drawing/2014/main" id="{D1823B97-465D-4919-9C8A-82C3EEADC106}"/>
               </a:ext>
             </a:extLst>
           </p:cNvPr>
@@ -4837,7 +4837,7 @@
                   <a:srgbClr val="0F766E"/>
                 </a:solidFill>
               </a:rPr>
-              <a:t>Scenario</a:t>
+              <a:t>Сценарий</a:t>
             </a:r>
           </a:p>
         </p:txBody>
@@ -4847,7 +4847,7 @@
           <p:cNvPr id="12" name="">
             <a:extLst xmlns:a="http://schemas.openxmlformats.org/drawingml/2006/main">
               <a:ext uri="{FF2B5EF4-FFF2-40B4-BE49-F238E27FC236}">
-                <a16:creationId xmlns:a16="http://schemas.microsoft.com/office/drawing/2014/main" id="{6A225C74-6A9F-4A3A-B83A-85BF9790CB56}"/>
+                <a16:creationId xmlns:a16="http://schemas.microsoft.com/office/drawing/2014/main" id="{7741D839-C6ED-4336-BBF6-24303421A008}"/>
               </a:ext>
             </a:extLst>
           </p:cNvPr>
@@ -4897,7 +4897,7 @@
           <p:cNvPr id="13" name="">
             <a:extLst xmlns:a="http://schemas.openxmlformats.org/drawingml/2006/main">
               <a:ext uri="{FF2B5EF4-FFF2-40B4-BE49-F238E27FC236}">
-                <a16:creationId xmlns:a16="http://schemas.microsoft.com/office/drawing/2014/main" id="{BDBC7DA9-1A57-41B6-8C4D-86A4B1B1A158}"/>
+                <a16:creationId xmlns:a16="http://schemas.microsoft.com/office/drawing/2014/main" id="{30FE9D8F-72A3-46CA-9265-E5116331BB9F}"/>
               </a:ext>
             </a:extLst>
           </p:cNvPr>
@@ -4930,7 +4930,7 @@
           <p:cNvPr id="14" name="">
             <a:extLst xmlns:a="http://schemas.openxmlformats.org/drawingml/2006/main">
               <a:ext uri="{FF2B5EF4-FFF2-40B4-BE49-F238E27FC236}">
-                <a16:creationId xmlns:a16="http://schemas.microsoft.com/office/drawing/2014/main" id="{C0FA946E-84C1-4504-8974-48708B95078B}"/>
+                <a16:creationId xmlns:a16="http://schemas.microsoft.com/office/drawing/2014/main" id="{110BCDB6-27BB-4EAF-BC75-76BC46D007F3}"/>
               </a:ext>
             </a:extLst>
           </p:cNvPr>
@@ -4965,7 +4965,7 @@
           <p:cNvPr id="15" name="">
             <a:extLst xmlns:a="http://schemas.openxmlformats.org/drawingml/2006/main">
               <a:ext uri="{FF2B5EF4-FFF2-40B4-BE49-F238E27FC236}">
-                <a16:creationId xmlns:a16="http://schemas.microsoft.com/office/drawing/2014/main" id="{8A47D9EB-5526-4C3C-BA42-3FDAEC24DD4F}"/>
+                <a16:creationId xmlns:a16="http://schemas.microsoft.com/office/drawing/2014/main" id="{3B36613A-6AD8-41FB-A1F3-D785BE7FF617}"/>
               </a:ext>
             </a:extLst>
           </p:cNvPr>
@@ -5005,7 +5005,7 @@
                   <a:srgbClr val="111827"/>
                 </a:solidFill>
               </a:rPr>
-              <a:t>Tasks</a:t>
+              <a:t>Задачи</a:t>
             </a:r>
           </a:p>
         </p:txBody>
@@ -5015,7 +5015,7 @@
           <p:cNvPr id="16" name="">
             <a:extLst xmlns:a="http://schemas.openxmlformats.org/drawingml/2006/main">
               <a:ext uri="{FF2B5EF4-FFF2-40B4-BE49-F238E27FC236}">
-                <a16:creationId xmlns:a16="http://schemas.microsoft.com/office/drawing/2014/main" id="{F2DA4B8D-04BD-49F9-AA2A-ACBF7E3AD176}"/>
+                <a16:creationId xmlns:a16="http://schemas.microsoft.com/office/drawing/2014/main" id="{7005AD88-AB05-4CBF-A5FD-F693B48029C7}"/>
               </a:ext>
             </a:extLst>
           </p:cNvPr>
@@ -5065,7 +5065,7 @@
           <p:cNvPr id="17" name="">
             <a:extLst xmlns:a="http://schemas.openxmlformats.org/drawingml/2006/main">
               <a:ext uri="{FF2B5EF4-FFF2-40B4-BE49-F238E27FC236}">
-                <a16:creationId xmlns:a16="http://schemas.microsoft.com/office/drawing/2014/main" id="{821177E2-6A25-42B9-9C97-5C4FD99E4AA5}"/>
+                <a16:creationId xmlns:a16="http://schemas.microsoft.com/office/drawing/2014/main" id="{CC3552F4-7CFC-41D0-BCFC-DC53B1D563D6}"/>
               </a:ext>
             </a:extLst>
           </p:cNvPr>
@@ -5098,7 +5098,7 @@
           <p:cNvPr id="18" name="">
             <a:extLst xmlns:a="http://schemas.openxmlformats.org/drawingml/2006/main">
               <a:ext uri="{FF2B5EF4-FFF2-40B4-BE49-F238E27FC236}">
-                <a16:creationId xmlns:a16="http://schemas.microsoft.com/office/drawing/2014/main" id="{A30DF963-EC50-43AC-AA32-CCC4E58B6A99}"/>
+                <a16:creationId xmlns:a16="http://schemas.microsoft.com/office/drawing/2014/main" id="{918726B7-D15E-452B-A0C6-45A9F5061F86}"/>
               </a:ext>
             </a:extLst>
           </p:cNvPr>
@@ -5133,7 +5133,7 @@
           <p:cNvPr id="19" name="">
             <a:extLst xmlns:a="http://schemas.openxmlformats.org/drawingml/2006/main">
               <a:ext uri="{FF2B5EF4-FFF2-40B4-BE49-F238E27FC236}">
-                <a16:creationId xmlns:a16="http://schemas.microsoft.com/office/drawing/2014/main" id="{0DE2689A-0F47-45C9-8FFA-0C9A395FA6FF}"/>
+                <a16:creationId xmlns:a16="http://schemas.microsoft.com/office/drawing/2014/main" id="{E4A6DF5A-7110-4CC7-AC2B-6C9CD7DF7433}"/>
               </a:ext>
             </a:extLst>
           </p:cNvPr>
@@ -5173,7 +5173,7 @@
                   <a:srgbClr val="111827"/>
                 </a:solidFill>
               </a:rPr>
-              <a:t>Evidence</a:t>
+              <a:t>Доказано</a:t>
             </a:r>
           </a:p>
         </p:txBody>
@@ -5183,7 +5183,7 @@
           <p:cNvPr id="20" name="">
             <a:extLst xmlns:a="http://schemas.openxmlformats.org/drawingml/2006/main">
               <a:ext uri="{FF2B5EF4-FFF2-40B4-BE49-F238E27FC236}">
-                <a16:creationId xmlns:a16="http://schemas.microsoft.com/office/drawing/2014/main" id="{A0A491DD-F3E1-4FCC-B046-E159C53440E2}"/>
+                <a16:creationId xmlns:a16="http://schemas.microsoft.com/office/drawing/2014/main" id="{A5A0255C-330F-4B94-9DA9-71F6A8BDB5AF}"/>
               </a:ext>
             </a:extLst>
           </p:cNvPr>
@@ -5223,7 +5223,7 @@
                   <a:srgbClr val="4B5563"/>
                 </a:solidFill>
               </a:rPr>
-              <a:t>чем доказано</a:t>
+              <a:t>чем подтверждено</a:t>
             </a:r>
           </a:p>
         </p:txBody>
@@ -5233,7 +5233,7 @@
           <p:cNvPr id="21" name="">
             <a:extLst xmlns:a="http://schemas.openxmlformats.org/drawingml/2006/main">
               <a:ext uri="{FF2B5EF4-FFF2-40B4-BE49-F238E27FC236}">
-                <a16:creationId xmlns:a16="http://schemas.microsoft.com/office/drawing/2014/main" id="{93B02C72-10B2-49A6-AEB5-4BA353F5A863}"/>
+                <a16:creationId xmlns:a16="http://schemas.microsoft.com/office/drawing/2014/main" id="{1A586A29-2F61-4131-A93B-8D7BB8D6A9AE}"/>
               </a:ext>
             </a:extLst>
           </p:cNvPr>
@@ -5266,7 +5266,7 @@
           <p:cNvPr id="22" name="">
             <a:extLst xmlns:a="http://schemas.openxmlformats.org/drawingml/2006/main">
               <a:ext uri="{FF2B5EF4-FFF2-40B4-BE49-F238E27FC236}">
-                <a16:creationId xmlns:a16="http://schemas.microsoft.com/office/drawing/2014/main" id="{DAF5BB0F-E046-4CD8-ABBB-4AFB3409A643}"/>
+                <a16:creationId xmlns:a16="http://schemas.microsoft.com/office/drawing/2014/main" id="{0E1D6A1F-EB02-4787-A373-CF40052632D6}"/>
               </a:ext>
             </a:extLst>
           </p:cNvPr>
@@ -5301,7 +5301,7 @@
           <p:cNvPr id="23" name="">
             <a:extLst xmlns:a="http://schemas.openxmlformats.org/drawingml/2006/main">
               <a:ext uri="{FF2B5EF4-FFF2-40B4-BE49-F238E27FC236}">
-                <a16:creationId xmlns:a16="http://schemas.microsoft.com/office/drawing/2014/main" id="{DCDBF355-7471-4981-89A7-634870966891}"/>
+                <a16:creationId xmlns:a16="http://schemas.microsoft.com/office/drawing/2014/main" id="{52E29ACE-8282-425D-8F6D-3D477DD52938}"/>
               </a:ext>
             </a:extLst>
           </p:cNvPr>
@@ -5341,7 +5341,7 @@
                   <a:srgbClr val="111827"/>
                 </a:solidFill>
               </a:rPr>
-              <a:t>Living specs</a:t>
+              <a:t>Норма</a:t>
             </a:r>
           </a:p>
         </p:txBody>
@@ -5351,7 +5351,7 @@
           <p:cNvPr id="24" name="">
             <a:extLst xmlns:a="http://schemas.openxmlformats.org/drawingml/2006/main">
               <a:ext uri="{FF2B5EF4-FFF2-40B4-BE49-F238E27FC236}">
-                <a16:creationId xmlns:a16="http://schemas.microsoft.com/office/drawing/2014/main" id="{402CA980-AD78-4A1C-9784-930DBE5DD16E}"/>
+                <a16:creationId xmlns:a16="http://schemas.microsoft.com/office/drawing/2014/main" id="{B76B7DEF-FAD3-4C56-B45F-4DF543B22CC1}"/>
               </a:ext>
             </a:extLst>
           </p:cNvPr>
@@ -5391,7 +5391,7 @@
                   <a:srgbClr val="4B5563"/>
                 </a:solidFill>
               </a:rPr>
-              <a:t>что стало нормой</a:t>
+              <a:t>что стало правилом</a:t>
             </a:r>
           </a:p>
         </p:txBody>
@@ -5401,7 +5401,7 @@
           <p:cNvPr id="25" name="">
             <a:extLst xmlns:a="http://schemas.openxmlformats.org/drawingml/2006/main">
               <a:ext uri="{FF2B5EF4-FFF2-40B4-BE49-F238E27FC236}">
-                <a16:creationId xmlns:a16="http://schemas.microsoft.com/office/drawing/2014/main" id="{50BA08FF-8F03-4A5E-83AB-817C65BCC5A9}"/>
+                <a16:creationId xmlns:a16="http://schemas.microsoft.com/office/drawing/2014/main" id="{DCF3008A-6806-43F2-8143-AC476C65CD20}"/>
               </a:ext>
             </a:extLst>
           </p:cNvPr>
@@ -5441,7 +5441,7 @@
                   <a:srgbClr val="111827"/>
                 </a:solidFill>
               </a:rPr>
-              <a:t>Команда обсуждает не набор файлов, а одну трассируемую историю изменения.</a:t>
+              <a:t>Команда обсуждает не набор файлов, а одну понятную историю изменения.</a:t>
             </a:r>
           </a:p>
         </p:txBody>
@@ -5449,7 +5449,7 @@
     </p:spTree>
     <p:extLst>
       <p:ext uri="{BB962C8B-B14F-4D97-AF65-F5344CB8AC3E}">
-        <p14:creationId xmlns:p14="http://schemas.microsoft.com/office/powerpoint/2010/main" val="1514949073"/>
+        <p14:creationId xmlns:p14="http://schemas.microsoft.com/office/powerpoint/2010/main" val="378870238"/>
       </p:ext>
     </p:extLst>
   </p:cSld>
@@ -5480,7 +5480,7 @@
           <p:cNvPr id="1" name="">
             <a:extLst xmlns:a="http://schemas.openxmlformats.org/drawingml/2006/main">
               <a:ext uri="{FF2B5EF4-FFF2-40B4-BE49-F238E27FC236}">
-                <a16:creationId xmlns:a16="http://schemas.microsoft.com/office/drawing/2014/main" id="{461BE262-4226-499D-899A-DE37A800534C}"/>
+                <a16:creationId xmlns:a16="http://schemas.microsoft.com/office/drawing/2014/main" id="{64178100-8267-4214-A393-FE3432276B60}"/>
               </a:ext>
             </a:extLst>
           </p:cNvPr>
@@ -5530,7 +5530,7 @@
           <p:cNvPr id="2" name="">
             <a:extLst xmlns:a="http://schemas.openxmlformats.org/drawingml/2006/main">
               <a:ext uri="{FF2B5EF4-FFF2-40B4-BE49-F238E27FC236}">
-                <a16:creationId xmlns:a16="http://schemas.microsoft.com/office/drawing/2014/main" id="{BECAF7B8-72A7-4662-8747-71A2A08100B0}"/>
+                <a16:creationId xmlns:a16="http://schemas.microsoft.com/office/drawing/2014/main" id="{5A64C423-F577-423D-8586-52E9E971E1CC}"/>
               </a:ext>
             </a:extLst>
           </p:cNvPr>
@@ -5570,7 +5570,7 @@
                   <a:srgbClr val="111827"/>
                 </a:solidFill>
               </a:rPr>
-              <a:t>MVP доказывает thin change flow без тяжелых интеграций</a:t>
+              <a:t>Первый результат доказывает легкий путь изменения без тяжелых интеграций</a:t>
             </a:r>
           </a:p>
         </p:txBody>
@@ -5580,7 +5580,7 @@
           <p:cNvPr id="3" name="">
             <a:extLst xmlns:a="http://schemas.openxmlformats.org/drawingml/2006/main">
               <a:ext uri="{FF2B5EF4-FFF2-40B4-BE49-F238E27FC236}">
-                <a16:creationId xmlns:a16="http://schemas.microsoft.com/office/drawing/2014/main" id="{70C15974-781F-4004-AFCD-2530C5B2C168}"/>
+                <a16:creationId xmlns:a16="http://schemas.microsoft.com/office/drawing/2014/main" id="{EB071B67-561E-4858-B2F4-554268C51EE6}"/>
               </a:ext>
             </a:extLst>
           </p:cNvPr>
@@ -5613,7 +5613,7 @@
           <p:cNvPr id="4" name="">
             <a:extLst xmlns:a="http://schemas.openxmlformats.org/drawingml/2006/main">
               <a:ext uri="{FF2B5EF4-FFF2-40B4-BE49-F238E27FC236}">
-                <a16:creationId xmlns:a16="http://schemas.microsoft.com/office/drawing/2014/main" id="{EAAA0526-53B9-4BA3-A127-AA8BA400DB00}"/>
+                <a16:creationId xmlns:a16="http://schemas.microsoft.com/office/drawing/2014/main" id="{39E19019-4029-4FDD-83DB-45BE6A8AA235}"/>
               </a:ext>
             </a:extLst>
           </p:cNvPr>
@@ -5663,7 +5663,7 @@
           <p:cNvPr id="5" name="">
             <a:extLst xmlns:a="http://schemas.openxmlformats.org/drawingml/2006/main">
               <a:ext uri="{FF2B5EF4-FFF2-40B4-BE49-F238E27FC236}">
-                <a16:creationId xmlns:a16="http://schemas.microsoft.com/office/drawing/2014/main" id="{FE132A62-DD21-4FFC-8743-79159638614B}"/>
+                <a16:creationId xmlns:a16="http://schemas.microsoft.com/office/drawing/2014/main" id="{BBA7F8FD-CACE-49E4-8B88-D79188234052}"/>
               </a:ext>
             </a:extLst>
           </p:cNvPr>
@@ -5713,7 +5713,7 @@
           <p:cNvPr id="6" name="">
             <a:extLst xmlns:a="http://schemas.openxmlformats.org/drawingml/2006/main">
               <a:ext uri="{FF2B5EF4-FFF2-40B4-BE49-F238E27FC236}">
-                <a16:creationId xmlns:a16="http://schemas.microsoft.com/office/drawing/2014/main" id="{BB36981A-A68C-4586-AAEF-9CF7B7F4B144}"/>
+                <a16:creationId xmlns:a16="http://schemas.microsoft.com/office/drawing/2014/main" id="{6250A975-70BD-4718-9B41-53F00CE7054B}"/>
               </a:ext>
             </a:extLst>
           </p:cNvPr>
@@ -5763,7 +5763,7 @@
           <p:cNvPr id="7" name="">
             <a:extLst xmlns:a="http://schemas.openxmlformats.org/drawingml/2006/main">
               <a:ext uri="{FF2B5EF4-FFF2-40B4-BE49-F238E27FC236}">
-                <a16:creationId xmlns:a16="http://schemas.microsoft.com/office/drawing/2014/main" id="{269929D3-AB53-4563-86D5-B7644413C7DB}"/>
+                <a16:creationId xmlns:a16="http://schemas.microsoft.com/office/drawing/2014/main" id="{E6674305-1A35-4D97-B735-D68C3E57BC6A}"/>
               </a:ext>
             </a:extLst>
           </p:cNvPr>
@@ -5798,7 +5798,7 @@
           <p:cNvPr id="8" name="">
             <a:extLst xmlns:a="http://schemas.openxmlformats.org/drawingml/2006/main">
               <a:ext uri="{FF2B5EF4-FFF2-40B4-BE49-F238E27FC236}">
-                <a16:creationId xmlns:a16="http://schemas.microsoft.com/office/drawing/2014/main" id="{491950AC-178A-43AE-A64F-08F3103F63A9}"/>
+                <a16:creationId xmlns:a16="http://schemas.microsoft.com/office/drawing/2014/main" id="{9C12CB64-746C-412C-8C65-D999488C29AC}"/>
               </a:ext>
             </a:extLst>
           </p:cNvPr>
@@ -5838,7 +5838,7 @@
                   <a:srgbClr val="111827"/>
                 </a:solidFill>
               </a:rPr>
-              <a:t>Создать package</a:t>
+              <a:t>Создать пакет</a:t>
             </a:r>
           </a:p>
         </p:txBody>
@@ -5848,7 +5848,7 @@
           <p:cNvPr id="9" name="">
             <a:extLst xmlns:a="http://schemas.openxmlformats.org/drawingml/2006/main">
               <a:ext uri="{FF2B5EF4-FFF2-40B4-BE49-F238E27FC236}">
-                <a16:creationId xmlns:a16="http://schemas.microsoft.com/office/drawing/2014/main" id="{3CE9BB0D-71C7-4D40-98BC-1334ABEC8E59}"/>
+                <a16:creationId xmlns:a16="http://schemas.microsoft.com/office/drawing/2014/main" id="{72C1DECA-2363-495F-8649-002D001F10D3}"/>
               </a:ext>
             </a:extLst>
           </p:cNvPr>
@@ -5898,7 +5898,7 @@
           <p:cNvPr id="10" name="">
             <a:extLst xmlns:a="http://schemas.openxmlformats.org/drawingml/2006/main">
               <a:ext uri="{FF2B5EF4-FFF2-40B4-BE49-F238E27FC236}">
-                <a16:creationId xmlns:a16="http://schemas.microsoft.com/office/drawing/2014/main" id="{64549994-B740-4111-9426-2FFAD6ECA1CE}"/>
+                <a16:creationId xmlns:a16="http://schemas.microsoft.com/office/drawing/2014/main" id="{2AF47CCE-413E-4D50-8E7D-247CC422A24F}"/>
               </a:ext>
             </a:extLst>
           </p:cNvPr>
@@ -5931,7 +5931,7 @@
           <p:cNvPr id="11" name="">
             <a:extLst xmlns:a="http://schemas.openxmlformats.org/drawingml/2006/main">
               <a:ext uri="{FF2B5EF4-FFF2-40B4-BE49-F238E27FC236}">
-                <a16:creationId xmlns:a16="http://schemas.microsoft.com/office/drawing/2014/main" id="{4C1054C9-E8FF-46C5-B930-792F9E2ECDD9}"/>
+                <a16:creationId xmlns:a16="http://schemas.microsoft.com/office/drawing/2014/main" id="{F925FC4E-58FA-4F0C-B489-438F668A3E97}"/>
               </a:ext>
             </a:extLst>
           </p:cNvPr>
@@ -5981,7 +5981,7 @@
           <p:cNvPr id="12" name="">
             <a:extLst xmlns:a="http://schemas.openxmlformats.org/drawingml/2006/main">
               <a:ext uri="{FF2B5EF4-FFF2-40B4-BE49-F238E27FC236}">
-                <a16:creationId xmlns:a16="http://schemas.microsoft.com/office/drawing/2014/main" id="{BD41241B-3C4C-48E4-8202-8677CE699476}"/>
+                <a16:creationId xmlns:a16="http://schemas.microsoft.com/office/drawing/2014/main" id="{26755537-6C44-4779-B34B-16CB09332B20}"/>
               </a:ext>
             </a:extLst>
           </p:cNvPr>
@@ -6016,7 +6016,7 @@
           <p:cNvPr id="13" name="">
             <a:extLst xmlns:a="http://schemas.openxmlformats.org/drawingml/2006/main">
               <a:ext uri="{FF2B5EF4-FFF2-40B4-BE49-F238E27FC236}">
-                <a16:creationId xmlns:a16="http://schemas.microsoft.com/office/drawing/2014/main" id="{E8AAB9FA-03E8-49D2-8FDD-906111BF929A}"/>
+                <a16:creationId xmlns:a16="http://schemas.microsoft.com/office/drawing/2014/main" id="{AD700691-392F-4696-88B1-EB96E9564201}"/>
               </a:ext>
             </a:extLst>
           </p:cNvPr>
@@ -6066,7 +6066,7 @@
           <p:cNvPr id="14" name="">
             <a:extLst xmlns:a="http://schemas.openxmlformats.org/drawingml/2006/main">
               <a:ext uri="{FF2B5EF4-FFF2-40B4-BE49-F238E27FC236}">
-                <a16:creationId xmlns:a16="http://schemas.microsoft.com/office/drawing/2014/main" id="{7A9C839A-26AC-44BC-8400-AF19F094E788}"/>
+                <a16:creationId xmlns:a16="http://schemas.microsoft.com/office/drawing/2014/main" id="{3D9F1A9C-33D7-430A-B278-45E784BCC356}"/>
               </a:ext>
             </a:extLst>
           </p:cNvPr>
@@ -6106,7 +6106,7 @@
                   <a:srgbClr val="4B5563"/>
                 </a:solidFill>
               </a:rPr>
-              <a:t>структуру и traceability</a:t>
+              <a:t>структуру и связи</a:t>
             </a:r>
           </a:p>
         </p:txBody>
@@ -6116,7 +6116,7 @@
           <p:cNvPr id="15" name="">
             <a:extLst xmlns:a="http://schemas.openxmlformats.org/drawingml/2006/main">
               <a:ext uri="{FF2B5EF4-FFF2-40B4-BE49-F238E27FC236}">
-                <a16:creationId xmlns:a16="http://schemas.microsoft.com/office/drawing/2014/main" id="{58A3D8F7-3BB2-42F7-85E6-E79AD02D13C8}"/>
+                <a16:creationId xmlns:a16="http://schemas.microsoft.com/office/drawing/2014/main" id="{C48069B0-39FB-40B9-900B-5B2F8BF0A842}"/>
               </a:ext>
             </a:extLst>
           </p:cNvPr>
@@ -6149,7 +6149,7 @@
           <p:cNvPr id="16" name="">
             <a:extLst xmlns:a="http://schemas.openxmlformats.org/drawingml/2006/main">
               <a:ext uri="{FF2B5EF4-FFF2-40B4-BE49-F238E27FC236}">
-                <a16:creationId xmlns:a16="http://schemas.microsoft.com/office/drawing/2014/main" id="{9EDEC91D-18C7-4BA5-8CFC-A7B844C5C961}"/>
+                <a16:creationId xmlns:a16="http://schemas.microsoft.com/office/drawing/2014/main" id="{4A4BEFCB-3092-492C-AB08-806ADF250139}"/>
               </a:ext>
             </a:extLst>
           </p:cNvPr>
@@ -6199,7 +6199,7 @@
           <p:cNvPr id="17" name="">
             <a:extLst xmlns:a="http://schemas.openxmlformats.org/drawingml/2006/main">
               <a:ext uri="{FF2B5EF4-FFF2-40B4-BE49-F238E27FC236}">
-                <a16:creationId xmlns:a16="http://schemas.microsoft.com/office/drawing/2014/main" id="{4E4E4A0E-07D6-4766-989F-49BAE4AA4115}"/>
+                <a16:creationId xmlns:a16="http://schemas.microsoft.com/office/drawing/2014/main" id="{85664B70-B7B8-4C48-B843-9935D3CF9C55}"/>
               </a:ext>
             </a:extLst>
           </p:cNvPr>
@@ -6234,7 +6234,7 @@
           <p:cNvPr id="18" name="">
             <a:extLst xmlns:a="http://schemas.openxmlformats.org/drawingml/2006/main">
               <a:ext uri="{FF2B5EF4-FFF2-40B4-BE49-F238E27FC236}">
-                <a16:creationId xmlns:a16="http://schemas.microsoft.com/office/drawing/2014/main" id="{E93E2301-DEAA-4417-B8D6-D6CF2C4017A0}"/>
+                <a16:creationId xmlns:a16="http://schemas.microsoft.com/office/drawing/2014/main" id="{5B1B9259-DB36-44C2-B1BE-50223D100027}"/>
               </a:ext>
             </a:extLst>
           </p:cNvPr>
@@ -6274,7 +6274,7 @@
                   <a:srgbClr val="111827"/>
                 </a:solidFill>
               </a:rPr>
-              <a:t>Открыть Spec PR</a:t>
+              <a:t>Отдать на ревью</a:t>
             </a:r>
           </a:p>
         </p:txBody>
@@ -6284,7 +6284,7 @@
           <p:cNvPr id="19" name="">
             <a:extLst xmlns:a="http://schemas.openxmlformats.org/drawingml/2006/main">
               <a:ext uri="{FF2B5EF4-FFF2-40B4-BE49-F238E27FC236}">
-                <a16:creationId xmlns:a16="http://schemas.microsoft.com/office/drawing/2014/main" id="{A2309D2C-E618-4826-9FBA-9FB283D50F62}"/>
+                <a16:creationId xmlns:a16="http://schemas.microsoft.com/office/drawing/2014/main" id="{E13D11D7-FF33-4F99-A541-D7BFA0E17100}"/>
               </a:ext>
             </a:extLst>
           </p:cNvPr>
@@ -6324,7 +6324,7 @@
                   <a:srgbClr val="4B5563"/>
                 </a:solidFill>
               </a:rPr>
-              <a:t>на review</a:t>
+              <a:t>требования</a:t>
             </a:r>
           </a:p>
         </p:txBody>
@@ -6334,7 +6334,7 @@
           <p:cNvPr id="20" name="">
             <a:extLst xmlns:a="http://schemas.openxmlformats.org/drawingml/2006/main">
               <a:ext uri="{FF2B5EF4-FFF2-40B4-BE49-F238E27FC236}">
-                <a16:creationId xmlns:a16="http://schemas.microsoft.com/office/drawing/2014/main" id="{CB56619A-33BE-4B8C-871C-25FC5B2165F5}"/>
+                <a16:creationId xmlns:a16="http://schemas.microsoft.com/office/drawing/2014/main" id="{BA1598FF-861E-4CB5-826B-873B98D6A350}"/>
               </a:ext>
             </a:extLst>
           </p:cNvPr>
@@ -6367,7 +6367,7 @@
           <p:cNvPr id="21" name="">
             <a:extLst xmlns:a="http://schemas.openxmlformats.org/drawingml/2006/main">
               <a:ext uri="{FF2B5EF4-FFF2-40B4-BE49-F238E27FC236}">
-                <a16:creationId xmlns:a16="http://schemas.microsoft.com/office/drawing/2014/main" id="{8B79F7F3-2A23-439C-9A77-B7F02D230579}"/>
+                <a16:creationId xmlns:a16="http://schemas.microsoft.com/office/drawing/2014/main" id="{85F34C78-0000-497C-AEE0-F5A8F05A54AF}"/>
               </a:ext>
             </a:extLst>
           </p:cNvPr>
@@ -6417,7 +6417,7 @@
           <p:cNvPr id="22" name="">
             <a:extLst xmlns:a="http://schemas.openxmlformats.org/drawingml/2006/main">
               <a:ext uri="{FF2B5EF4-FFF2-40B4-BE49-F238E27FC236}">
-                <a16:creationId xmlns:a16="http://schemas.microsoft.com/office/drawing/2014/main" id="{B0E19EB6-EC80-4047-B55D-CD6D9BACE517}"/>
+                <a16:creationId xmlns:a16="http://schemas.microsoft.com/office/drawing/2014/main" id="{99D248EB-C456-4AC0-BB0E-F232AE3CF8A1}"/>
               </a:ext>
             </a:extLst>
           </p:cNvPr>
@@ -6452,7 +6452,7 @@
           <p:cNvPr id="23" name="">
             <a:extLst xmlns:a="http://schemas.openxmlformats.org/drawingml/2006/main">
               <a:ext uri="{FF2B5EF4-FFF2-40B4-BE49-F238E27FC236}">
-                <a16:creationId xmlns:a16="http://schemas.microsoft.com/office/drawing/2014/main" id="{E8B7786E-07A8-4512-AFFC-AD0F2661F49B}"/>
+                <a16:creationId xmlns:a16="http://schemas.microsoft.com/office/drawing/2014/main" id="{7498C780-9FBF-44F3-B4A8-D9E7D92B89A8}"/>
               </a:ext>
             </a:extLst>
           </p:cNvPr>
@@ -6492,7 +6492,7 @@
                   <a:srgbClr val="111827"/>
                 </a:solidFill>
               </a:rPr>
-              <a:t>Archive</a:t>
+              <a:t>Зафиксировать</a:t>
             </a:r>
           </a:p>
         </p:txBody>
@@ -6502,7 +6502,7 @@
           <p:cNvPr id="24" name="">
             <a:extLst xmlns:a="http://schemas.openxmlformats.org/drawingml/2006/main">
               <a:ext uri="{FF2B5EF4-FFF2-40B4-BE49-F238E27FC236}">
-                <a16:creationId xmlns:a16="http://schemas.microsoft.com/office/drawing/2014/main" id="{3651D1E6-5AA3-4104-80B6-C40EA4ED63C9}"/>
+                <a16:creationId xmlns:a16="http://schemas.microsoft.com/office/drawing/2014/main" id="{EEFA9166-66A0-46D2-8184-6CB77E4CB22F}"/>
               </a:ext>
             </a:extLst>
           </p:cNvPr>
@@ -6542,7 +6542,7 @@
                   <a:srgbClr val="4B5563"/>
                 </a:solidFill>
               </a:rPr>
-              <a:t>в living specs</a:t>
+              <a:t>в действующих требованиях</a:t>
             </a:r>
           </a:p>
         </p:txBody>
@@ -6552,7 +6552,7 @@
           <p:cNvPr id="25" name="">
             <a:extLst xmlns:a="http://schemas.openxmlformats.org/drawingml/2006/main">
               <a:ext uri="{FF2B5EF4-FFF2-40B4-BE49-F238E27FC236}">
-                <a16:creationId xmlns:a16="http://schemas.microsoft.com/office/drawing/2014/main" id="{00DF985B-4864-4223-9121-AB2D0069954D}"/>
+                <a16:creationId xmlns:a16="http://schemas.microsoft.com/office/drawing/2014/main" id="{789295A4-CC0C-488A-93BF-1130CFF9282B}"/>
               </a:ext>
             </a:extLst>
           </p:cNvPr>
@@ -6592,7 +6592,7 @@
                   <a:srgbClr val="111827"/>
                 </a:solidFill>
               </a:rPr>
-              <a:t>Результат: requirement -&gt; scenario -&gt; evidence видно без ручного расследования.</a:t>
+              <a:t>Результат: видно, какое требование чем проверено и подтверждено.</a:t>
             </a:r>
           </a:p>
         </p:txBody>
@@ -6600,7 +6600,7 @@
     </p:spTree>
     <p:extLst>
       <p:ext uri="{BB962C8B-B14F-4D97-AF65-F5344CB8AC3E}">
-        <p14:creationId xmlns:p14="http://schemas.microsoft.com/office/powerpoint/2010/main" val="72189519"/>
+        <p14:creationId xmlns:p14="http://schemas.microsoft.com/office/powerpoint/2010/main" val="1743889291"/>
       </p:ext>
     </p:extLst>
   </p:cSld>
@@ -6631,7 +6631,7 @@
           <p:cNvPr id="1" name="">
             <a:extLst xmlns:a="http://schemas.openxmlformats.org/drawingml/2006/main">
               <a:ext uri="{FF2B5EF4-FFF2-40B4-BE49-F238E27FC236}">
-                <a16:creationId xmlns:a16="http://schemas.microsoft.com/office/drawing/2014/main" id="{E074B61A-7395-441A-8A89-903CF3F087AC}"/>
+                <a16:creationId xmlns:a16="http://schemas.microsoft.com/office/drawing/2014/main" id="{0109325D-FB05-4D64-901C-B64CD55A5B6F}"/>
               </a:ext>
             </a:extLst>
           </p:cNvPr>
@@ -6671,7 +6671,7 @@
                   <a:srgbClr val="0F766E"/>
                 </a:solidFill>
               </a:rPr>
-              <a:t>Граница MVP</a:t>
+              <a:t>Граница первого запуска</a:t>
             </a:r>
           </a:p>
         </p:txBody>
@@ -6681,7 +6681,7 @@
           <p:cNvPr id="2" name="">
             <a:extLst xmlns:a="http://schemas.openxmlformats.org/drawingml/2006/main">
               <a:ext uri="{FF2B5EF4-FFF2-40B4-BE49-F238E27FC236}">
-                <a16:creationId xmlns:a16="http://schemas.microsoft.com/office/drawing/2014/main" id="{FAE51AC3-AE13-4489-A012-F76319DA3B46}"/>
+                <a16:creationId xmlns:a16="http://schemas.microsoft.com/office/drawing/2014/main" id="{7FC26C33-1550-4EDC-9EAF-EA8E867F949E}"/>
               </a:ext>
             </a:extLst>
           </p:cNvPr>
@@ -6721,7 +6721,7 @@
                   <a:srgbClr val="111827"/>
                 </a:solidFill>
               </a:rPr>
-              <a:t>Первый MVP намеренно узкий, чтобы успеть и не потерять качество</a:t>
+              <a:t>Первый результат намеренно узкий, чтобы успеть и не потерять качество</a:t>
             </a:r>
           </a:p>
         </p:txBody>
@@ -6731,7 +6731,7 @@
           <p:cNvPr id="3" name="">
             <a:extLst xmlns:a="http://schemas.openxmlformats.org/drawingml/2006/main">
               <a:ext uri="{FF2B5EF4-FFF2-40B4-BE49-F238E27FC236}">
-                <a16:creationId xmlns:a16="http://schemas.microsoft.com/office/drawing/2014/main" id="{2ADA2DFD-9E55-4817-A6C5-EE214B09C67C}"/>
+                <a16:creationId xmlns:a16="http://schemas.microsoft.com/office/drawing/2014/main" id="{5B97B49C-A854-4EA2-AB6F-65F6A45683E7}"/>
               </a:ext>
             </a:extLst>
           </p:cNvPr>
@@ -6764,7 +6764,7 @@
           <p:cNvPr id="4" name="">
             <a:extLst xmlns:a="http://schemas.openxmlformats.org/drawingml/2006/main">
               <a:ext uri="{FF2B5EF4-FFF2-40B4-BE49-F238E27FC236}">
-                <a16:creationId xmlns:a16="http://schemas.microsoft.com/office/drawing/2014/main" id="{D948D239-173D-40FD-8ED9-6AFE433BEB97}"/>
+                <a16:creationId xmlns:a16="http://schemas.microsoft.com/office/drawing/2014/main" id="{6A1345D8-0AE9-4AD8-9532-019BE36B6DCE}"/>
               </a:ext>
             </a:extLst>
           </p:cNvPr>
@@ -6814,7 +6814,7 @@
           <p:cNvPr id="5" name="">
             <a:extLst xmlns:a="http://schemas.openxmlformats.org/drawingml/2006/main">
               <a:ext uri="{FF2B5EF4-FFF2-40B4-BE49-F238E27FC236}">
-                <a16:creationId xmlns:a16="http://schemas.microsoft.com/office/drawing/2014/main" id="{A5619BC2-E2A3-45EA-9A2D-4CDBA8473AA5}"/>
+                <a16:creationId xmlns:a16="http://schemas.microsoft.com/office/drawing/2014/main" id="{6D6597B4-126E-451F-9424-4E358816AA96}"/>
               </a:ext>
             </a:extLst>
           </p:cNvPr>
@@ -6864,7 +6864,7 @@
           <p:cNvPr id="6" name="">
             <a:extLst xmlns:a="http://schemas.openxmlformats.org/drawingml/2006/main">
               <a:ext uri="{FF2B5EF4-FFF2-40B4-BE49-F238E27FC236}">
-                <a16:creationId xmlns:a16="http://schemas.microsoft.com/office/drawing/2014/main" id="{88E635B7-93AC-4D51-972C-34F136A8A9A2}"/>
+                <a16:creationId xmlns:a16="http://schemas.microsoft.com/office/drawing/2014/main" id="{2C7BC858-66E8-4BA7-8DF6-DC18AD077D52}"/>
               </a:ext>
             </a:extLst>
           </p:cNvPr>
@@ -6914,7 +6914,7 @@
           <p:cNvPr id="7" name="">
             <a:extLst xmlns:a="http://schemas.openxmlformats.org/drawingml/2006/main">
               <a:ext uri="{FF2B5EF4-FFF2-40B4-BE49-F238E27FC236}">
-                <a16:creationId xmlns:a16="http://schemas.microsoft.com/office/drawing/2014/main" id="{0A4787EB-A03E-4B00-8FD4-9E20765F4DB1}"/>
+                <a16:creationId xmlns:a16="http://schemas.microsoft.com/office/drawing/2014/main" id="{2801B36C-5395-40B7-B6DF-A4E5ACDFBDFF}"/>
               </a:ext>
             </a:extLst>
           </p:cNvPr>
@@ -6947,7 +6947,7 @@
           <p:cNvPr id="8" name="">
             <a:extLst xmlns:a="http://schemas.openxmlformats.org/drawingml/2006/main">
               <a:ext uri="{FF2B5EF4-FFF2-40B4-BE49-F238E27FC236}">
-                <a16:creationId xmlns:a16="http://schemas.microsoft.com/office/drawing/2014/main" id="{42E5774D-C98D-4AE6-8265-8EBE9C102D97}"/>
+                <a16:creationId xmlns:a16="http://schemas.microsoft.com/office/drawing/2014/main" id="{92D44172-CC8F-40C4-9FF1-B2F80B2AFEDE}"/>
               </a:ext>
             </a:extLst>
           </p:cNvPr>
@@ -6987,7 +6987,7 @@
                   <a:srgbClr val="111827"/>
                 </a:solidFill>
               </a:rPr>
-              <a:t>thin change package</a:t>
+              <a:t>легкий пакет изменения</a:t>
             </a:r>
           </a:p>
         </p:txBody>
@@ -6997,7 +6997,7 @@
           <p:cNvPr id="9" name="">
             <a:extLst xmlns:a="http://schemas.openxmlformats.org/drawingml/2006/main">
               <a:ext uri="{FF2B5EF4-FFF2-40B4-BE49-F238E27FC236}">
-                <a16:creationId xmlns:a16="http://schemas.microsoft.com/office/drawing/2014/main" id="{E980C090-2560-4106-A83A-323FB158096F}"/>
+                <a16:creationId xmlns:a16="http://schemas.microsoft.com/office/drawing/2014/main" id="{FE522948-1442-4424-8FA7-34D06E2FB78D}"/>
               </a:ext>
             </a:extLst>
           </p:cNvPr>
@@ -7030,7 +7030,7 @@
           <p:cNvPr id="10" name="">
             <a:extLst xmlns:a="http://schemas.openxmlformats.org/drawingml/2006/main">
               <a:ext uri="{FF2B5EF4-FFF2-40B4-BE49-F238E27FC236}">
-                <a16:creationId xmlns:a16="http://schemas.microsoft.com/office/drawing/2014/main" id="{2558710C-09FF-4B6F-801E-D4B00DE61671}"/>
+                <a16:creationId xmlns:a16="http://schemas.microsoft.com/office/drawing/2014/main" id="{367BB0A4-A050-4245-BF84-F7F6D116FFAE}"/>
               </a:ext>
             </a:extLst>
           </p:cNvPr>
@@ -7070,7 +7070,7 @@
                   <a:srgbClr val="111827"/>
                 </a:solidFill>
               </a:rPr>
-              <a:t>локальная validation gate</a:t>
+              <a:t>локальная проверка правил</a:t>
             </a:r>
           </a:p>
         </p:txBody>
@@ -7080,7 +7080,7 @@
           <p:cNvPr id="11" name="">
             <a:extLst xmlns:a="http://schemas.openxmlformats.org/drawingml/2006/main">
               <a:ext uri="{FF2B5EF4-FFF2-40B4-BE49-F238E27FC236}">
-                <a16:creationId xmlns:a16="http://schemas.microsoft.com/office/drawing/2014/main" id="{7E0FBBAA-AC03-45AD-9531-B6E0278F0DF8}"/>
+                <a16:creationId xmlns:a16="http://schemas.microsoft.com/office/drawing/2014/main" id="{B9F6BC14-C6E0-40F0-A107-1D8864FBF540}"/>
               </a:ext>
             </a:extLst>
           </p:cNvPr>
@@ -7113,7 +7113,7 @@
           <p:cNvPr id="12" name="">
             <a:extLst xmlns:a="http://schemas.openxmlformats.org/drawingml/2006/main">
               <a:ext uri="{FF2B5EF4-FFF2-40B4-BE49-F238E27FC236}">
-                <a16:creationId xmlns:a16="http://schemas.microsoft.com/office/drawing/2014/main" id="{FC288D34-F95D-426B-9EA5-AD1DF1BA23B1}"/>
+                <a16:creationId xmlns:a16="http://schemas.microsoft.com/office/drawing/2014/main" id="{90051AC8-D102-4C41-9E2D-4AD49558D41F}"/>
               </a:ext>
             </a:extLst>
           </p:cNvPr>
@@ -7153,7 +7153,7 @@
                   <a:srgbClr val="111827"/>
                 </a:solidFill>
               </a:rPr>
-              <a:t>Spec PR и archive flow</a:t>
+              <a:t>ревью и фиксация требований</a:t>
             </a:r>
           </a:p>
         </p:txBody>
@@ -7163,7 +7163,7 @@
           <p:cNvPr id="13" name="">
             <a:extLst xmlns:a="http://schemas.openxmlformats.org/drawingml/2006/main">
               <a:ext uri="{FF2B5EF4-FFF2-40B4-BE49-F238E27FC236}">
-                <a16:creationId xmlns:a16="http://schemas.microsoft.com/office/drawing/2014/main" id="{8BB56814-F53C-4970-9965-8D4724E1D2FF}"/>
+                <a16:creationId xmlns:a16="http://schemas.microsoft.com/office/drawing/2014/main" id="{52D0F831-01C6-4E82-96FD-C3657DBA5513}"/>
               </a:ext>
             </a:extLst>
           </p:cNvPr>
@@ -7196,7 +7196,7 @@
           <p:cNvPr id="14" name="">
             <a:extLst xmlns:a="http://schemas.openxmlformats.org/drawingml/2006/main">
               <a:ext uri="{FF2B5EF4-FFF2-40B4-BE49-F238E27FC236}">
-                <a16:creationId xmlns:a16="http://schemas.microsoft.com/office/drawing/2014/main" id="{A061A8E2-10E3-4365-8D45-3EF1B488D99C}"/>
+                <a16:creationId xmlns:a16="http://schemas.microsoft.com/office/drawing/2014/main" id="{AC8282E8-C58D-4B18-96F2-569DFF0ABAD5}"/>
               </a:ext>
             </a:extLst>
           </p:cNvPr>
@@ -7236,7 +7236,7 @@
                   <a:srgbClr val="111827"/>
                 </a:solidFill>
               </a:rPr>
-              <a:t>basic traceability.yaml</a:t>
+              <a:t>базовая карта связей</a:t>
             </a:r>
           </a:p>
         </p:txBody>
@@ -7246,7 +7246,7 @@
           <p:cNvPr id="15" name="">
             <a:extLst xmlns:a="http://schemas.openxmlformats.org/drawingml/2006/main">
               <a:ext uri="{FF2B5EF4-FFF2-40B4-BE49-F238E27FC236}">
-                <a16:creationId xmlns:a16="http://schemas.microsoft.com/office/drawing/2014/main" id="{2525821E-8F12-44C7-ACC0-E1E6EEF8DC50}"/>
+                <a16:creationId xmlns:a16="http://schemas.microsoft.com/office/drawing/2014/main" id="{A591C153-CD88-4978-93C0-9ECD865E8285}"/>
               </a:ext>
             </a:extLst>
           </p:cNvPr>
@@ -7258,7 +7258,7 @@
         <p:spPr>
           <a:xfrm xmlns:a="http://schemas.openxmlformats.org/drawingml/2006/main">
             <a:off x="6858000" y="2400300"/>
-            <a:ext cx="2857500" cy="342900"/>
+            <a:ext cx="3429000" cy="342900"/>
           </a:xfrm>
           <a:prstGeom xmlns:a="http://schemas.openxmlformats.org/drawingml/2006/main" prst="rect">
             <a:avLst/>
@@ -7286,7 +7286,7 @@
                   <a:srgbClr val="B45309"/>
                 </a:solidFill>
               </a:rPr>
-              <a:t>После MVP</a:t>
+              <a:t>После первого запуска</a:t>
             </a:r>
           </a:p>
         </p:txBody>
@@ -7296,7 +7296,7 @@
           <p:cNvPr id="16" name="">
             <a:extLst xmlns:a="http://schemas.openxmlformats.org/drawingml/2006/main">
               <a:ext uri="{FF2B5EF4-FFF2-40B4-BE49-F238E27FC236}">
-                <a16:creationId xmlns:a16="http://schemas.microsoft.com/office/drawing/2014/main" id="{2101AB73-2E91-43B4-98D1-BE0C1CD880D4}"/>
+                <a16:creationId xmlns:a16="http://schemas.microsoft.com/office/drawing/2014/main" id="{F3F3CD51-AB37-4465-98AD-486F8BEB761F}"/>
               </a:ext>
             </a:extLst>
           </p:cNvPr>
@@ -7329,7 +7329,7 @@
           <p:cNvPr id="17" name="">
             <a:extLst xmlns:a="http://schemas.openxmlformats.org/drawingml/2006/main">
               <a:ext uri="{FF2B5EF4-FFF2-40B4-BE49-F238E27FC236}">
-                <a16:creationId xmlns:a16="http://schemas.microsoft.com/office/drawing/2014/main" id="{A1B280B5-4ED7-42B7-9C7E-CE518E60737E}"/>
+                <a16:creationId xmlns:a16="http://schemas.microsoft.com/office/drawing/2014/main" id="{59FF9BCC-25B4-4F7B-902E-58024D31ADF5}"/>
               </a:ext>
             </a:extLst>
           </p:cNvPr>
@@ -7369,7 +7369,7 @@
                   <a:srgbClr val="111827"/>
                 </a:solidFill>
               </a:rPr>
-              <a:t>Confluence publication</a:t>
+              <a:t>публикация в Confluence</a:t>
             </a:r>
           </a:p>
         </p:txBody>
@@ -7379,7 +7379,7 @@
           <p:cNvPr id="18" name="">
             <a:extLst xmlns:a="http://schemas.openxmlformats.org/drawingml/2006/main">
               <a:ext uri="{FF2B5EF4-FFF2-40B4-BE49-F238E27FC236}">
-                <a16:creationId xmlns:a16="http://schemas.microsoft.com/office/drawing/2014/main" id="{F701871B-3B78-440C-8B60-D1FEC863C0EC}"/>
+                <a16:creationId xmlns:a16="http://schemas.microsoft.com/office/drawing/2014/main" id="{E5D0CC88-475E-4620-8CB3-ACDCF0616C6C}"/>
               </a:ext>
             </a:extLst>
           </p:cNvPr>
@@ -7412,7 +7412,7 @@
           <p:cNvPr id="19" name="">
             <a:extLst xmlns:a="http://schemas.openxmlformats.org/drawingml/2006/main">
               <a:ext uri="{FF2B5EF4-FFF2-40B4-BE49-F238E27FC236}">
-                <a16:creationId xmlns:a16="http://schemas.microsoft.com/office/drawing/2014/main" id="{1DCAA63D-CCFF-452D-BD4C-D106253A8279}"/>
+                <a16:creationId xmlns:a16="http://schemas.microsoft.com/office/drawing/2014/main" id="{02626917-AAF4-4757-A502-3AFC89C419D6}"/>
               </a:ext>
             </a:extLst>
           </p:cNvPr>
@@ -7452,7 +7452,7 @@
                   <a:srgbClr val="111827"/>
                 </a:solidFill>
               </a:rPr>
-              <a:t>Jira task automation</a:t>
+              <a:t>автоматизация задач в Jira</a:t>
             </a:r>
           </a:p>
         </p:txBody>
@@ -7462,7 +7462,7 @@
           <p:cNvPr id="20" name="">
             <a:extLst xmlns:a="http://schemas.openxmlformats.org/drawingml/2006/main">
               <a:ext uri="{FF2B5EF4-FFF2-40B4-BE49-F238E27FC236}">
-                <a16:creationId xmlns:a16="http://schemas.microsoft.com/office/drawing/2014/main" id="{8499C992-B665-4FDA-86F6-DF90E90E9B20}"/>
+                <a16:creationId xmlns:a16="http://schemas.microsoft.com/office/drawing/2014/main" id="{52008247-96E0-4D25-98E7-462F5B0F9714}"/>
               </a:ext>
             </a:extLst>
           </p:cNvPr>
@@ -7495,7 +7495,7 @@
           <p:cNvPr id="21" name="">
             <a:extLst xmlns:a="http://schemas.openxmlformats.org/drawingml/2006/main">
               <a:ext uri="{FF2B5EF4-FFF2-40B4-BE49-F238E27FC236}">
-                <a16:creationId xmlns:a16="http://schemas.microsoft.com/office/drawing/2014/main" id="{59EBC3C1-750D-45D6-8BF8-FE2A83E0CAB8}"/>
+                <a16:creationId xmlns:a16="http://schemas.microsoft.com/office/drawing/2014/main" id="{DCD438B5-5270-49D6-976B-F98EB259F26C}"/>
               </a:ext>
             </a:extLst>
           </p:cNvPr>
@@ -7535,7 +7535,7 @@
                   <a:srgbClr val="111827"/>
                 </a:solidFill>
               </a:rPr>
-              <a:t>QA/AT proposal generation</a:t>
+              <a:t>помощь для тестов и автотестов</a:t>
             </a:r>
           </a:p>
         </p:txBody>
@@ -7545,7 +7545,7 @@
           <p:cNvPr id="22" name="">
             <a:extLst xmlns:a="http://schemas.openxmlformats.org/drawingml/2006/main">
               <a:ext uri="{FF2B5EF4-FFF2-40B4-BE49-F238E27FC236}">
-                <a16:creationId xmlns:a16="http://schemas.microsoft.com/office/drawing/2014/main" id="{3FDE1C0B-C1F2-4386-A8CD-E552D93B8A61}"/>
+                <a16:creationId xmlns:a16="http://schemas.microsoft.com/office/drawing/2014/main" id="{F0486BDE-ECC4-44E0-A6F9-B6BEAD8DEBBC}"/>
               </a:ext>
             </a:extLst>
           </p:cNvPr>
@@ -7578,7 +7578,7 @@
           <p:cNvPr id="23" name="">
             <a:extLst xmlns:a="http://schemas.openxmlformats.org/drawingml/2006/main">
               <a:ext uri="{FF2B5EF4-FFF2-40B4-BE49-F238E27FC236}">
-                <a16:creationId xmlns:a16="http://schemas.microsoft.com/office/drawing/2014/main" id="{BE416AB3-26F8-40D8-A963-14778E110436}"/>
+                <a16:creationId xmlns:a16="http://schemas.microsoft.com/office/drawing/2014/main" id="{3EB18D68-C424-46BF-B41F-63224911E927}"/>
               </a:ext>
             </a:extLst>
           </p:cNvPr>
@@ -7618,7 +7618,7 @@
                   <a:srgbClr val="111827"/>
                 </a:solidFill>
               </a:rPr>
-              <a:t>role inboxes, deploy, Zephyr</a:t>
+              <a:t>личные рабочие списки, выкладка, Zephyr</a:t>
             </a:r>
           </a:p>
         </p:txBody>
@@ -7628,7 +7628,7 @@
           <p:cNvPr id="24" name="">
             <a:extLst xmlns:a="http://schemas.openxmlformats.org/drawingml/2006/main">
               <a:ext uri="{FF2B5EF4-FFF2-40B4-BE49-F238E27FC236}">
-                <a16:creationId xmlns:a16="http://schemas.microsoft.com/office/drawing/2014/main" id="{CC463CDC-484E-4438-9C52-1D5D1E160F3B}"/>
+                <a16:creationId xmlns:a16="http://schemas.microsoft.com/office/drawing/2014/main" id="{E68B6B72-4950-4126-B345-C6964235F379}"/>
               </a:ext>
             </a:extLst>
           </p:cNvPr>
@@ -7653,7 +7653,7 @@
     </p:spTree>
     <p:extLst>
       <p:ext uri="{BB962C8B-B14F-4D97-AF65-F5344CB8AC3E}">
-        <p14:creationId xmlns:p14="http://schemas.microsoft.com/office/powerpoint/2010/main" val="1837129830"/>
+        <p14:creationId xmlns:p14="http://schemas.microsoft.com/office/powerpoint/2010/main" val="786774718"/>
       </p:ext>
     </p:extLst>
   </p:cSld>
@@ -7684,7 +7684,7 @@
           <p:cNvPr id="1" name="">
             <a:extLst xmlns:a="http://schemas.openxmlformats.org/drawingml/2006/main">
               <a:ext uri="{FF2B5EF4-FFF2-40B4-BE49-F238E27FC236}">
-                <a16:creationId xmlns:a16="http://schemas.microsoft.com/office/drawing/2014/main" id="{302FECB9-884B-41D3-90A6-EA8D13B92864}"/>
+                <a16:creationId xmlns:a16="http://schemas.microsoft.com/office/drawing/2014/main" id="{8D5F7796-695E-4791-869E-93FE4BBB7294}"/>
               </a:ext>
             </a:extLst>
           </p:cNvPr>
@@ -7734,7 +7734,7 @@
           <p:cNvPr id="2" name="">
             <a:extLst xmlns:a="http://schemas.openxmlformats.org/drawingml/2006/main">
               <a:ext uri="{FF2B5EF4-FFF2-40B4-BE49-F238E27FC236}">
-                <a16:creationId xmlns:a16="http://schemas.microsoft.com/office/drawing/2014/main" id="{D8886DF8-0058-4180-AB28-D9685FB5E164}"/>
+                <a16:creationId xmlns:a16="http://schemas.microsoft.com/office/drawing/2014/main" id="{7D7E88EF-70BE-4118-ABEB-8EF40E48C3ED}"/>
               </a:ext>
             </a:extLst>
           </p:cNvPr>
@@ -7774,7 +7774,7 @@
                   <a:srgbClr val="111827"/>
                 </a:solidFill>
               </a:rPr>
-              <a:t>План MVP укладывается в 1,5 месяца, если держать scope узким</a:t>
+              <a:t>План укладывается в 1,5 месяца, если держать объем работ узким</a:t>
             </a:r>
           </a:p>
         </p:txBody>
@@ -7784,7 +7784,7 @@
           <p:cNvPr id="3" name="">
             <a:extLst xmlns:a="http://schemas.openxmlformats.org/drawingml/2006/main">
               <a:ext uri="{FF2B5EF4-FFF2-40B4-BE49-F238E27FC236}">
-                <a16:creationId xmlns:a16="http://schemas.microsoft.com/office/drawing/2014/main" id="{C9E31F94-A347-4BB8-88C6-13F4AA1B7AE6}"/>
+                <a16:creationId xmlns:a16="http://schemas.microsoft.com/office/drawing/2014/main" id="{19F6A5D0-6863-403A-9458-C110220905BC}"/>
               </a:ext>
             </a:extLst>
           </p:cNvPr>
@@ -7817,7 +7817,7 @@
           <p:cNvPr id="4" name="">
             <a:extLst xmlns:a="http://schemas.openxmlformats.org/drawingml/2006/main">
               <a:ext uri="{FF2B5EF4-FFF2-40B4-BE49-F238E27FC236}">
-                <a16:creationId xmlns:a16="http://schemas.microsoft.com/office/drawing/2014/main" id="{C10A41E7-9BC1-4E24-89B0-DA498995609C}"/>
+                <a16:creationId xmlns:a16="http://schemas.microsoft.com/office/drawing/2014/main" id="{FAB41B55-0204-4B7A-9434-93DFA8E7AE18}"/>
               </a:ext>
             </a:extLst>
           </p:cNvPr>
@@ -7867,7 +7867,7 @@
           <p:cNvPr id="5" name="">
             <a:extLst xmlns:a="http://schemas.openxmlformats.org/drawingml/2006/main">
               <a:ext uri="{FF2B5EF4-FFF2-40B4-BE49-F238E27FC236}">
-                <a16:creationId xmlns:a16="http://schemas.microsoft.com/office/drawing/2014/main" id="{0F5677D2-18A5-4E61-8713-EE3F2B92EB71}"/>
+                <a16:creationId xmlns:a16="http://schemas.microsoft.com/office/drawing/2014/main" id="{4195F714-8FB6-4CA5-A074-BE6759F5BEA3}"/>
               </a:ext>
             </a:extLst>
           </p:cNvPr>
@@ -7917,23 +7917,23 @@
           <p:cNvPr id="6" name="">
             <a:extLst xmlns:a="http://schemas.openxmlformats.org/drawingml/2006/main">
               <a:ext uri="{FF2B5EF4-FFF2-40B4-BE49-F238E27FC236}">
-                <a16:creationId xmlns:a16="http://schemas.microsoft.com/office/drawing/2014/main" id="{76E2456C-E34F-4D42-906B-EE76D1A4047E}"/>
-              </a:ext>
-            </a:extLst>
-          </p:cNvPr>
-          <p:cNvSpPr>
-            <a:spLocks xmlns:a="http://schemas.openxmlformats.org/drawingml/2006/main" noGrp="1"/>
-          </p:cNvSpPr>
-          <p:nvPr/>
-        </p:nvSpPr>
-        <p:spPr>
-          <a:xfrm xmlns:a="http://schemas.openxmlformats.org/drawingml/2006/main">
-            <a:off x="647700" y="2857500"/>
-            <a:ext cx="1828800" cy="1543050"/>
+                <a16:creationId xmlns:a16="http://schemas.microsoft.com/office/drawing/2014/main" id="{84865209-4B78-4163-AE9D-6679D0E2A4F9}"/>
+              </a:ext>
+            </a:extLst>
+          </p:cNvPr>
+          <p:cNvSpPr>
+            <a:spLocks xmlns:a="http://schemas.openxmlformats.org/drawingml/2006/main" noGrp="1"/>
+          </p:cNvSpPr>
+          <p:nvPr/>
+        </p:nvSpPr>
+        <p:spPr>
+          <a:xfrm xmlns:a="http://schemas.openxmlformats.org/drawingml/2006/main">
+            <a:off x="647700" y="2724150"/>
+            <a:ext cx="1828800" cy="1790700"/>
           </a:xfrm>
           <a:prstGeom xmlns:a="http://schemas.openxmlformats.org/drawingml/2006/main" prst="roundRect">
             <a:avLst>
-              <a:gd name="adj" fmla="val 1235"/>
+              <a:gd name="adj" fmla="val 1064"/>
             </a:avLst>
           </a:prstGeom>
           <a:solidFill xmlns:a="http://schemas.openxmlformats.org/drawingml/2006/main">
@@ -7952,18 +7952,18 @@
           <p:cNvPr id="7" name="">
             <a:extLst xmlns:a="http://schemas.openxmlformats.org/drawingml/2006/main">
               <a:ext uri="{FF2B5EF4-FFF2-40B4-BE49-F238E27FC236}">
-                <a16:creationId xmlns:a16="http://schemas.microsoft.com/office/drawing/2014/main" id="{26676864-CFF6-4F93-8D54-A4679EBDB90A}"/>
-              </a:ext>
-            </a:extLst>
-          </p:cNvPr>
-          <p:cNvSpPr>
-            <a:spLocks xmlns:a="http://schemas.openxmlformats.org/drawingml/2006/main" noGrp="1"/>
-          </p:cNvSpPr>
-          <p:nvPr/>
-        </p:nvSpPr>
-        <p:spPr>
-          <a:xfrm xmlns:a="http://schemas.openxmlformats.org/drawingml/2006/main">
-            <a:off x="819150" y="3067050"/>
+                <a16:creationId xmlns:a16="http://schemas.microsoft.com/office/drawing/2014/main" id="{561CC773-B279-493C-9123-574FC2FC1DA1}"/>
+              </a:ext>
+            </a:extLst>
+          </p:cNvPr>
+          <p:cNvSpPr>
+            <a:spLocks xmlns:a="http://schemas.openxmlformats.org/drawingml/2006/main" noGrp="1"/>
+          </p:cNvSpPr>
+          <p:nvPr/>
+        </p:nvSpPr>
+        <p:spPr>
+          <a:xfrm xmlns:a="http://schemas.openxmlformats.org/drawingml/2006/main">
+            <a:off x="819150" y="2952750"/>
             <a:ext cx="1485900" cy="266700"/>
           </a:xfrm>
           <a:prstGeom xmlns:a="http://schemas.openxmlformats.org/drawingml/2006/main" prst="rect">
@@ -7980,19 +7980,19 @@
           <a:lstStyle xmlns:a="http://schemas.openxmlformats.org/drawingml/2006/main"/>
           <a:p xmlns:a="http://schemas.openxmlformats.org/drawingml/2006/main">
             <a:pPr>
-              <a:defRPr sz="1500" b="1">
-                <a:solidFill>
-                  <a:srgbClr val="111827"/>
-                </a:solidFill>
-              </a:defRPr>
-            </a:pPr>
-            <a:r>
-              <a:rPr sz="1500" b="1">
-                <a:solidFill>
-                  <a:srgbClr val="111827"/>
-                </a:solidFill>
-              </a:rPr>
-              <a:t>Week 1</a:t>
+              <a:defRPr sz="1425" b="1">
+                <a:solidFill>
+                  <a:srgbClr val="111827"/>
+                </a:solidFill>
+              </a:defRPr>
+            </a:pPr>
+            <a:r>
+              <a:rPr sz="1425" b="1">
+                <a:solidFill>
+                  <a:srgbClr val="111827"/>
+                </a:solidFill>
+              </a:rPr>
+              <a:t>Неделя 1</a:t>
             </a:r>
           </a:p>
         </p:txBody>
@@ -8002,19 +8002,19 @@
           <p:cNvPr id="8" name="">
             <a:extLst xmlns:a="http://schemas.openxmlformats.org/drawingml/2006/main">
               <a:ext uri="{FF2B5EF4-FFF2-40B4-BE49-F238E27FC236}">
-                <a16:creationId xmlns:a16="http://schemas.microsoft.com/office/drawing/2014/main" id="{8F5552AA-6B90-4CD5-B5EA-82C16C96EFDB}"/>
-              </a:ext>
-            </a:extLst>
-          </p:cNvPr>
-          <p:cNvSpPr>
-            <a:spLocks xmlns:a="http://schemas.openxmlformats.org/drawingml/2006/main" noGrp="1"/>
-          </p:cNvSpPr>
-          <p:nvPr/>
-        </p:nvSpPr>
-        <p:spPr>
-          <a:xfrm xmlns:a="http://schemas.openxmlformats.org/drawingml/2006/main">
-            <a:off x="819150" y="3448050"/>
-            <a:ext cx="1485900" cy="514350"/>
+                <a16:creationId xmlns:a16="http://schemas.microsoft.com/office/drawing/2014/main" id="{9EE58169-FCAB-47FA-8850-822EFDCC7B00}"/>
+              </a:ext>
+            </a:extLst>
+          </p:cNvPr>
+          <p:cNvSpPr>
+            <a:spLocks xmlns:a="http://schemas.openxmlformats.org/drawingml/2006/main" noGrp="1"/>
+          </p:cNvSpPr>
+          <p:nvPr/>
+        </p:nvSpPr>
+        <p:spPr>
+          <a:xfrm xmlns:a="http://schemas.openxmlformats.org/drawingml/2006/main">
+            <a:off x="819150" y="3333750"/>
+            <a:ext cx="1485900" cy="533400"/>
           </a:xfrm>
           <a:prstGeom xmlns:a="http://schemas.openxmlformats.org/drawingml/2006/main" prst="rect">
             <a:avLst/>
@@ -8030,19 +8030,19 @@
           <a:lstStyle xmlns:a="http://schemas.openxmlformats.org/drawingml/2006/main"/>
           <a:p xmlns:a="http://schemas.openxmlformats.org/drawingml/2006/main">
             <a:pPr>
-              <a:defRPr sz="1500" b="1">
-                <a:solidFill>
-                  <a:srgbClr val="111827"/>
-                </a:solidFill>
-              </a:defRPr>
-            </a:pPr>
-            <a:r>
-              <a:rPr sz="1500" b="1">
-                <a:solidFill>
-                  <a:srgbClr val="111827"/>
-                </a:solidFill>
-              </a:rPr>
-              <a:t>Requirements sync</a:t>
+              <a:defRPr sz="1425" b="1">
+                <a:solidFill>
+                  <a:srgbClr val="111827"/>
+                </a:solidFill>
+              </a:defRPr>
+            </a:pPr>
+            <a:r>
+              <a:rPr sz="1425" b="1">
+                <a:solidFill>
+                  <a:srgbClr val="111827"/>
+                </a:solidFill>
+              </a:rPr>
+              <a:t>Сверка требований</a:t>
             </a:r>
           </a:p>
         </p:txBody>
@@ -8052,19 +8052,19 @@
           <p:cNvPr id="9" name="">
             <a:extLst xmlns:a="http://schemas.openxmlformats.org/drawingml/2006/main">
               <a:ext uri="{FF2B5EF4-FFF2-40B4-BE49-F238E27FC236}">
-                <a16:creationId xmlns:a16="http://schemas.microsoft.com/office/drawing/2014/main" id="{0E1E3632-B43A-4E34-AB55-26DF3E7D9998}"/>
-              </a:ext>
-            </a:extLst>
-          </p:cNvPr>
-          <p:cNvSpPr>
-            <a:spLocks xmlns:a="http://schemas.openxmlformats.org/drawingml/2006/main" noGrp="1"/>
-          </p:cNvSpPr>
-          <p:nvPr/>
-        </p:nvSpPr>
-        <p:spPr>
-          <a:xfrm xmlns:a="http://schemas.openxmlformats.org/drawingml/2006/main">
-            <a:off x="819150" y="4000500"/>
-            <a:ext cx="1485900" cy="323850"/>
+                <a16:creationId xmlns:a16="http://schemas.microsoft.com/office/drawing/2014/main" id="{1CF65EB8-BE8E-476D-9B35-94B1FE5DFB6E}"/>
+              </a:ext>
+            </a:extLst>
+          </p:cNvPr>
+          <p:cNvSpPr>
+            <a:spLocks xmlns:a="http://schemas.openxmlformats.org/drawingml/2006/main" noGrp="1"/>
+          </p:cNvSpPr>
+          <p:nvPr/>
+        </p:nvSpPr>
+        <p:spPr>
+          <a:xfrm xmlns:a="http://schemas.openxmlformats.org/drawingml/2006/main">
+            <a:off x="819150" y="3962400"/>
+            <a:ext cx="1485900" cy="438150"/>
           </a:xfrm>
           <a:prstGeom xmlns:a="http://schemas.openxmlformats.org/drawingml/2006/main" prst="rect">
             <a:avLst/>
@@ -8080,19 +8080,19 @@
           <a:lstStyle xmlns:a="http://schemas.openxmlformats.org/drawingml/2006/main"/>
           <a:p xmlns:a="http://schemas.openxmlformats.org/drawingml/2006/main">
             <a:pPr>
-              <a:defRPr sz="1125">
+              <a:defRPr sz="1050">
                 <a:solidFill>
                   <a:srgbClr val="4B5563"/>
                 </a:solidFill>
               </a:defRPr>
             </a:pPr>
             <a:r>
-              <a:rPr sz="1125">
+              <a:rPr sz="1050">
                 <a:solidFill>
                   <a:srgbClr val="4B5563"/>
                 </a:solidFill>
               </a:rPr>
-              <a:t>закрыть открытые решения Phase 1</a:t>
+              <a:t>закрыть открытые решения первой фазы</a:t>
             </a:r>
           </a:p>
         </p:txBody>
@@ -8102,23 +8102,23 @@
           <p:cNvPr id="10" name="">
             <a:extLst xmlns:a="http://schemas.openxmlformats.org/drawingml/2006/main">
               <a:ext uri="{FF2B5EF4-FFF2-40B4-BE49-F238E27FC236}">
-                <a16:creationId xmlns:a16="http://schemas.microsoft.com/office/drawing/2014/main" id="{06F341AB-FC83-48C7-8BE3-B6FF4FD522C8}"/>
-              </a:ext>
-            </a:extLst>
-          </p:cNvPr>
-          <p:cNvSpPr>
-            <a:spLocks xmlns:a="http://schemas.openxmlformats.org/drawingml/2006/main" noGrp="1"/>
-          </p:cNvSpPr>
-          <p:nvPr/>
-        </p:nvSpPr>
-        <p:spPr>
-          <a:xfrm xmlns:a="http://schemas.openxmlformats.org/drawingml/2006/main">
-            <a:off x="2914650" y="2857500"/>
-            <a:ext cx="1828800" cy="1543050"/>
+                <a16:creationId xmlns:a16="http://schemas.microsoft.com/office/drawing/2014/main" id="{09013CBD-BD9E-4AE5-8CE3-E02A97B97D01}"/>
+              </a:ext>
+            </a:extLst>
+          </p:cNvPr>
+          <p:cNvSpPr>
+            <a:spLocks xmlns:a="http://schemas.openxmlformats.org/drawingml/2006/main" noGrp="1"/>
+          </p:cNvSpPr>
+          <p:nvPr/>
+        </p:nvSpPr>
+        <p:spPr>
+          <a:xfrm xmlns:a="http://schemas.openxmlformats.org/drawingml/2006/main">
+            <a:off x="2914650" y="2724150"/>
+            <a:ext cx="1828800" cy="1790700"/>
           </a:xfrm>
           <a:prstGeom xmlns:a="http://schemas.openxmlformats.org/drawingml/2006/main" prst="roundRect">
             <a:avLst>
-              <a:gd name="adj" fmla="val 1235"/>
+              <a:gd name="adj" fmla="val 1064"/>
             </a:avLst>
           </a:prstGeom>
           <a:solidFill xmlns:a="http://schemas.openxmlformats.org/drawingml/2006/main">
@@ -8137,18 +8137,18 @@
           <p:cNvPr id="11" name="">
             <a:extLst xmlns:a="http://schemas.openxmlformats.org/drawingml/2006/main">
               <a:ext uri="{FF2B5EF4-FFF2-40B4-BE49-F238E27FC236}">
-                <a16:creationId xmlns:a16="http://schemas.microsoft.com/office/drawing/2014/main" id="{11262D55-4340-4EBE-AB2B-1CE11B2FBD61}"/>
-              </a:ext>
-            </a:extLst>
-          </p:cNvPr>
-          <p:cNvSpPr>
-            <a:spLocks xmlns:a="http://schemas.openxmlformats.org/drawingml/2006/main" noGrp="1"/>
-          </p:cNvSpPr>
-          <p:nvPr/>
-        </p:nvSpPr>
-        <p:spPr>
-          <a:xfrm xmlns:a="http://schemas.openxmlformats.org/drawingml/2006/main">
-            <a:off x="3086100" y="3067050"/>
+                <a16:creationId xmlns:a16="http://schemas.microsoft.com/office/drawing/2014/main" id="{966FFDE8-62FE-4AEC-A93F-C4C22D4F9286}"/>
+              </a:ext>
+            </a:extLst>
+          </p:cNvPr>
+          <p:cNvSpPr>
+            <a:spLocks xmlns:a="http://schemas.openxmlformats.org/drawingml/2006/main" noGrp="1"/>
+          </p:cNvSpPr>
+          <p:nvPr/>
+        </p:nvSpPr>
+        <p:spPr>
+          <a:xfrm xmlns:a="http://schemas.openxmlformats.org/drawingml/2006/main">
+            <a:off x="3086100" y="2952750"/>
             <a:ext cx="1485900" cy="266700"/>
           </a:xfrm>
           <a:prstGeom xmlns:a="http://schemas.openxmlformats.org/drawingml/2006/main" prst="rect">
@@ -8165,19 +8165,19 @@
           <a:lstStyle xmlns:a="http://schemas.openxmlformats.org/drawingml/2006/main"/>
           <a:p xmlns:a="http://schemas.openxmlformats.org/drawingml/2006/main">
             <a:pPr>
-              <a:defRPr sz="1500" b="1">
-                <a:solidFill>
-                  <a:srgbClr val="111827"/>
-                </a:solidFill>
-              </a:defRPr>
-            </a:pPr>
-            <a:r>
-              <a:rPr sz="1500" b="1">
-                <a:solidFill>
-                  <a:srgbClr val="111827"/>
-                </a:solidFill>
-              </a:rPr>
-              <a:t>Week 2</a:t>
+              <a:defRPr sz="1425" b="1">
+                <a:solidFill>
+                  <a:srgbClr val="111827"/>
+                </a:solidFill>
+              </a:defRPr>
+            </a:pPr>
+            <a:r>
+              <a:rPr sz="1425" b="1">
+                <a:solidFill>
+                  <a:srgbClr val="111827"/>
+                </a:solidFill>
+              </a:rPr>
+              <a:t>Неделя 2</a:t>
             </a:r>
           </a:p>
         </p:txBody>
@@ -8187,19 +8187,19 @@
           <p:cNvPr id="12" name="">
             <a:extLst xmlns:a="http://schemas.openxmlformats.org/drawingml/2006/main">
               <a:ext uri="{FF2B5EF4-FFF2-40B4-BE49-F238E27FC236}">
-                <a16:creationId xmlns:a16="http://schemas.microsoft.com/office/drawing/2014/main" id="{00F1EA97-6384-4835-9F1C-D48319ADB6E2}"/>
-              </a:ext>
-            </a:extLst>
-          </p:cNvPr>
-          <p:cNvSpPr>
-            <a:spLocks xmlns:a="http://schemas.openxmlformats.org/drawingml/2006/main" noGrp="1"/>
-          </p:cNvSpPr>
-          <p:nvPr/>
-        </p:nvSpPr>
-        <p:spPr>
-          <a:xfrm xmlns:a="http://schemas.openxmlformats.org/drawingml/2006/main">
-            <a:off x="3086100" y="3448050"/>
-            <a:ext cx="1485900" cy="514350"/>
+                <a16:creationId xmlns:a16="http://schemas.microsoft.com/office/drawing/2014/main" id="{CD64F6E4-55AE-4019-9A43-F37CE766D6CB}"/>
+              </a:ext>
+            </a:extLst>
+          </p:cNvPr>
+          <p:cNvSpPr>
+            <a:spLocks xmlns:a="http://schemas.openxmlformats.org/drawingml/2006/main" noGrp="1"/>
+          </p:cNvSpPr>
+          <p:nvPr/>
+        </p:nvSpPr>
+        <p:spPr>
+          <a:xfrm xmlns:a="http://schemas.openxmlformats.org/drawingml/2006/main">
+            <a:off x="3086100" y="3333750"/>
+            <a:ext cx="1485900" cy="533400"/>
           </a:xfrm>
           <a:prstGeom xmlns:a="http://schemas.openxmlformats.org/drawingml/2006/main" prst="rect">
             <a:avLst/>
@@ -8215,19 +8215,19 @@
           <a:lstStyle xmlns:a="http://schemas.openxmlformats.org/drawingml/2006/main"/>
           <a:p xmlns:a="http://schemas.openxmlformats.org/drawingml/2006/main">
             <a:pPr>
-              <a:defRPr sz="1500" b="1">
-                <a:solidFill>
-                  <a:srgbClr val="111827"/>
-                </a:solidFill>
-              </a:defRPr>
-            </a:pPr>
-            <a:r>
-              <a:rPr sz="1500" b="1">
-                <a:solidFill>
-                  <a:srgbClr val="111827"/>
-                </a:solidFill>
-              </a:rPr>
-              <a:t>Architecture</a:t>
+              <a:defRPr sz="1425" b="1">
+                <a:solidFill>
+                  <a:srgbClr val="111827"/>
+                </a:solidFill>
+              </a:defRPr>
+            </a:pPr>
+            <a:r>
+              <a:rPr sz="1425" b="1">
+                <a:solidFill>
+                  <a:srgbClr val="111827"/>
+                </a:solidFill>
+              </a:rPr>
+              <a:t>Архитектура</a:t>
             </a:r>
           </a:p>
         </p:txBody>
@@ -8237,19 +8237,19 @@
           <p:cNvPr id="13" name="">
             <a:extLst xmlns:a="http://schemas.openxmlformats.org/drawingml/2006/main">
               <a:ext uri="{FF2B5EF4-FFF2-40B4-BE49-F238E27FC236}">
-                <a16:creationId xmlns:a16="http://schemas.microsoft.com/office/drawing/2014/main" id="{BF364FF8-B9F8-43B6-A0D3-9A11C5FE3E0F}"/>
-              </a:ext>
-            </a:extLst>
-          </p:cNvPr>
-          <p:cNvSpPr>
-            <a:spLocks xmlns:a="http://schemas.openxmlformats.org/drawingml/2006/main" noGrp="1"/>
-          </p:cNvSpPr>
-          <p:nvPr/>
-        </p:nvSpPr>
-        <p:spPr>
-          <a:xfrm xmlns:a="http://schemas.openxmlformats.org/drawingml/2006/main">
-            <a:off x="3086100" y="4000500"/>
-            <a:ext cx="1485900" cy="323850"/>
+                <a16:creationId xmlns:a16="http://schemas.microsoft.com/office/drawing/2014/main" id="{916684EF-4AAF-45EF-B826-E47AB5C70097}"/>
+              </a:ext>
+            </a:extLst>
+          </p:cNvPr>
+          <p:cNvSpPr>
+            <a:spLocks xmlns:a="http://schemas.openxmlformats.org/drawingml/2006/main" noGrp="1"/>
+          </p:cNvSpPr>
+          <p:nvPr/>
+        </p:nvSpPr>
+        <p:spPr>
+          <a:xfrm xmlns:a="http://schemas.openxmlformats.org/drawingml/2006/main">
+            <a:off x="3086100" y="3962400"/>
+            <a:ext cx="1485900" cy="438150"/>
           </a:xfrm>
           <a:prstGeom xmlns:a="http://schemas.openxmlformats.org/drawingml/2006/main" prst="rect">
             <a:avLst/>
@@ -8265,19 +8265,19 @@
           <a:lstStyle xmlns:a="http://schemas.openxmlformats.org/drawingml/2006/main"/>
           <a:p xmlns:a="http://schemas.openxmlformats.org/drawingml/2006/main">
             <a:pPr>
-              <a:defRPr sz="1125">
+              <a:defRPr sz="1050">
                 <a:solidFill>
                   <a:srgbClr val="4B5563"/>
                 </a:solidFill>
               </a:defRPr>
             </a:pPr>
             <a:r>
-              <a:rPr sz="1125">
+              <a:rPr sz="1050">
                 <a:solidFill>
                   <a:srgbClr val="4B5563"/>
                 </a:solidFill>
               </a:rPr>
-              <a:t>topology, config, version policy</a:t>
+              <a:t>схема репозиториев, настройки, версия OpenSpec</a:t>
             </a:r>
           </a:p>
         </p:txBody>
@@ -8287,23 +8287,23 @@
           <p:cNvPr id="14" name="">
             <a:extLst xmlns:a="http://schemas.openxmlformats.org/drawingml/2006/main">
               <a:ext uri="{FF2B5EF4-FFF2-40B4-BE49-F238E27FC236}">
-                <a16:creationId xmlns:a16="http://schemas.microsoft.com/office/drawing/2014/main" id="{8A1804D8-FCDB-4662-BE64-05477D8E0EED}"/>
-              </a:ext>
-            </a:extLst>
-          </p:cNvPr>
-          <p:cNvSpPr>
-            <a:spLocks xmlns:a="http://schemas.openxmlformats.org/drawingml/2006/main" noGrp="1"/>
-          </p:cNvSpPr>
-          <p:nvPr/>
-        </p:nvSpPr>
-        <p:spPr>
-          <a:xfrm xmlns:a="http://schemas.openxmlformats.org/drawingml/2006/main">
-            <a:off x="5181600" y="2857500"/>
-            <a:ext cx="2057400" cy="1543050"/>
+                <a16:creationId xmlns:a16="http://schemas.microsoft.com/office/drawing/2014/main" id="{3B69C475-298B-4436-BE3D-D3B36C7A4BE5}"/>
+              </a:ext>
+            </a:extLst>
+          </p:cNvPr>
+          <p:cNvSpPr>
+            <a:spLocks xmlns:a="http://schemas.openxmlformats.org/drawingml/2006/main" noGrp="1"/>
+          </p:cNvSpPr>
+          <p:nvPr/>
+        </p:nvSpPr>
+        <p:spPr>
+          <a:xfrm xmlns:a="http://schemas.openxmlformats.org/drawingml/2006/main">
+            <a:off x="5181600" y="2724150"/>
+            <a:ext cx="2057400" cy="1790700"/>
           </a:xfrm>
           <a:prstGeom xmlns:a="http://schemas.openxmlformats.org/drawingml/2006/main" prst="roundRect">
             <a:avLst>
-              <a:gd name="adj" fmla="val 1235"/>
+              <a:gd name="adj" fmla="val 1064"/>
             </a:avLst>
           </a:prstGeom>
           <a:solidFill xmlns:a="http://schemas.openxmlformats.org/drawingml/2006/main">
@@ -8322,18 +8322,18 @@
           <p:cNvPr id="15" name="">
             <a:extLst xmlns:a="http://schemas.openxmlformats.org/drawingml/2006/main">
               <a:ext uri="{FF2B5EF4-FFF2-40B4-BE49-F238E27FC236}">
-                <a16:creationId xmlns:a16="http://schemas.microsoft.com/office/drawing/2014/main" id="{E31A7E23-0CED-4D95-B1EA-0766897CD23B}"/>
-              </a:ext>
-            </a:extLst>
-          </p:cNvPr>
-          <p:cNvSpPr>
-            <a:spLocks xmlns:a="http://schemas.openxmlformats.org/drawingml/2006/main" noGrp="1"/>
-          </p:cNvSpPr>
-          <p:nvPr/>
-        </p:nvSpPr>
-        <p:spPr>
-          <a:xfrm xmlns:a="http://schemas.openxmlformats.org/drawingml/2006/main">
-            <a:off x="5353050" y="3067050"/>
+                <a16:creationId xmlns:a16="http://schemas.microsoft.com/office/drawing/2014/main" id="{31147F48-25FA-4E73-A419-56C69737C28E}"/>
+              </a:ext>
+            </a:extLst>
+          </p:cNvPr>
+          <p:cNvSpPr>
+            <a:spLocks xmlns:a="http://schemas.openxmlformats.org/drawingml/2006/main" noGrp="1"/>
+          </p:cNvSpPr>
+          <p:nvPr/>
+        </p:nvSpPr>
+        <p:spPr>
+          <a:xfrm xmlns:a="http://schemas.openxmlformats.org/drawingml/2006/main">
+            <a:off x="5353050" y="2952750"/>
             <a:ext cx="1714500" cy="266700"/>
           </a:xfrm>
           <a:prstGeom xmlns:a="http://schemas.openxmlformats.org/drawingml/2006/main" prst="rect">
@@ -8350,19 +8350,19 @@
           <a:lstStyle xmlns:a="http://schemas.openxmlformats.org/drawingml/2006/main"/>
           <a:p xmlns:a="http://schemas.openxmlformats.org/drawingml/2006/main">
             <a:pPr>
-              <a:defRPr sz="1500" b="1">
+              <a:defRPr sz="1425" b="1">
                 <a:solidFill>
                   <a:srgbClr val="0F766E"/>
                 </a:solidFill>
               </a:defRPr>
             </a:pPr>
             <a:r>
-              <a:rPr sz="1500" b="1">
+              <a:rPr sz="1425" b="1">
                 <a:solidFill>
                   <a:srgbClr val="0F766E"/>
                 </a:solidFill>
               </a:rPr>
-              <a:t>Week 3-4</a:t>
+              <a:t>Неделя 3-4</a:t>
             </a:r>
           </a:p>
         </p:txBody>
@@ -8372,19 +8372,19 @@
           <p:cNvPr id="16" name="">
             <a:extLst xmlns:a="http://schemas.openxmlformats.org/drawingml/2006/main">
               <a:ext uri="{FF2B5EF4-FFF2-40B4-BE49-F238E27FC236}">
-                <a16:creationId xmlns:a16="http://schemas.microsoft.com/office/drawing/2014/main" id="{B9FD9458-6457-4FF8-9F66-279F3FCA63E0}"/>
-              </a:ext>
-            </a:extLst>
-          </p:cNvPr>
-          <p:cNvSpPr>
-            <a:spLocks xmlns:a="http://schemas.openxmlformats.org/drawingml/2006/main" noGrp="1"/>
-          </p:cNvSpPr>
-          <p:nvPr/>
-        </p:nvSpPr>
-        <p:spPr>
-          <a:xfrm xmlns:a="http://schemas.openxmlformats.org/drawingml/2006/main">
-            <a:off x="5353050" y="3448050"/>
-            <a:ext cx="1714500" cy="514350"/>
+                <a16:creationId xmlns:a16="http://schemas.microsoft.com/office/drawing/2014/main" id="{3DB0C339-A302-4C58-A7A1-1BA8B800B928}"/>
+              </a:ext>
+            </a:extLst>
+          </p:cNvPr>
+          <p:cNvSpPr>
+            <a:spLocks xmlns:a="http://schemas.openxmlformats.org/drawingml/2006/main" noGrp="1"/>
+          </p:cNvSpPr>
+          <p:nvPr/>
+        </p:nvSpPr>
+        <p:spPr>
+          <a:xfrm xmlns:a="http://schemas.openxmlformats.org/drawingml/2006/main">
+            <a:off x="5353050" y="3333750"/>
+            <a:ext cx="1714500" cy="533400"/>
           </a:xfrm>
           <a:prstGeom xmlns:a="http://schemas.openxmlformats.org/drawingml/2006/main" prst="rect">
             <a:avLst/>
@@ -8400,19 +8400,19 @@
           <a:lstStyle xmlns:a="http://schemas.openxmlformats.org/drawingml/2006/main"/>
           <a:p xmlns:a="http://schemas.openxmlformats.org/drawingml/2006/main">
             <a:pPr>
-              <a:defRPr sz="1500" b="1">
-                <a:solidFill>
-                  <a:srgbClr val="111827"/>
-                </a:solidFill>
-              </a:defRPr>
-            </a:pPr>
-            <a:r>
-              <a:rPr sz="1500" b="1">
-                <a:solidFill>
-                  <a:srgbClr val="111827"/>
-                </a:solidFill>
-              </a:rPr>
-              <a:t>Thin flow</a:t>
+              <a:defRPr sz="1425" b="1">
+                <a:solidFill>
+                  <a:srgbClr val="111827"/>
+                </a:solidFill>
+              </a:defRPr>
+            </a:pPr>
+            <a:r>
+              <a:rPr sz="1425" b="1">
+                <a:solidFill>
+                  <a:srgbClr val="111827"/>
+                </a:solidFill>
+              </a:rPr>
+              <a:t>Легкий путь</a:t>
             </a:r>
           </a:p>
         </p:txBody>
@@ -8422,19 +8422,19 @@
           <p:cNvPr id="17" name="">
             <a:extLst xmlns:a="http://schemas.openxmlformats.org/drawingml/2006/main">
               <a:ext uri="{FF2B5EF4-FFF2-40B4-BE49-F238E27FC236}">
-                <a16:creationId xmlns:a16="http://schemas.microsoft.com/office/drawing/2014/main" id="{8A14CB94-198A-4627-8A17-1E1A125F0627}"/>
-              </a:ext>
-            </a:extLst>
-          </p:cNvPr>
-          <p:cNvSpPr>
-            <a:spLocks xmlns:a="http://schemas.openxmlformats.org/drawingml/2006/main" noGrp="1"/>
-          </p:cNvSpPr>
-          <p:nvPr/>
-        </p:nvSpPr>
-        <p:spPr>
-          <a:xfrm xmlns:a="http://schemas.openxmlformats.org/drawingml/2006/main">
-            <a:off x="5353050" y="4000500"/>
-            <a:ext cx="1714500" cy="323850"/>
+                <a16:creationId xmlns:a16="http://schemas.microsoft.com/office/drawing/2014/main" id="{5CEEAF6D-871E-4F01-942D-0AE4D7F71F6B}"/>
+              </a:ext>
+            </a:extLst>
+          </p:cNvPr>
+          <p:cNvSpPr>
+            <a:spLocks xmlns:a="http://schemas.openxmlformats.org/drawingml/2006/main" noGrp="1"/>
+          </p:cNvSpPr>
+          <p:nvPr/>
+        </p:nvSpPr>
+        <p:spPr>
+          <a:xfrm xmlns:a="http://schemas.openxmlformats.org/drawingml/2006/main">
+            <a:off x="5353050" y="3962400"/>
+            <a:ext cx="1714500" cy="438150"/>
           </a:xfrm>
           <a:prstGeom xmlns:a="http://schemas.openxmlformats.org/drawingml/2006/main" prst="rect">
             <a:avLst/>
@@ -8450,19 +8450,19 @@
           <a:lstStyle xmlns:a="http://schemas.openxmlformats.org/drawingml/2006/main"/>
           <a:p xmlns:a="http://schemas.openxmlformats.org/drawingml/2006/main">
             <a:pPr>
-              <a:defRPr sz="1125">
+              <a:defRPr sz="1050">
                 <a:solidFill>
                   <a:srgbClr val="4B5563"/>
                 </a:solidFill>
               </a:defRPr>
             </a:pPr>
             <a:r>
-              <a:rPr sz="1125">
+              <a:rPr sz="1050">
                 <a:solidFill>
                   <a:srgbClr val="4B5563"/>
                 </a:solidFill>
               </a:rPr>
-              <a:t>templates, validator, PR/archive path</a:t>
+              <a:t>шаблоны, проверка, ревью и фиксация</a:t>
             </a:r>
           </a:p>
         </p:txBody>
@@ -8472,23 +8472,23 @@
           <p:cNvPr id="18" name="">
             <a:extLst xmlns:a="http://schemas.openxmlformats.org/drawingml/2006/main">
               <a:ext uri="{FF2B5EF4-FFF2-40B4-BE49-F238E27FC236}">
-                <a16:creationId xmlns:a16="http://schemas.microsoft.com/office/drawing/2014/main" id="{19E524CB-251D-4880-99D6-3EEE79EF4C26}"/>
-              </a:ext>
-            </a:extLst>
-          </p:cNvPr>
-          <p:cNvSpPr>
-            <a:spLocks xmlns:a="http://schemas.openxmlformats.org/drawingml/2006/main" noGrp="1"/>
-          </p:cNvSpPr>
-          <p:nvPr/>
-        </p:nvSpPr>
-        <p:spPr>
-          <a:xfrm xmlns:a="http://schemas.openxmlformats.org/drawingml/2006/main">
-            <a:off x="7448550" y="2857500"/>
-            <a:ext cx="1828800" cy="1543050"/>
+                <a16:creationId xmlns:a16="http://schemas.microsoft.com/office/drawing/2014/main" id="{60E669E6-5A7E-4E3F-9FEA-8D4F5EA60CA4}"/>
+              </a:ext>
+            </a:extLst>
+          </p:cNvPr>
+          <p:cNvSpPr>
+            <a:spLocks xmlns:a="http://schemas.openxmlformats.org/drawingml/2006/main" noGrp="1"/>
+          </p:cNvSpPr>
+          <p:nvPr/>
+        </p:nvSpPr>
+        <p:spPr>
+          <a:xfrm xmlns:a="http://schemas.openxmlformats.org/drawingml/2006/main">
+            <a:off x="7448550" y="2724150"/>
+            <a:ext cx="1828800" cy="1790700"/>
           </a:xfrm>
           <a:prstGeom xmlns:a="http://schemas.openxmlformats.org/drawingml/2006/main" prst="roundRect">
             <a:avLst>
-              <a:gd name="adj" fmla="val 1235"/>
+              <a:gd name="adj" fmla="val 1064"/>
             </a:avLst>
           </a:prstGeom>
           <a:solidFill xmlns:a="http://schemas.openxmlformats.org/drawingml/2006/main">
@@ -8507,18 +8507,18 @@
           <p:cNvPr id="19" name="">
             <a:extLst xmlns:a="http://schemas.openxmlformats.org/drawingml/2006/main">
               <a:ext uri="{FF2B5EF4-FFF2-40B4-BE49-F238E27FC236}">
-                <a16:creationId xmlns:a16="http://schemas.microsoft.com/office/drawing/2014/main" id="{669F8531-6CA5-4298-920C-F3455CCE0C62}"/>
-              </a:ext>
-            </a:extLst>
-          </p:cNvPr>
-          <p:cNvSpPr>
-            <a:spLocks xmlns:a="http://schemas.openxmlformats.org/drawingml/2006/main" noGrp="1"/>
-          </p:cNvSpPr>
-          <p:nvPr/>
-        </p:nvSpPr>
-        <p:spPr>
-          <a:xfrm xmlns:a="http://schemas.openxmlformats.org/drawingml/2006/main">
-            <a:off x="7620000" y="3067050"/>
+                <a16:creationId xmlns:a16="http://schemas.microsoft.com/office/drawing/2014/main" id="{57FB7179-DA4F-450A-9DBC-5F4F1DCF0F9E}"/>
+              </a:ext>
+            </a:extLst>
+          </p:cNvPr>
+          <p:cNvSpPr>
+            <a:spLocks xmlns:a="http://schemas.openxmlformats.org/drawingml/2006/main" noGrp="1"/>
+          </p:cNvSpPr>
+          <p:nvPr/>
+        </p:nvSpPr>
+        <p:spPr>
+          <a:xfrm xmlns:a="http://schemas.openxmlformats.org/drawingml/2006/main">
+            <a:off x="7620000" y="2952750"/>
             <a:ext cx="1485900" cy="266700"/>
           </a:xfrm>
           <a:prstGeom xmlns:a="http://schemas.openxmlformats.org/drawingml/2006/main" prst="rect">
@@ -8535,19 +8535,19 @@
           <a:lstStyle xmlns:a="http://schemas.openxmlformats.org/drawingml/2006/main"/>
           <a:p xmlns:a="http://schemas.openxmlformats.org/drawingml/2006/main">
             <a:pPr>
-              <a:defRPr sz="1500" b="1">
-                <a:solidFill>
-                  <a:srgbClr val="111827"/>
-                </a:solidFill>
-              </a:defRPr>
-            </a:pPr>
-            <a:r>
-              <a:rPr sz="1500" b="1">
-                <a:solidFill>
-                  <a:srgbClr val="111827"/>
-                </a:solidFill>
-              </a:rPr>
-              <a:t>Week 5</a:t>
+              <a:defRPr sz="1425" b="1">
+                <a:solidFill>
+                  <a:srgbClr val="111827"/>
+                </a:solidFill>
+              </a:defRPr>
+            </a:pPr>
+            <a:r>
+              <a:rPr sz="1425" b="1">
+                <a:solidFill>
+                  <a:srgbClr val="111827"/>
+                </a:solidFill>
+              </a:rPr>
+              <a:t>Неделя 5</a:t>
             </a:r>
           </a:p>
         </p:txBody>
@@ -8557,19 +8557,19 @@
           <p:cNvPr id="20" name="">
             <a:extLst xmlns:a="http://schemas.openxmlformats.org/drawingml/2006/main">
               <a:ext uri="{FF2B5EF4-FFF2-40B4-BE49-F238E27FC236}">
-                <a16:creationId xmlns:a16="http://schemas.microsoft.com/office/drawing/2014/main" id="{A698ECF0-4022-450A-B475-B5953BEBBB19}"/>
-              </a:ext>
-            </a:extLst>
-          </p:cNvPr>
-          <p:cNvSpPr>
-            <a:spLocks xmlns:a="http://schemas.openxmlformats.org/drawingml/2006/main" noGrp="1"/>
-          </p:cNvSpPr>
-          <p:nvPr/>
-        </p:nvSpPr>
-        <p:spPr>
-          <a:xfrm xmlns:a="http://schemas.openxmlformats.org/drawingml/2006/main">
-            <a:off x="7620000" y="3448050"/>
-            <a:ext cx="1485900" cy="514350"/>
+                <a16:creationId xmlns:a16="http://schemas.microsoft.com/office/drawing/2014/main" id="{143199AA-D21A-4BC4-9481-0B60E45559E2}"/>
+              </a:ext>
+            </a:extLst>
+          </p:cNvPr>
+          <p:cNvSpPr>
+            <a:spLocks xmlns:a="http://schemas.openxmlformats.org/drawingml/2006/main" noGrp="1"/>
+          </p:cNvSpPr>
+          <p:nvPr/>
+        </p:nvSpPr>
+        <p:spPr>
+          <a:xfrm xmlns:a="http://schemas.openxmlformats.org/drawingml/2006/main">
+            <a:off x="7620000" y="3333750"/>
+            <a:ext cx="1485900" cy="533400"/>
           </a:xfrm>
           <a:prstGeom xmlns:a="http://schemas.openxmlformats.org/drawingml/2006/main" prst="rect">
             <a:avLst/>
@@ -8585,19 +8585,19 @@
           <a:lstStyle xmlns:a="http://schemas.openxmlformats.org/drawingml/2006/main"/>
           <a:p xmlns:a="http://schemas.openxmlformats.org/drawingml/2006/main">
             <a:pPr>
-              <a:defRPr sz="1500" b="1">
-                <a:solidFill>
-                  <a:srgbClr val="111827"/>
-                </a:solidFill>
-              </a:defRPr>
-            </a:pPr>
-            <a:r>
-              <a:rPr sz="1500" b="1">
-                <a:solidFill>
-                  <a:srgbClr val="111827"/>
-                </a:solidFill>
-              </a:rPr>
-              <a:t>Hardening</a:t>
+              <a:defRPr sz="1425" b="1">
+                <a:solidFill>
+                  <a:srgbClr val="111827"/>
+                </a:solidFill>
+              </a:defRPr>
+            </a:pPr>
+            <a:r>
+              <a:rPr sz="1425" b="1">
+                <a:solidFill>
+                  <a:srgbClr val="111827"/>
+                </a:solidFill>
+              </a:rPr>
+              <a:t>Укрепление</a:t>
             </a:r>
           </a:p>
         </p:txBody>
@@ -8607,19 +8607,19 @@
           <p:cNvPr id="21" name="">
             <a:extLst xmlns:a="http://schemas.openxmlformats.org/drawingml/2006/main">
               <a:ext uri="{FF2B5EF4-FFF2-40B4-BE49-F238E27FC236}">
-                <a16:creationId xmlns:a16="http://schemas.microsoft.com/office/drawing/2014/main" id="{49E81EB0-5535-4A53-84A1-ACF380D00E9B}"/>
-              </a:ext>
-            </a:extLst>
-          </p:cNvPr>
-          <p:cNvSpPr>
-            <a:spLocks xmlns:a="http://schemas.openxmlformats.org/drawingml/2006/main" noGrp="1"/>
-          </p:cNvSpPr>
-          <p:nvPr/>
-        </p:nvSpPr>
-        <p:spPr>
-          <a:xfrm xmlns:a="http://schemas.openxmlformats.org/drawingml/2006/main">
-            <a:off x="7620000" y="4000500"/>
-            <a:ext cx="1485900" cy="323850"/>
+                <a16:creationId xmlns:a16="http://schemas.microsoft.com/office/drawing/2014/main" id="{B8490ABB-1CFC-49DB-B32C-56F288C53AF4}"/>
+              </a:ext>
+            </a:extLst>
+          </p:cNvPr>
+          <p:cNvSpPr>
+            <a:spLocks xmlns:a="http://schemas.openxmlformats.org/drawingml/2006/main" noGrp="1"/>
+          </p:cNvSpPr>
+          <p:nvPr/>
+        </p:nvSpPr>
+        <p:spPr>
+          <a:xfrm xmlns:a="http://schemas.openxmlformats.org/drawingml/2006/main">
+            <a:off x="7620000" y="3962400"/>
+            <a:ext cx="1485900" cy="438150"/>
           </a:xfrm>
           <a:prstGeom xmlns:a="http://schemas.openxmlformats.org/drawingml/2006/main" prst="rect">
             <a:avLst/>
@@ -8635,19 +8635,19 @@
           <a:lstStyle xmlns:a="http://schemas.openxmlformats.org/drawingml/2006/main"/>
           <a:p xmlns:a="http://schemas.openxmlformats.org/drawingml/2006/main">
             <a:pPr>
-              <a:defRPr sz="1125">
+              <a:defRPr sz="1050">
                 <a:solidFill>
                   <a:srgbClr val="4B5563"/>
                 </a:solidFill>
               </a:defRPr>
             </a:pPr>
             <a:r>
-              <a:rPr sz="1125">
+              <a:rPr sz="1050">
                 <a:solidFill>
                   <a:srgbClr val="4B5563"/>
                 </a:solidFill>
               </a:rPr>
-              <a:t>negative cases, docs, evidence</a:t>
+              <a:t>ошибочные случаи, документы, подтверждения</a:t>
             </a:r>
           </a:p>
         </p:txBody>
@@ -8657,23 +8657,23 @@
           <p:cNvPr id="22" name="">
             <a:extLst xmlns:a="http://schemas.openxmlformats.org/drawingml/2006/main">
               <a:ext uri="{FF2B5EF4-FFF2-40B4-BE49-F238E27FC236}">
-                <a16:creationId xmlns:a16="http://schemas.microsoft.com/office/drawing/2014/main" id="{E8DEACAA-8811-4B5B-8D2A-D6C244FD8372}"/>
-              </a:ext>
-            </a:extLst>
-          </p:cNvPr>
-          <p:cNvSpPr>
-            <a:spLocks xmlns:a="http://schemas.openxmlformats.org/drawingml/2006/main" noGrp="1"/>
-          </p:cNvSpPr>
-          <p:nvPr/>
-        </p:nvSpPr>
-        <p:spPr>
-          <a:xfrm xmlns:a="http://schemas.openxmlformats.org/drawingml/2006/main">
-            <a:off x="9715500" y="2857500"/>
-            <a:ext cx="1828800" cy="1543050"/>
+                <a16:creationId xmlns:a16="http://schemas.microsoft.com/office/drawing/2014/main" id="{A9528726-A1E3-48FB-B71F-2A7907C8F272}"/>
+              </a:ext>
+            </a:extLst>
+          </p:cNvPr>
+          <p:cNvSpPr>
+            <a:spLocks xmlns:a="http://schemas.openxmlformats.org/drawingml/2006/main" noGrp="1"/>
+          </p:cNvSpPr>
+          <p:nvPr/>
+        </p:nvSpPr>
+        <p:spPr>
+          <a:xfrm xmlns:a="http://schemas.openxmlformats.org/drawingml/2006/main">
+            <a:off x="9715500" y="2724150"/>
+            <a:ext cx="1828800" cy="1790700"/>
           </a:xfrm>
           <a:prstGeom xmlns:a="http://schemas.openxmlformats.org/drawingml/2006/main" prst="roundRect">
             <a:avLst>
-              <a:gd name="adj" fmla="val 1235"/>
+              <a:gd name="adj" fmla="val 1064"/>
             </a:avLst>
           </a:prstGeom>
           <a:solidFill xmlns:a="http://schemas.openxmlformats.org/drawingml/2006/main">
@@ -8692,18 +8692,18 @@
           <p:cNvPr id="23" name="">
             <a:extLst xmlns:a="http://schemas.openxmlformats.org/drawingml/2006/main">
               <a:ext uri="{FF2B5EF4-FFF2-40B4-BE49-F238E27FC236}">
-                <a16:creationId xmlns:a16="http://schemas.microsoft.com/office/drawing/2014/main" id="{1921DE1F-C03D-4618-939C-8067193F50CB}"/>
-              </a:ext>
-            </a:extLst>
-          </p:cNvPr>
-          <p:cNvSpPr>
-            <a:spLocks xmlns:a="http://schemas.openxmlformats.org/drawingml/2006/main" noGrp="1"/>
-          </p:cNvSpPr>
-          <p:nvPr/>
-        </p:nvSpPr>
-        <p:spPr>
-          <a:xfrm xmlns:a="http://schemas.openxmlformats.org/drawingml/2006/main">
-            <a:off x="9886950" y="3067050"/>
+                <a16:creationId xmlns:a16="http://schemas.microsoft.com/office/drawing/2014/main" id="{463A08F3-DAC0-4CEA-AC9D-CDF564F3C591}"/>
+              </a:ext>
+            </a:extLst>
+          </p:cNvPr>
+          <p:cNvSpPr>
+            <a:spLocks xmlns:a="http://schemas.openxmlformats.org/drawingml/2006/main" noGrp="1"/>
+          </p:cNvSpPr>
+          <p:nvPr/>
+        </p:nvSpPr>
+        <p:spPr>
+          <a:xfrm xmlns:a="http://schemas.openxmlformats.org/drawingml/2006/main">
+            <a:off x="9886950" y="2952750"/>
             <a:ext cx="1485900" cy="266700"/>
           </a:xfrm>
           <a:prstGeom xmlns:a="http://schemas.openxmlformats.org/drawingml/2006/main" prst="rect">
@@ -8720,19 +8720,19 @@
           <a:lstStyle xmlns:a="http://schemas.openxmlformats.org/drawingml/2006/main"/>
           <a:p xmlns:a="http://schemas.openxmlformats.org/drawingml/2006/main">
             <a:pPr>
-              <a:defRPr sz="1500" b="1">
-                <a:solidFill>
-                  <a:srgbClr val="111827"/>
-                </a:solidFill>
-              </a:defRPr>
-            </a:pPr>
-            <a:r>
-              <a:rPr sz="1500" b="1">
-                <a:solidFill>
-                  <a:srgbClr val="111827"/>
-                </a:solidFill>
-              </a:rPr>
-              <a:t>Week 6</a:t>
+              <a:defRPr sz="1425" b="1">
+                <a:solidFill>
+                  <a:srgbClr val="111827"/>
+                </a:solidFill>
+              </a:defRPr>
+            </a:pPr>
+            <a:r>
+              <a:rPr sz="1425" b="1">
+                <a:solidFill>
+                  <a:srgbClr val="111827"/>
+                </a:solidFill>
+              </a:rPr>
+              <a:t>Неделя 6</a:t>
             </a:r>
           </a:p>
         </p:txBody>
@@ -8742,19 +8742,19 @@
           <p:cNvPr id="24" name="">
             <a:extLst xmlns:a="http://schemas.openxmlformats.org/drawingml/2006/main">
               <a:ext uri="{FF2B5EF4-FFF2-40B4-BE49-F238E27FC236}">
-                <a16:creationId xmlns:a16="http://schemas.microsoft.com/office/drawing/2014/main" id="{3BA24FAA-89C9-4EF5-B77E-CF6006CFDCE5}"/>
-              </a:ext>
-            </a:extLst>
-          </p:cNvPr>
-          <p:cNvSpPr>
-            <a:spLocks xmlns:a="http://schemas.openxmlformats.org/drawingml/2006/main" noGrp="1"/>
-          </p:cNvSpPr>
-          <p:nvPr/>
-        </p:nvSpPr>
-        <p:spPr>
-          <a:xfrm xmlns:a="http://schemas.openxmlformats.org/drawingml/2006/main">
-            <a:off x="9886950" y="3448050"/>
-            <a:ext cx="1485900" cy="514350"/>
+                <a16:creationId xmlns:a16="http://schemas.microsoft.com/office/drawing/2014/main" id="{3378E1DE-7B7A-4214-A732-76E40CB4D467}"/>
+              </a:ext>
+            </a:extLst>
+          </p:cNvPr>
+          <p:cNvSpPr>
+            <a:spLocks xmlns:a="http://schemas.openxmlformats.org/drawingml/2006/main" noGrp="1"/>
+          </p:cNvSpPr>
+          <p:nvPr/>
+        </p:nvSpPr>
+        <p:spPr>
+          <a:xfrm xmlns:a="http://schemas.openxmlformats.org/drawingml/2006/main">
+            <a:off x="9886950" y="3333750"/>
+            <a:ext cx="1485900" cy="533400"/>
           </a:xfrm>
           <a:prstGeom xmlns:a="http://schemas.openxmlformats.org/drawingml/2006/main" prst="rect">
             <a:avLst/>
@@ -8770,19 +8770,19 @@
           <a:lstStyle xmlns:a="http://schemas.openxmlformats.org/drawingml/2006/main"/>
           <a:p xmlns:a="http://schemas.openxmlformats.org/drawingml/2006/main">
             <a:pPr>
-              <a:defRPr sz="1500" b="1">
-                <a:solidFill>
-                  <a:srgbClr val="111827"/>
-                </a:solidFill>
-              </a:defRPr>
-            </a:pPr>
-            <a:r>
-              <a:rPr sz="1500" b="1">
-                <a:solidFill>
-                  <a:srgbClr val="111827"/>
-                </a:solidFill>
-              </a:rPr>
-              <a:t>Pilot readiness</a:t>
+              <a:defRPr sz="1425" b="1">
+                <a:solidFill>
+                  <a:srgbClr val="111827"/>
+                </a:solidFill>
+              </a:defRPr>
+            </a:pPr>
+            <a:r>
+              <a:rPr sz="1425" b="1">
+                <a:solidFill>
+                  <a:srgbClr val="111827"/>
+                </a:solidFill>
+              </a:rPr>
+              <a:t>Готовность к пилоту</a:t>
             </a:r>
           </a:p>
         </p:txBody>
@@ -8792,19 +8792,19 @@
           <p:cNvPr id="25" name="">
             <a:extLst xmlns:a="http://schemas.openxmlformats.org/drawingml/2006/main">
               <a:ext uri="{FF2B5EF4-FFF2-40B4-BE49-F238E27FC236}">
-                <a16:creationId xmlns:a16="http://schemas.microsoft.com/office/drawing/2014/main" id="{5CE52903-9AC8-450D-991F-FDB6B8B40F49}"/>
-              </a:ext>
-            </a:extLst>
-          </p:cNvPr>
-          <p:cNvSpPr>
-            <a:spLocks xmlns:a="http://schemas.openxmlformats.org/drawingml/2006/main" noGrp="1"/>
-          </p:cNvSpPr>
-          <p:nvPr/>
-        </p:nvSpPr>
-        <p:spPr>
-          <a:xfrm xmlns:a="http://schemas.openxmlformats.org/drawingml/2006/main">
-            <a:off x="9886950" y="4000500"/>
-            <a:ext cx="1485900" cy="323850"/>
+                <a16:creationId xmlns:a16="http://schemas.microsoft.com/office/drawing/2014/main" id="{54164079-86D6-4D6E-A98F-5112F8E5FBBA}"/>
+              </a:ext>
+            </a:extLst>
+          </p:cNvPr>
+          <p:cNvSpPr>
+            <a:spLocks xmlns:a="http://schemas.openxmlformats.org/drawingml/2006/main" noGrp="1"/>
+          </p:cNvSpPr>
+          <p:nvPr/>
+        </p:nvSpPr>
+        <p:spPr>
+          <a:xfrm xmlns:a="http://schemas.openxmlformats.org/drawingml/2006/main">
+            <a:off x="9886950" y="3962400"/>
+            <a:ext cx="1485900" cy="438150"/>
           </a:xfrm>
           <a:prstGeom xmlns:a="http://schemas.openxmlformats.org/drawingml/2006/main" prst="rect">
             <a:avLst/>
@@ -8820,19 +8820,19 @@
           <a:lstStyle xmlns:a="http://schemas.openxmlformats.org/drawingml/2006/main"/>
           <a:p xmlns:a="http://schemas.openxmlformats.org/drawingml/2006/main">
             <a:pPr>
-              <a:defRPr sz="1125">
+              <a:defRPr sz="1050">
                 <a:solidFill>
                   <a:srgbClr val="4B5563"/>
                 </a:solidFill>
               </a:defRPr>
             </a:pPr>
             <a:r>
-              <a:rPr sz="1125">
+              <a:rPr sz="1050">
                 <a:solidFill>
                   <a:srgbClr val="4B5563"/>
                 </a:solidFill>
               </a:rPr>
-              <a:t>walkthrough, fixes, go/no-go</a:t>
+              <a:t>прогон, правки, решение о запуске</a:t>
             </a:r>
           </a:p>
         </p:txBody>
@@ -8842,7 +8842,7 @@
           <p:cNvPr id="26" name="">
             <a:extLst xmlns:a="http://schemas.openxmlformats.org/drawingml/2006/main">
               <a:ext uri="{FF2B5EF4-FFF2-40B4-BE49-F238E27FC236}">
-                <a16:creationId xmlns:a16="http://schemas.microsoft.com/office/drawing/2014/main" id="{1E2FD6BC-C06C-4190-BAB9-F617A45410F1}"/>
+                <a16:creationId xmlns:a16="http://schemas.microsoft.com/office/drawing/2014/main" id="{C639B42A-CCEB-4E21-8F61-0B36BAB85321}"/>
               </a:ext>
             </a:extLst>
           </p:cNvPr>
@@ -8882,7 +8882,7 @@
                   <a:srgbClr val="B45309"/>
                 </a:solidFill>
               </a:rPr>
-              <a:t>Критическое условие: Jira, Confluence, QA/AT генерация и inbox не попадают в эти 6 недель.</a:t>
+              <a:t>Критическое условие: Jira, Confluence, генерация тестов и личные списки не попадают в эти 6 недель.</a:t>
             </a:r>
           </a:p>
         </p:txBody>
@@ -8890,7 +8890,7 @@
     </p:spTree>
     <p:extLst>
       <p:ext uri="{BB962C8B-B14F-4D97-AF65-F5344CB8AC3E}">
-        <p14:creationId xmlns:p14="http://schemas.microsoft.com/office/powerpoint/2010/main" val="1095912272"/>
+        <p14:creationId xmlns:p14="http://schemas.microsoft.com/office/powerpoint/2010/main" val="137889154"/>
       </p:ext>
     </p:extLst>
   </p:cSld>
@@ -8921,7 +8921,7 @@
           <p:cNvPr id="1" name="">
             <a:extLst xmlns:a="http://schemas.openxmlformats.org/drawingml/2006/main">
               <a:ext uri="{FF2B5EF4-FFF2-40B4-BE49-F238E27FC236}">
-                <a16:creationId xmlns:a16="http://schemas.microsoft.com/office/drawing/2014/main" id="{EC835270-0E59-4C5E-93A9-1684CAB79ACE}"/>
+                <a16:creationId xmlns:a16="http://schemas.microsoft.com/office/drawing/2014/main" id="{7D824249-69FC-4063-ADF5-02FAD48E7C9A}"/>
               </a:ext>
             </a:extLst>
           </p:cNvPr>
@@ -8971,7 +8971,7 @@
           <p:cNvPr id="2" name="">
             <a:extLst xmlns:a="http://schemas.openxmlformats.org/drawingml/2006/main">
               <a:ext uri="{FF2B5EF4-FFF2-40B4-BE49-F238E27FC236}">
-                <a16:creationId xmlns:a16="http://schemas.microsoft.com/office/drawing/2014/main" id="{C5242CCA-8E05-48E0-99EB-6B53589B67AD}"/>
+                <a16:creationId xmlns:a16="http://schemas.microsoft.com/office/drawing/2014/main" id="{A6DCE4AC-CB00-429D-9AF3-4B5FBC5B1D58}"/>
               </a:ext>
             </a:extLst>
           </p:cNvPr>
@@ -9011,7 +9011,7 @@
                   <a:srgbClr val="111827"/>
                 </a:solidFill>
               </a:rPr>
-              <a:t>После MVP расширяем процесс слоями, только когда доказана базовая ценность</a:t>
+              <a:t>После первого запуска расширяем процесс слоями, только когда доказана базовая ценность</a:t>
             </a:r>
           </a:p>
         </p:txBody>
@@ -9021,7 +9021,7 @@
           <p:cNvPr id="3" name="">
             <a:extLst xmlns:a="http://schemas.openxmlformats.org/drawingml/2006/main">
               <a:ext uri="{FF2B5EF4-FFF2-40B4-BE49-F238E27FC236}">
-                <a16:creationId xmlns:a16="http://schemas.microsoft.com/office/drawing/2014/main" id="{1A7A9869-C32B-46FB-9972-C3C7426CBFE9}"/>
+                <a16:creationId xmlns:a16="http://schemas.microsoft.com/office/drawing/2014/main" id="{467C2ADA-C681-4A22-AA88-14EBBC9D5EAB}"/>
               </a:ext>
             </a:extLst>
           </p:cNvPr>
@@ -9054,7 +9054,7 @@
           <p:cNvPr id="4" name="">
             <a:extLst xmlns:a="http://schemas.openxmlformats.org/drawingml/2006/main">
               <a:ext uri="{FF2B5EF4-FFF2-40B4-BE49-F238E27FC236}">
-                <a16:creationId xmlns:a16="http://schemas.microsoft.com/office/drawing/2014/main" id="{0B64F2F8-145D-45E3-AD38-3608B0DF591B}"/>
+                <a16:creationId xmlns:a16="http://schemas.microsoft.com/office/drawing/2014/main" id="{004704B9-D8E8-4DB6-B35B-8DA63F0875D0}"/>
               </a:ext>
             </a:extLst>
           </p:cNvPr>
@@ -9104,7 +9104,7 @@
           <p:cNvPr id="5" name="">
             <a:extLst xmlns:a="http://schemas.openxmlformats.org/drawingml/2006/main">
               <a:ext uri="{FF2B5EF4-FFF2-40B4-BE49-F238E27FC236}">
-                <a16:creationId xmlns:a16="http://schemas.microsoft.com/office/drawing/2014/main" id="{F700B36E-EE7F-4C85-9C96-A214E931289A}"/>
+                <a16:creationId xmlns:a16="http://schemas.microsoft.com/office/drawing/2014/main" id="{CF80407B-DD80-40C2-BF76-121AD37BA98A}"/>
               </a:ext>
             </a:extLst>
           </p:cNvPr>
@@ -9154,23 +9154,23 @@
           <p:cNvPr id="6" name="">
             <a:extLst xmlns:a="http://schemas.openxmlformats.org/drawingml/2006/main">
               <a:ext uri="{FF2B5EF4-FFF2-40B4-BE49-F238E27FC236}">
-                <a16:creationId xmlns:a16="http://schemas.microsoft.com/office/drawing/2014/main" id="{46A0A7F6-1994-43A6-A0CE-41039948481D}"/>
-              </a:ext>
-            </a:extLst>
-          </p:cNvPr>
-          <p:cNvSpPr>
-            <a:spLocks xmlns:a="http://schemas.openxmlformats.org/drawingml/2006/main" noGrp="1"/>
-          </p:cNvSpPr>
-          <p:nvPr/>
-        </p:nvSpPr>
-        <p:spPr>
-          <a:xfrm xmlns:a="http://schemas.openxmlformats.org/drawingml/2006/main">
-            <a:off x="1143000" y="2857500"/>
-            <a:ext cx="2000250" cy="1428750"/>
+                <a16:creationId xmlns:a16="http://schemas.microsoft.com/office/drawing/2014/main" id="{176D3DA3-2B34-41CF-BEF1-B8544974EE5D}"/>
+              </a:ext>
+            </a:extLst>
+          </p:cNvPr>
+          <p:cNvSpPr>
+            <a:spLocks xmlns:a="http://schemas.openxmlformats.org/drawingml/2006/main" noGrp="1"/>
+          </p:cNvSpPr>
+          <p:nvPr/>
+        </p:nvSpPr>
+        <p:spPr>
+          <a:xfrm xmlns:a="http://schemas.openxmlformats.org/drawingml/2006/main">
+            <a:off x="1143000" y="2781300"/>
+            <a:ext cx="2000250" cy="1657350"/>
           </a:xfrm>
           <a:prstGeom xmlns:a="http://schemas.openxmlformats.org/drawingml/2006/main" prst="roundRect">
             <a:avLst>
-              <a:gd name="adj" fmla="val 1333"/>
+              <a:gd name="adj" fmla="val 1149"/>
             </a:avLst>
           </a:prstGeom>
           <a:solidFill xmlns:a="http://schemas.openxmlformats.org/drawingml/2006/main">
@@ -9189,19 +9189,19 @@
           <p:cNvPr id="7" name="">
             <a:extLst xmlns:a="http://schemas.openxmlformats.org/drawingml/2006/main">
               <a:ext uri="{FF2B5EF4-FFF2-40B4-BE49-F238E27FC236}">
-                <a16:creationId xmlns:a16="http://schemas.microsoft.com/office/drawing/2014/main" id="{57DB161A-78D7-4A2C-B9DA-3C54D4472829}"/>
-              </a:ext>
-            </a:extLst>
-          </p:cNvPr>
-          <p:cNvSpPr>
-            <a:spLocks xmlns:a="http://schemas.openxmlformats.org/drawingml/2006/main" noGrp="1"/>
-          </p:cNvSpPr>
-          <p:nvPr/>
-        </p:nvSpPr>
-        <p:spPr>
-          <a:xfrm xmlns:a="http://schemas.openxmlformats.org/drawingml/2006/main">
-            <a:off x="1352550" y="3143250"/>
-            <a:ext cx="1581150" cy="285750"/>
+                <a16:creationId xmlns:a16="http://schemas.microsoft.com/office/drawing/2014/main" id="{376FDA22-AA4F-4057-BB9A-1F154A441C21}"/>
+              </a:ext>
+            </a:extLst>
+          </p:cNvPr>
+          <p:cNvSpPr>
+            <a:spLocks xmlns:a="http://schemas.openxmlformats.org/drawingml/2006/main" noGrp="1"/>
+          </p:cNvSpPr>
+          <p:nvPr/>
+        </p:nvSpPr>
+        <p:spPr>
+          <a:xfrm xmlns:a="http://schemas.openxmlformats.org/drawingml/2006/main">
+            <a:off x="1352550" y="3067050"/>
+            <a:ext cx="1581150" cy="323850"/>
           </a:xfrm>
           <a:prstGeom xmlns:a="http://schemas.openxmlformats.org/drawingml/2006/main" prst="rect">
             <a:avLst/>
@@ -9229,7 +9229,7 @@
                   <a:srgbClr val="111827"/>
                 </a:solidFill>
               </a:rPr>
-              <a:t>Publish</a:t>
+              <a:t>Публикация</a:t>
             </a:r>
           </a:p>
         </p:txBody>
@@ -9239,19 +9239,19 @@
           <p:cNvPr id="8" name="">
             <a:extLst xmlns:a="http://schemas.openxmlformats.org/drawingml/2006/main">
               <a:ext uri="{FF2B5EF4-FFF2-40B4-BE49-F238E27FC236}">
-                <a16:creationId xmlns:a16="http://schemas.microsoft.com/office/drawing/2014/main" id="{0435986E-DDB7-4F70-8FE0-5027678269CF}"/>
-              </a:ext>
-            </a:extLst>
-          </p:cNvPr>
-          <p:cNvSpPr>
-            <a:spLocks xmlns:a="http://schemas.openxmlformats.org/drawingml/2006/main" noGrp="1"/>
-          </p:cNvSpPr>
-          <p:nvPr/>
-        </p:nvSpPr>
-        <p:spPr>
-          <a:xfrm xmlns:a="http://schemas.openxmlformats.org/drawingml/2006/main">
-            <a:off x="1352550" y="3600450"/>
-            <a:ext cx="1581150" cy="514350"/>
+                <a16:creationId xmlns:a16="http://schemas.microsoft.com/office/drawing/2014/main" id="{85582531-D6E2-4EE3-83EC-318310BAA4B9}"/>
+              </a:ext>
+            </a:extLst>
+          </p:cNvPr>
+          <p:cNvSpPr>
+            <a:spLocks xmlns:a="http://schemas.openxmlformats.org/drawingml/2006/main" noGrp="1"/>
+          </p:cNvSpPr>
+          <p:nvPr/>
+        </p:nvSpPr>
+        <p:spPr>
+          <a:xfrm xmlns:a="http://schemas.openxmlformats.org/drawingml/2006/main">
+            <a:off x="1352550" y="3562350"/>
+            <a:ext cx="1581150" cy="685800"/>
           </a:xfrm>
           <a:prstGeom xmlns:a="http://schemas.openxmlformats.org/drawingml/2006/main" prst="rect">
             <a:avLst/>
@@ -9267,19 +9267,19 @@
           <a:lstStyle xmlns:a="http://schemas.openxmlformats.org/drawingml/2006/main"/>
           <a:p xmlns:a="http://schemas.openxmlformats.org/drawingml/2006/main">
             <a:pPr algn="ctr">
-              <a:defRPr sz="1275">
+              <a:defRPr sz="1200">
                 <a:solidFill>
                   <a:srgbClr val="4B5563"/>
                 </a:solidFill>
               </a:defRPr>
             </a:pPr>
             <a:r>
-              <a:rPr sz="1275">
+              <a:rPr sz="1200">
                 <a:solidFill>
                   <a:srgbClr val="4B5563"/>
                 </a:solidFill>
               </a:rPr>
-              <a:t>Confluence views with source metadata</a:t>
+              <a:t>страницы Confluence со ссылкой на источник</a:t>
             </a:r>
           </a:p>
         </p:txBody>
@@ -9289,23 +9289,23 @@
           <p:cNvPr id="9" name="">
             <a:extLst xmlns:a="http://schemas.openxmlformats.org/drawingml/2006/main">
               <a:ext uri="{FF2B5EF4-FFF2-40B4-BE49-F238E27FC236}">
-                <a16:creationId xmlns:a16="http://schemas.microsoft.com/office/drawing/2014/main" id="{20832F1D-95C9-49FD-A1EC-FC0F9DED6617}"/>
-              </a:ext>
-            </a:extLst>
-          </p:cNvPr>
-          <p:cNvSpPr>
-            <a:spLocks xmlns:a="http://schemas.openxmlformats.org/drawingml/2006/main" noGrp="1"/>
-          </p:cNvSpPr>
-          <p:nvPr/>
-        </p:nvSpPr>
-        <p:spPr>
-          <a:xfrm xmlns:a="http://schemas.openxmlformats.org/drawingml/2006/main">
-            <a:off x="3762375" y="2857500"/>
-            <a:ext cx="2000250" cy="1428750"/>
+                <a16:creationId xmlns:a16="http://schemas.microsoft.com/office/drawing/2014/main" id="{EE481D5A-EB2A-4031-B72D-9A07F2CBF3B3}"/>
+              </a:ext>
+            </a:extLst>
+          </p:cNvPr>
+          <p:cNvSpPr>
+            <a:spLocks xmlns:a="http://schemas.openxmlformats.org/drawingml/2006/main" noGrp="1"/>
+          </p:cNvSpPr>
+          <p:nvPr/>
+        </p:nvSpPr>
+        <p:spPr>
+          <a:xfrm xmlns:a="http://schemas.openxmlformats.org/drawingml/2006/main">
+            <a:off x="3762375" y="2781300"/>
+            <a:ext cx="2000250" cy="1657350"/>
           </a:xfrm>
           <a:prstGeom xmlns:a="http://schemas.openxmlformats.org/drawingml/2006/main" prst="roundRect">
             <a:avLst>
-              <a:gd name="adj" fmla="val 1333"/>
+              <a:gd name="adj" fmla="val 1149"/>
             </a:avLst>
           </a:prstGeom>
           <a:solidFill xmlns:a="http://schemas.openxmlformats.org/drawingml/2006/main">
@@ -9324,19 +9324,19 @@
           <p:cNvPr id="10" name="">
             <a:extLst xmlns:a="http://schemas.openxmlformats.org/drawingml/2006/main">
               <a:ext uri="{FF2B5EF4-FFF2-40B4-BE49-F238E27FC236}">
-                <a16:creationId xmlns:a16="http://schemas.microsoft.com/office/drawing/2014/main" id="{26B0A8D5-E1AD-42A6-8058-B0B530064BBB}"/>
-              </a:ext>
-            </a:extLst>
-          </p:cNvPr>
-          <p:cNvSpPr>
-            <a:spLocks xmlns:a="http://schemas.openxmlformats.org/drawingml/2006/main" noGrp="1"/>
-          </p:cNvSpPr>
-          <p:nvPr/>
-        </p:nvSpPr>
-        <p:spPr>
-          <a:xfrm xmlns:a="http://schemas.openxmlformats.org/drawingml/2006/main">
-            <a:off x="3971925" y="3143250"/>
-            <a:ext cx="1581150" cy="285750"/>
+                <a16:creationId xmlns:a16="http://schemas.microsoft.com/office/drawing/2014/main" id="{3E0115C0-EE24-4A83-85FF-3FF81F3FB498}"/>
+              </a:ext>
+            </a:extLst>
+          </p:cNvPr>
+          <p:cNvSpPr>
+            <a:spLocks xmlns:a="http://schemas.openxmlformats.org/drawingml/2006/main" noGrp="1"/>
+          </p:cNvSpPr>
+          <p:nvPr/>
+        </p:nvSpPr>
+        <p:spPr>
+          <a:xfrm xmlns:a="http://schemas.openxmlformats.org/drawingml/2006/main">
+            <a:off x="3971925" y="3067050"/>
+            <a:ext cx="1581150" cy="323850"/>
           </a:xfrm>
           <a:prstGeom xmlns:a="http://schemas.openxmlformats.org/drawingml/2006/main" prst="rect">
             <a:avLst/>
@@ -9364,7 +9364,7 @@
                   <a:srgbClr val="111827"/>
                 </a:solidFill>
               </a:rPr>
-              <a:t>Plan</a:t>
+              <a:t>Планы</a:t>
             </a:r>
           </a:p>
         </p:txBody>
@@ -9374,19 +9374,19 @@
           <p:cNvPr id="11" name="">
             <a:extLst xmlns:a="http://schemas.openxmlformats.org/drawingml/2006/main">
               <a:ext uri="{FF2B5EF4-FFF2-40B4-BE49-F238E27FC236}">
-                <a16:creationId xmlns:a16="http://schemas.microsoft.com/office/drawing/2014/main" id="{A132AC3F-75FA-4C00-9A2C-2B837C0D4C93}"/>
-              </a:ext>
-            </a:extLst>
-          </p:cNvPr>
-          <p:cNvSpPr>
-            <a:spLocks xmlns:a="http://schemas.openxmlformats.org/drawingml/2006/main" noGrp="1"/>
-          </p:cNvSpPr>
-          <p:nvPr/>
-        </p:nvSpPr>
-        <p:spPr>
-          <a:xfrm xmlns:a="http://schemas.openxmlformats.org/drawingml/2006/main">
-            <a:off x="3971925" y="3600450"/>
-            <a:ext cx="1581150" cy="514350"/>
+                <a16:creationId xmlns:a16="http://schemas.microsoft.com/office/drawing/2014/main" id="{2DEE3355-BF2E-4EF1-84A1-6E335AF1897E}"/>
+              </a:ext>
+            </a:extLst>
+          </p:cNvPr>
+          <p:cNvSpPr>
+            <a:spLocks xmlns:a="http://schemas.openxmlformats.org/drawingml/2006/main" noGrp="1"/>
+          </p:cNvSpPr>
+          <p:nvPr/>
+        </p:nvSpPr>
+        <p:spPr>
+          <a:xfrm xmlns:a="http://schemas.openxmlformats.org/drawingml/2006/main">
+            <a:off x="3971925" y="3562350"/>
+            <a:ext cx="1581150" cy="685800"/>
           </a:xfrm>
           <a:prstGeom xmlns:a="http://schemas.openxmlformats.org/drawingml/2006/main" prst="rect">
             <a:avLst/>
@@ -9402,19 +9402,19 @@
           <a:lstStyle xmlns:a="http://schemas.openxmlformats.org/drawingml/2006/main"/>
           <a:p xmlns:a="http://schemas.openxmlformats.org/drawingml/2006/main">
             <a:pPr algn="ctr">
-              <a:defRPr sz="1275">
+              <a:defRPr sz="1200">
                 <a:solidFill>
                   <a:srgbClr val="4B5563"/>
                 </a:solidFill>
               </a:defRPr>
             </a:pPr>
             <a:r>
-              <a:rPr sz="1275">
+              <a:rPr sz="1200">
                 <a:solidFill>
                   <a:srgbClr val="4B5563"/>
                 </a:solidFill>
               </a:rPr>
-              <a:t>Jira tasks from accepted change context</a:t>
+              <a:t>задачи Jira из принятого изменения</a:t>
             </a:r>
           </a:p>
         </p:txBody>
@@ -9424,23 +9424,23 @@
           <p:cNvPr id="12" name="">
             <a:extLst xmlns:a="http://schemas.openxmlformats.org/drawingml/2006/main">
               <a:ext uri="{FF2B5EF4-FFF2-40B4-BE49-F238E27FC236}">
-                <a16:creationId xmlns:a16="http://schemas.microsoft.com/office/drawing/2014/main" id="{304288C4-E351-4196-B10B-668B73A13971}"/>
-              </a:ext>
-            </a:extLst>
-          </p:cNvPr>
-          <p:cNvSpPr>
-            <a:spLocks xmlns:a="http://schemas.openxmlformats.org/drawingml/2006/main" noGrp="1"/>
-          </p:cNvSpPr>
-          <p:nvPr/>
-        </p:nvSpPr>
-        <p:spPr>
-          <a:xfrm xmlns:a="http://schemas.openxmlformats.org/drawingml/2006/main">
-            <a:off x="6381750" y="2857500"/>
-            <a:ext cx="2000250" cy="1428750"/>
+                <a16:creationId xmlns:a16="http://schemas.microsoft.com/office/drawing/2014/main" id="{07F02051-CC25-4291-B9F1-C746504B9354}"/>
+              </a:ext>
+            </a:extLst>
+          </p:cNvPr>
+          <p:cNvSpPr>
+            <a:spLocks xmlns:a="http://schemas.openxmlformats.org/drawingml/2006/main" noGrp="1"/>
+          </p:cNvSpPr>
+          <p:nvPr/>
+        </p:nvSpPr>
+        <p:spPr>
+          <a:xfrm xmlns:a="http://schemas.openxmlformats.org/drawingml/2006/main">
+            <a:off x="6381750" y="2781300"/>
+            <a:ext cx="2000250" cy="1657350"/>
           </a:xfrm>
           <a:prstGeom xmlns:a="http://schemas.openxmlformats.org/drawingml/2006/main" prst="roundRect">
             <a:avLst>
-              <a:gd name="adj" fmla="val 1333"/>
+              <a:gd name="adj" fmla="val 1149"/>
             </a:avLst>
           </a:prstGeom>
           <a:solidFill xmlns:a="http://schemas.openxmlformats.org/drawingml/2006/main">
@@ -9459,19 +9459,19 @@
           <p:cNvPr id="13" name="">
             <a:extLst xmlns:a="http://schemas.openxmlformats.org/drawingml/2006/main">
               <a:ext uri="{FF2B5EF4-FFF2-40B4-BE49-F238E27FC236}">
-                <a16:creationId xmlns:a16="http://schemas.microsoft.com/office/drawing/2014/main" id="{DA08B210-DE16-4CC1-9082-1E91DD0A0324}"/>
-              </a:ext>
-            </a:extLst>
-          </p:cNvPr>
-          <p:cNvSpPr>
-            <a:spLocks xmlns:a="http://schemas.openxmlformats.org/drawingml/2006/main" noGrp="1"/>
-          </p:cNvSpPr>
-          <p:nvPr/>
-        </p:nvSpPr>
-        <p:spPr>
-          <a:xfrm xmlns:a="http://schemas.openxmlformats.org/drawingml/2006/main">
-            <a:off x="6591300" y="3143250"/>
-            <a:ext cx="1581150" cy="285750"/>
+                <a16:creationId xmlns:a16="http://schemas.microsoft.com/office/drawing/2014/main" id="{92BA8CF9-AFE5-4B55-9F5B-F0B5B5EED883}"/>
+              </a:ext>
+            </a:extLst>
+          </p:cNvPr>
+          <p:cNvSpPr>
+            <a:spLocks xmlns:a="http://schemas.openxmlformats.org/drawingml/2006/main" noGrp="1"/>
+          </p:cNvSpPr>
+          <p:nvPr/>
+        </p:nvSpPr>
+        <p:spPr>
+          <a:xfrm xmlns:a="http://schemas.openxmlformats.org/drawingml/2006/main">
+            <a:off x="6591300" y="3067050"/>
+            <a:ext cx="1581150" cy="323850"/>
           </a:xfrm>
           <a:prstGeom xmlns:a="http://schemas.openxmlformats.org/drawingml/2006/main" prst="rect">
             <a:avLst/>
@@ -9499,7 +9499,7 @@
                   <a:srgbClr val="111827"/>
                 </a:solidFill>
               </a:rPr>
-              <a:t>Test</a:t>
+              <a:t>Проверка</a:t>
             </a:r>
           </a:p>
         </p:txBody>
@@ -9509,19 +9509,19 @@
           <p:cNvPr id="14" name="">
             <a:extLst xmlns:a="http://schemas.openxmlformats.org/drawingml/2006/main">
               <a:ext uri="{FF2B5EF4-FFF2-40B4-BE49-F238E27FC236}">
-                <a16:creationId xmlns:a16="http://schemas.microsoft.com/office/drawing/2014/main" id="{2E7FCC81-9E58-486D-A742-B28EEA00B27D}"/>
-              </a:ext>
-            </a:extLst>
-          </p:cNvPr>
-          <p:cNvSpPr>
-            <a:spLocks xmlns:a="http://schemas.openxmlformats.org/drawingml/2006/main" noGrp="1"/>
-          </p:cNvSpPr>
-          <p:nvPr/>
-        </p:nvSpPr>
-        <p:spPr>
-          <a:xfrm xmlns:a="http://schemas.openxmlformats.org/drawingml/2006/main">
-            <a:off x="6591300" y="3600450"/>
-            <a:ext cx="1581150" cy="514350"/>
+                <a16:creationId xmlns:a16="http://schemas.microsoft.com/office/drawing/2014/main" id="{34E7E2C5-F134-4809-B776-DDACC713DB46}"/>
+              </a:ext>
+            </a:extLst>
+          </p:cNvPr>
+          <p:cNvSpPr>
+            <a:spLocks xmlns:a="http://schemas.openxmlformats.org/drawingml/2006/main" noGrp="1"/>
+          </p:cNvSpPr>
+          <p:nvPr/>
+        </p:nvSpPr>
+        <p:spPr>
+          <a:xfrm xmlns:a="http://schemas.openxmlformats.org/drawingml/2006/main">
+            <a:off x="6591300" y="3562350"/>
+            <a:ext cx="1581150" cy="685800"/>
           </a:xfrm>
           <a:prstGeom xmlns:a="http://schemas.openxmlformats.org/drawingml/2006/main" prst="rect">
             <a:avLst/>
@@ -9537,19 +9537,19 @@
           <a:lstStyle xmlns:a="http://schemas.openxmlformats.org/drawingml/2006/main"/>
           <a:p xmlns:a="http://schemas.openxmlformats.org/drawingml/2006/main">
             <a:pPr algn="ctr">
-              <a:defRPr sz="1275">
+              <a:defRPr sz="1200">
                 <a:solidFill>
                   <a:srgbClr val="4B5563"/>
                 </a:solidFill>
               </a:defRPr>
             </a:pPr>
             <a:r>
-              <a:rPr sz="1275">
+              <a:rPr sz="1200">
                 <a:solidFill>
                   <a:srgbClr val="4B5563"/>
                 </a:solidFill>
               </a:rPr>
-              <a:t>QA/AT scenarios and skeletons</a:t>
+              <a:t>сценарии тестов и заготовки автотестов</a:t>
             </a:r>
           </a:p>
         </p:txBody>
@@ -9559,23 +9559,23 @@
           <p:cNvPr id="15" name="">
             <a:extLst xmlns:a="http://schemas.openxmlformats.org/drawingml/2006/main">
               <a:ext uri="{FF2B5EF4-FFF2-40B4-BE49-F238E27FC236}">
-                <a16:creationId xmlns:a16="http://schemas.microsoft.com/office/drawing/2014/main" id="{05A055BE-516D-495C-9721-D62D4D2F319E}"/>
-              </a:ext>
-            </a:extLst>
-          </p:cNvPr>
-          <p:cNvSpPr>
-            <a:spLocks xmlns:a="http://schemas.openxmlformats.org/drawingml/2006/main" noGrp="1"/>
-          </p:cNvSpPr>
-          <p:nvPr/>
-        </p:nvSpPr>
-        <p:spPr>
-          <a:xfrm xmlns:a="http://schemas.openxmlformats.org/drawingml/2006/main">
-            <a:off x="9001125" y="2857500"/>
-            <a:ext cx="2000250" cy="1428750"/>
+                <a16:creationId xmlns:a16="http://schemas.microsoft.com/office/drawing/2014/main" id="{38688E97-020E-4F7C-9530-D5C50AA74C29}"/>
+              </a:ext>
+            </a:extLst>
+          </p:cNvPr>
+          <p:cNvSpPr>
+            <a:spLocks xmlns:a="http://schemas.openxmlformats.org/drawingml/2006/main" noGrp="1"/>
+          </p:cNvSpPr>
+          <p:nvPr/>
+        </p:nvSpPr>
+        <p:spPr>
+          <a:xfrm xmlns:a="http://schemas.openxmlformats.org/drawingml/2006/main">
+            <a:off x="9001125" y="2781300"/>
+            <a:ext cx="2000250" cy="1657350"/>
           </a:xfrm>
           <a:prstGeom xmlns:a="http://schemas.openxmlformats.org/drawingml/2006/main" prst="roundRect">
             <a:avLst>
-              <a:gd name="adj" fmla="val 1333"/>
+              <a:gd name="adj" fmla="val 1149"/>
             </a:avLst>
           </a:prstGeom>
           <a:solidFill xmlns:a="http://schemas.openxmlformats.org/drawingml/2006/main">
@@ -9594,19 +9594,19 @@
           <p:cNvPr id="16" name="">
             <a:extLst xmlns:a="http://schemas.openxmlformats.org/drawingml/2006/main">
               <a:ext uri="{FF2B5EF4-FFF2-40B4-BE49-F238E27FC236}">
-                <a16:creationId xmlns:a16="http://schemas.microsoft.com/office/drawing/2014/main" id="{EF553294-8C6E-4E30-9EAD-25EEF9C750F1}"/>
-              </a:ext>
-            </a:extLst>
-          </p:cNvPr>
-          <p:cNvSpPr>
-            <a:spLocks xmlns:a="http://schemas.openxmlformats.org/drawingml/2006/main" noGrp="1"/>
-          </p:cNvSpPr>
-          <p:nvPr/>
-        </p:nvSpPr>
-        <p:spPr>
-          <a:xfrm xmlns:a="http://schemas.openxmlformats.org/drawingml/2006/main">
-            <a:off x="9210675" y="3143250"/>
-            <a:ext cx="1581150" cy="285750"/>
+                <a16:creationId xmlns:a16="http://schemas.microsoft.com/office/drawing/2014/main" id="{174E8C32-34E0-4E93-AF90-FB4E128FA4DE}"/>
+              </a:ext>
+            </a:extLst>
+          </p:cNvPr>
+          <p:cNvSpPr>
+            <a:spLocks xmlns:a="http://schemas.openxmlformats.org/drawingml/2006/main" noGrp="1"/>
+          </p:cNvSpPr>
+          <p:nvPr/>
+        </p:nvSpPr>
+        <p:spPr>
+          <a:xfrm xmlns:a="http://schemas.openxmlformats.org/drawingml/2006/main">
+            <a:off x="9210675" y="3067050"/>
+            <a:ext cx="1581150" cy="323850"/>
           </a:xfrm>
           <a:prstGeom xmlns:a="http://schemas.openxmlformats.org/drawingml/2006/main" prst="rect">
             <a:avLst/>
@@ -9634,7 +9634,7 @@
                   <a:srgbClr val="111827"/>
                 </a:solidFill>
               </a:rPr>
-              <a:t>Orient</a:t>
+              <a:t>Ориентация</a:t>
             </a:r>
           </a:p>
         </p:txBody>
@@ -9644,19 +9644,19 @@
           <p:cNvPr id="17" name="">
             <a:extLst xmlns:a="http://schemas.openxmlformats.org/drawingml/2006/main">
               <a:ext uri="{FF2B5EF4-FFF2-40B4-BE49-F238E27FC236}">
-                <a16:creationId xmlns:a16="http://schemas.microsoft.com/office/drawing/2014/main" id="{B77E3E06-8B91-40F9-B777-4D29340C9F0B}"/>
-              </a:ext>
-            </a:extLst>
-          </p:cNvPr>
-          <p:cNvSpPr>
-            <a:spLocks xmlns:a="http://schemas.openxmlformats.org/drawingml/2006/main" noGrp="1"/>
-          </p:cNvSpPr>
-          <p:nvPr/>
-        </p:nvSpPr>
-        <p:spPr>
-          <a:xfrm xmlns:a="http://schemas.openxmlformats.org/drawingml/2006/main">
-            <a:off x="9210675" y="3600450"/>
-            <a:ext cx="1581150" cy="514350"/>
+                <a16:creationId xmlns:a16="http://schemas.microsoft.com/office/drawing/2014/main" id="{31AC089E-00C7-4254-8246-888D77BBC7BD}"/>
+              </a:ext>
+            </a:extLst>
+          </p:cNvPr>
+          <p:cNvSpPr>
+            <a:spLocks xmlns:a="http://schemas.openxmlformats.org/drawingml/2006/main" noGrp="1"/>
+          </p:cNvSpPr>
+          <p:nvPr/>
+        </p:nvSpPr>
+        <p:spPr>
+          <a:xfrm xmlns:a="http://schemas.openxmlformats.org/drawingml/2006/main">
+            <a:off x="9210675" y="3562350"/>
+            <a:ext cx="1581150" cy="685800"/>
           </a:xfrm>
           <a:prstGeom xmlns:a="http://schemas.openxmlformats.org/drawingml/2006/main" prst="rect">
             <a:avLst/>
@@ -9672,19 +9672,19 @@
           <a:lstStyle xmlns:a="http://schemas.openxmlformats.org/drawingml/2006/main"/>
           <a:p xmlns:a="http://schemas.openxmlformats.org/drawingml/2006/main">
             <a:pPr algn="ctr">
-              <a:defRPr sz="1275">
+              <a:defRPr sz="1200">
                 <a:solidFill>
                   <a:srgbClr val="4B5563"/>
                 </a:solidFill>
               </a:defRPr>
             </a:pPr>
             <a:r>
-              <a:rPr sz="1275">
+              <a:rPr sz="1200">
                 <a:solidFill>
                   <a:srgbClr val="4B5563"/>
                 </a:solidFill>
               </a:rPr>
-              <a:t>role inboxes, project map, sync/upgrade</a:t>
+              <a:t>рабочие списки, карта проекта, сверка и обновления</a:t>
             </a:r>
           </a:p>
         </p:txBody>
@@ -9694,7 +9694,7 @@
           <p:cNvPr id="18" name="">
             <a:extLst xmlns:a="http://schemas.openxmlformats.org/drawingml/2006/main">
               <a:ext uri="{FF2B5EF4-FFF2-40B4-BE49-F238E27FC236}">
-                <a16:creationId xmlns:a16="http://schemas.microsoft.com/office/drawing/2014/main" id="{4944CA79-0599-45A4-B3F2-14B38BAEFEA6}"/>
+                <a16:creationId xmlns:a16="http://schemas.microsoft.com/office/drawing/2014/main" id="{9CB39A67-206D-45D9-BB1E-BC295B4A43F2}"/>
               </a:ext>
             </a:extLst>
           </p:cNvPr>
@@ -9734,7 +9734,7 @@
                   <a:srgbClr val="111827"/>
                 </a:solidFill>
               </a:rPr>
-              <a:t>Не автономный агент. Управляемый процесс, где люди утверждают, CI проверяет, AI ускоряет подготовку.</a:t>
+              <a:t>Это не автономный агент. Это управляемый процесс, где люди утверждают, автоматические проверки контролируют, а ИИ ускоряет подготовку.</a:t>
             </a:r>
           </a:p>
         </p:txBody>
@@ -9742,7 +9742,7 @@
     </p:spTree>
     <p:extLst>
       <p:ext uri="{BB962C8B-B14F-4D97-AF65-F5344CB8AC3E}">
-        <p14:creationId xmlns:p14="http://schemas.microsoft.com/office/powerpoint/2010/main" val="1868119686"/>
+        <p14:creationId xmlns:p14="http://schemas.microsoft.com/office/powerpoint/2010/main" val="1433114854"/>
       </p:ext>
     </p:extLst>
   </p:cSld>

</xml_diff>